<commit_message>
feat: upgrade admin panel with modern slate-indigo dark mode, secure guide tokens, CSV export, and SVG charts
</commit_message>
<xml_diff>
--- a/Samarqand_CrafTour_Investor_Pitch_Deck.pptx
+++ b/Samarqand_CrafTour_Investor_Pitch_Deck.pptx
@@ -3146,59 +3146,64 @@
           </a:p>
         </p:txBody>
       </p:sp>
-      <p:sp>
-        <p:nvSpPr>
-          <p:cNvPr id="3" name="Oval 2"/>
-          <p:cNvSpPr/>
-          <p:nvPr/>
-        </p:nvSpPr>
-        <p:spPr>
-          <a:xfrm>
-            <a:off x="8229600" y="-1828800"/>
-            <a:ext cx="5486400" cy="5486400"/>
-          </a:xfrm>
-          <a:prstGeom prst="ellipse">
-            <a:avLst/>
-          </a:prstGeom>
-          <a:solidFill>
-            <a:srgbClr val="0C2340"/>
-          </a:solidFill>
-          <a:ln>
-            <a:noFill/>
-          </a:ln>
-        </p:spPr>
-        <p:style>
-          <a:lnRef idx="1">
-            <a:schemeClr val="accent1"/>
-          </a:lnRef>
-          <a:fillRef idx="3">
-            <a:schemeClr val="accent1"/>
-          </a:fillRef>
-          <a:effectRef idx="2">
-            <a:schemeClr val="accent1"/>
-          </a:effectRef>
-          <a:fontRef idx="minor">
-            <a:schemeClr val="lt1"/>
-          </a:fontRef>
-        </p:style>
-        <p:txBody>
-          <a:bodyPr rtlCol="0" anchor="ctr"/>
-          <a:lstStyle/>
-          <a:p>
-            <a:pPr algn="ctr"/>
-          </a:p>
-        </p:txBody>
-      </p:sp>
-      <p:sp>
-        <p:nvSpPr>
-          <p:cNvPr id="4" name="TextBox 3"/>
+      <p:pic>
+        <p:nvPicPr>
+          <p:cNvPr id="3" name="Picture 2" descr="uzbek_mandala.jpg"/>
+          <p:cNvPicPr>
+            <a:picLocks noChangeAspect="1"/>
+          </p:cNvPicPr>
+          <p:nvPr/>
+        </p:nvPicPr>
+        <p:blipFill>
+          <a:blip r:embed="rId2"/>
+          <a:stretch>
+            <a:fillRect/>
+          </a:stretch>
+        </p:blipFill>
+        <p:spPr>
+          <a:xfrm>
+            <a:off x="6858000" y="1143000"/>
+            <a:ext cx="4572000" cy="4572000"/>
+          </a:xfrm>
+          <a:prstGeom prst="rect">
+            <a:avLst/>
+          </a:prstGeom>
+        </p:spPr>
+      </p:pic>
+      <p:pic>
+        <p:nvPicPr>
+          <p:cNvPr id="4" name="Picture 3" descr="logo.jpg"/>
+          <p:cNvPicPr>
+            <a:picLocks noChangeAspect="1"/>
+          </p:cNvPicPr>
+          <p:nvPr/>
+        </p:nvPicPr>
+        <p:blipFill>
+          <a:blip r:embed="rId3"/>
+          <a:stretch>
+            <a:fillRect/>
+          </a:stretch>
+        </p:blipFill>
+        <p:spPr>
+          <a:xfrm>
+            <a:off x="914400" y="731520"/>
+            <a:ext cx="1097280" cy="1097280"/>
+          </a:xfrm>
+          <a:prstGeom prst="rect">
+            <a:avLst/>
+          </a:prstGeom>
+        </p:spPr>
+      </p:pic>
+      <p:sp>
+        <p:nvSpPr>
+          <p:cNvPr id="5" name="TextBox 4"/>
           <p:cNvSpPr txBox="1"/>
           <p:nvPr/>
         </p:nvSpPr>
         <p:spPr>
           <a:xfrm>
-            <a:off x="914400" y="2011680"/>
-            <a:ext cx="10362895" cy="1828800"/>
+            <a:off x="914400" y="2103120"/>
+            <a:ext cx="5669280" cy="3657600"/>
           </a:xfrm>
           <a:prstGeom prst="rect">
             <a:avLst/>
@@ -3206,13 +3211,13 @@
           <a:noFill/>
         </p:spPr>
         <p:txBody>
-          <a:bodyPr wrap="square">
+          <a:bodyPr wrap="square" lIns="0" rIns="0" tIns="0" bIns="0">
             <a:spAutoFit/>
           </a:bodyPr>
           <a:lstStyle/>
           <a:p>
             <a:pPr algn="l">
-              <a:defRPr sz="5400" b="1">
+              <a:defRPr sz="4600" b="1">
                 <a:solidFill>
                   <a:srgbClr val="D4AF37"/>
                 </a:solidFill>
@@ -3226,9 +3231,9 @@
           <a:p>
             <a:pPr algn="l">
               <a:spcBef>
-                <a:spcPts val="1000"/>
+                <a:spcPts val="800"/>
               </a:spcBef>
-              <a:defRPr sz="2200">
+              <a:defRPr sz="1800">
                 <a:solidFill>
                   <a:srgbClr val="FFFFFF"/>
                 </a:solidFill>
@@ -3242,9 +3247,9 @@
           <a:p>
             <a:pPr algn="l">
               <a:spcBef>
-                <a:spcPts val="2000"/>
+                <a:spcPts val="1500"/>
               </a:spcBef>
-              <a:defRPr sz="1400">
+              <a:defRPr sz="1300">
                 <a:solidFill>
                   <a:srgbClr val="94A3B8"/>
                 </a:solidFill>
@@ -3259,7 +3264,7 @@
       </p:sp>
       <p:sp>
         <p:nvSpPr>
-          <p:cNvPr id="5" name="TextBox 4"/>
+          <p:cNvPr id="6" name="TextBox 5"/>
           <p:cNvSpPr txBox="1"/>
           <p:nvPr/>
         </p:nvSpPr>
@@ -3319,16 +3324,40 @@
         <p:nvPr/>
       </p:nvGrpSpPr>
       <p:grpSpPr/>
-      <p:sp>
-        <p:nvSpPr>
-          <p:cNvPr id="2" name="Rectangle 1"/>
+      <p:pic>
+        <p:nvPicPr>
+          <p:cNvPr id="2" name="Picture 1" descr="uzbek_mandala.jpg"/>
+          <p:cNvPicPr>
+            <a:picLocks noChangeAspect="1"/>
+          </p:cNvPicPr>
+          <p:nvPr/>
+        </p:nvPicPr>
+        <p:blipFill>
+          <a:blip r:embed="rId2"/>
+          <a:stretch>
+            <a:fillRect/>
+          </a:stretch>
+        </p:blipFill>
+        <p:spPr>
+          <a:xfrm>
+            <a:off x="10058400" y="-914400"/>
+            <a:ext cx="3200400" cy="3200400"/>
+          </a:xfrm>
+          <a:prstGeom prst="rect">
+            <a:avLst/>
+          </a:prstGeom>
+        </p:spPr>
+      </p:pic>
+      <p:sp>
+        <p:nvSpPr>
+          <p:cNvPr id="3" name="Rectangle 2"/>
           <p:cNvSpPr/>
           <p:nvPr/>
         </p:nvSpPr>
         <p:spPr>
           <a:xfrm>
             <a:off x="0" y="0"/>
-            <a:ext cx="12191695" cy="137160"/>
+            <a:ext cx="12191695" cy="109728"/>
           </a:xfrm>
           <a:prstGeom prst="rect">
             <a:avLst/>
@@ -3364,14 +3393,14 @@
       </p:sp>
       <p:sp>
         <p:nvSpPr>
-          <p:cNvPr id="3" name="TextBox 2"/>
+          <p:cNvPr id="4" name="TextBox 3"/>
           <p:cNvSpPr txBox="1"/>
           <p:nvPr/>
         </p:nvSpPr>
         <p:spPr>
           <a:xfrm>
-            <a:off x="457200" y="6492240"/>
-            <a:ext cx="11277295" cy="274320"/>
+            <a:off x="731520" y="6492240"/>
+            <a:ext cx="9601200" cy="274320"/>
           </a:xfrm>
           <a:prstGeom prst="rect">
             <a:avLst/>
@@ -3398,9 +3427,33 @@
           </a:p>
         </p:txBody>
       </p:sp>
-      <p:sp>
-        <p:nvSpPr>
-          <p:cNvPr id="4" name="TextBox 3"/>
+      <p:pic>
+        <p:nvPicPr>
+          <p:cNvPr id="5" name="Picture 4" descr="logo.jpg"/>
+          <p:cNvPicPr>
+            <a:picLocks noChangeAspect="1"/>
+          </p:cNvPicPr>
+          <p:nvPr/>
+        </p:nvPicPr>
+        <p:blipFill>
+          <a:blip r:embed="rId3"/>
+          <a:stretch>
+            <a:fillRect/>
+          </a:stretch>
+        </p:blipFill>
+        <p:spPr>
+          <a:xfrm>
+            <a:off x="11430000" y="6309360"/>
+            <a:ext cx="457200" cy="457200"/>
+          </a:xfrm>
+          <a:prstGeom prst="rect">
+            <a:avLst/>
+          </a:prstGeom>
+        </p:spPr>
+      </p:pic>
+      <p:sp>
+        <p:nvSpPr>
+          <p:cNvPr id="6" name="TextBox 5"/>
           <p:cNvSpPr txBox="1"/>
           <p:nvPr/>
         </p:nvSpPr>
@@ -3421,7 +3474,7 @@
           <a:lstStyle/>
           <a:p>
             <a:pPr>
-              <a:defRPr sz="3600" b="1">
+              <a:defRPr sz="3400" b="1">
                 <a:solidFill>
                   <a:srgbClr val="D4AF37"/>
                 </a:solidFill>
@@ -3436,7 +3489,7 @@
       </p:sp>
       <p:sp>
         <p:nvSpPr>
-          <p:cNvPr id="5" name="Rounded Rectangle 4"/>
+          <p:cNvPr id="7" name="Rounded Rectangle 6"/>
           <p:cNvSpPr/>
           <p:nvPr/>
         </p:nvSpPr>
@@ -3481,7 +3534,7 @@
       </p:sp>
       <p:sp>
         <p:nvSpPr>
-          <p:cNvPr id="6" name="TextBox 5"/>
+          <p:cNvPr id="8" name="TextBox 7"/>
           <p:cNvSpPr txBox="1"/>
           <p:nvPr/>
         </p:nvSpPr>
@@ -3565,7 +3618,7 @@
       </p:sp>
       <p:sp>
         <p:nvSpPr>
-          <p:cNvPr id="7" name="Rounded Rectangle 6"/>
+          <p:cNvPr id="9" name="Rounded Rectangle 8"/>
           <p:cNvSpPr/>
           <p:nvPr/>
         </p:nvSpPr>
@@ -3610,7 +3663,7 @@
       </p:sp>
       <p:sp>
         <p:nvSpPr>
-          <p:cNvPr id="8" name="TextBox 7"/>
+          <p:cNvPr id="10" name="TextBox 9"/>
           <p:cNvSpPr txBox="1"/>
           <p:nvPr/>
         </p:nvSpPr>
@@ -3694,7 +3747,7 @@
       </p:sp>
       <p:sp>
         <p:nvSpPr>
-          <p:cNvPr id="9" name="Rounded Rectangle 8"/>
+          <p:cNvPr id="11" name="Rounded Rectangle 10"/>
           <p:cNvSpPr/>
           <p:nvPr/>
         </p:nvSpPr>
@@ -3739,7 +3792,7 @@
       </p:sp>
       <p:sp>
         <p:nvSpPr>
-          <p:cNvPr id="10" name="TextBox 9"/>
+          <p:cNvPr id="12" name="TextBox 11"/>
           <p:cNvSpPr txBox="1"/>
           <p:nvPr/>
         </p:nvSpPr>
@@ -3847,16 +3900,40 @@
         <p:nvPr/>
       </p:nvGrpSpPr>
       <p:grpSpPr/>
-      <p:sp>
-        <p:nvSpPr>
-          <p:cNvPr id="2" name="Rectangle 1"/>
+      <p:pic>
+        <p:nvPicPr>
+          <p:cNvPr id="2" name="Picture 1" descr="uzbek_mandala.jpg"/>
+          <p:cNvPicPr>
+            <a:picLocks noChangeAspect="1"/>
+          </p:cNvPicPr>
+          <p:nvPr/>
+        </p:nvPicPr>
+        <p:blipFill>
+          <a:blip r:embed="rId2"/>
+          <a:stretch>
+            <a:fillRect/>
+          </a:stretch>
+        </p:blipFill>
+        <p:spPr>
+          <a:xfrm>
+            <a:off x="10058400" y="-914400"/>
+            <a:ext cx="3200400" cy="3200400"/>
+          </a:xfrm>
+          <a:prstGeom prst="rect">
+            <a:avLst/>
+          </a:prstGeom>
+        </p:spPr>
+      </p:pic>
+      <p:sp>
+        <p:nvSpPr>
+          <p:cNvPr id="3" name="Rectangle 2"/>
           <p:cNvSpPr/>
           <p:nvPr/>
         </p:nvSpPr>
         <p:spPr>
           <a:xfrm>
             <a:off x="0" y="0"/>
-            <a:ext cx="12191695" cy="137160"/>
+            <a:ext cx="12191695" cy="109728"/>
           </a:xfrm>
           <a:prstGeom prst="rect">
             <a:avLst/>
@@ -3892,14 +3969,14 @@
       </p:sp>
       <p:sp>
         <p:nvSpPr>
-          <p:cNvPr id="3" name="TextBox 2"/>
+          <p:cNvPr id="4" name="TextBox 3"/>
           <p:cNvSpPr txBox="1"/>
           <p:nvPr/>
         </p:nvSpPr>
         <p:spPr>
           <a:xfrm>
-            <a:off x="457200" y="6492240"/>
-            <a:ext cx="11277295" cy="274320"/>
+            <a:off x="731520" y="6492240"/>
+            <a:ext cx="9601200" cy="274320"/>
           </a:xfrm>
           <a:prstGeom prst="rect">
             <a:avLst/>
@@ -3926,9 +4003,33 @@
           </a:p>
         </p:txBody>
       </p:sp>
-      <p:sp>
-        <p:nvSpPr>
-          <p:cNvPr id="4" name="TextBox 3"/>
+      <p:pic>
+        <p:nvPicPr>
+          <p:cNvPr id="5" name="Picture 4" descr="logo.jpg"/>
+          <p:cNvPicPr>
+            <a:picLocks noChangeAspect="1"/>
+          </p:cNvPicPr>
+          <p:nvPr/>
+        </p:nvPicPr>
+        <p:blipFill>
+          <a:blip r:embed="rId3"/>
+          <a:stretch>
+            <a:fillRect/>
+          </a:stretch>
+        </p:blipFill>
+        <p:spPr>
+          <a:xfrm>
+            <a:off x="11430000" y="6309360"/>
+            <a:ext cx="457200" cy="457200"/>
+          </a:xfrm>
+          <a:prstGeom prst="rect">
+            <a:avLst/>
+          </a:prstGeom>
+        </p:spPr>
+      </p:pic>
+      <p:sp>
+        <p:nvSpPr>
+          <p:cNvPr id="6" name="TextBox 5"/>
           <p:cNvSpPr txBox="1"/>
           <p:nvPr/>
         </p:nvSpPr>
@@ -3949,7 +4050,7 @@
           <a:lstStyle/>
           <a:p>
             <a:pPr>
-              <a:defRPr sz="3600" b="1">
+              <a:defRPr sz="3400" b="1">
                 <a:solidFill>
                   <a:srgbClr val="D4AF37"/>
                 </a:solidFill>
@@ -3964,7 +4065,7 @@
       </p:sp>
       <p:sp>
         <p:nvSpPr>
-          <p:cNvPr id="5" name="TextBox 4"/>
+          <p:cNvPr id="7" name="TextBox 6"/>
           <p:cNvSpPr txBox="1"/>
           <p:nvPr/>
         </p:nvSpPr>
@@ -4032,7 +4133,7 @@
       </p:sp>
       <p:sp>
         <p:nvSpPr>
-          <p:cNvPr id="6" name="Rounded Rectangle 5"/>
+          <p:cNvPr id="8" name="Rounded Rectangle 7"/>
           <p:cNvSpPr/>
           <p:nvPr/>
         </p:nvSpPr>
@@ -4077,7 +4178,7 @@
       </p:sp>
       <p:sp>
         <p:nvSpPr>
-          <p:cNvPr id="7" name="TextBox 6"/>
+          <p:cNvPr id="9" name="TextBox 8"/>
           <p:cNvSpPr txBox="1"/>
           <p:nvPr/>
         </p:nvSpPr>
@@ -4129,7 +4230,7 @@
       </p:sp>
       <p:sp>
         <p:nvSpPr>
-          <p:cNvPr id="8" name="Rounded Rectangle 7"/>
+          <p:cNvPr id="10" name="Rounded Rectangle 9"/>
           <p:cNvSpPr/>
           <p:nvPr/>
         </p:nvSpPr>
@@ -4174,7 +4275,7 @@
       </p:sp>
       <p:sp>
         <p:nvSpPr>
-          <p:cNvPr id="9" name="TextBox 8"/>
+          <p:cNvPr id="11" name="TextBox 10"/>
           <p:cNvSpPr txBox="1"/>
           <p:nvPr/>
         </p:nvSpPr>
@@ -4226,7 +4327,7 @@
       </p:sp>
       <p:sp>
         <p:nvSpPr>
-          <p:cNvPr id="10" name="Rounded Rectangle 9"/>
+          <p:cNvPr id="12" name="Rounded Rectangle 11"/>
           <p:cNvSpPr/>
           <p:nvPr/>
         </p:nvSpPr>
@@ -4271,7 +4372,7 @@
       </p:sp>
       <p:sp>
         <p:nvSpPr>
-          <p:cNvPr id="11" name="TextBox 10"/>
+          <p:cNvPr id="13" name="TextBox 12"/>
           <p:cNvSpPr txBox="1"/>
           <p:nvPr/>
         </p:nvSpPr>
@@ -4347,16 +4448,40 @@
         <p:nvPr/>
       </p:nvGrpSpPr>
       <p:grpSpPr/>
-      <p:sp>
-        <p:nvSpPr>
-          <p:cNvPr id="2" name="Rectangle 1"/>
+      <p:pic>
+        <p:nvPicPr>
+          <p:cNvPr id="2" name="Picture 1" descr="uzbek_mandala.jpg"/>
+          <p:cNvPicPr>
+            <a:picLocks noChangeAspect="1"/>
+          </p:cNvPicPr>
+          <p:nvPr/>
+        </p:nvPicPr>
+        <p:blipFill>
+          <a:blip r:embed="rId2"/>
+          <a:stretch>
+            <a:fillRect/>
+          </a:stretch>
+        </p:blipFill>
+        <p:spPr>
+          <a:xfrm>
+            <a:off x="10058400" y="-914400"/>
+            <a:ext cx="3200400" cy="3200400"/>
+          </a:xfrm>
+          <a:prstGeom prst="rect">
+            <a:avLst/>
+          </a:prstGeom>
+        </p:spPr>
+      </p:pic>
+      <p:sp>
+        <p:nvSpPr>
+          <p:cNvPr id="3" name="Rectangle 2"/>
           <p:cNvSpPr/>
           <p:nvPr/>
         </p:nvSpPr>
         <p:spPr>
           <a:xfrm>
             <a:off x="0" y="0"/>
-            <a:ext cx="12191695" cy="137160"/>
+            <a:ext cx="12191695" cy="109728"/>
           </a:xfrm>
           <a:prstGeom prst="rect">
             <a:avLst/>
@@ -4392,14 +4517,14 @@
       </p:sp>
       <p:sp>
         <p:nvSpPr>
-          <p:cNvPr id="3" name="TextBox 2"/>
+          <p:cNvPr id="4" name="TextBox 3"/>
           <p:cNvSpPr txBox="1"/>
           <p:nvPr/>
         </p:nvSpPr>
         <p:spPr>
           <a:xfrm>
-            <a:off x="457200" y="6492240"/>
-            <a:ext cx="11277295" cy="274320"/>
+            <a:off x="731520" y="6492240"/>
+            <a:ext cx="9601200" cy="274320"/>
           </a:xfrm>
           <a:prstGeom prst="rect">
             <a:avLst/>
@@ -4426,9 +4551,33 @@
           </a:p>
         </p:txBody>
       </p:sp>
-      <p:sp>
-        <p:nvSpPr>
-          <p:cNvPr id="4" name="TextBox 3"/>
+      <p:pic>
+        <p:nvPicPr>
+          <p:cNvPr id="5" name="Picture 4" descr="logo.jpg"/>
+          <p:cNvPicPr>
+            <a:picLocks noChangeAspect="1"/>
+          </p:cNvPicPr>
+          <p:nvPr/>
+        </p:nvPicPr>
+        <p:blipFill>
+          <a:blip r:embed="rId3"/>
+          <a:stretch>
+            <a:fillRect/>
+          </a:stretch>
+        </p:blipFill>
+        <p:spPr>
+          <a:xfrm>
+            <a:off x="11430000" y="6309360"/>
+            <a:ext cx="457200" cy="457200"/>
+          </a:xfrm>
+          <a:prstGeom prst="rect">
+            <a:avLst/>
+          </a:prstGeom>
+        </p:spPr>
+      </p:pic>
+      <p:sp>
+        <p:nvSpPr>
+          <p:cNvPr id="6" name="TextBox 5"/>
           <p:cNvSpPr txBox="1"/>
           <p:nvPr/>
         </p:nvSpPr>
@@ -4449,7 +4598,7 @@
           <a:lstStyle/>
           <a:p>
             <a:pPr>
-              <a:defRPr sz="3600" b="1">
+              <a:defRPr sz="3400" b="1">
                 <a:solidFill>
                   <a:srgbClr val="D4AF37"/>
                 </a:solidFill>
@@ -4464,7 +4613,7 @@
       </p:sp>
       <p:sp>
         <p:nvSpPr>
-          <p:cNvPr id="5" name="Rounded Rectangle 4"/>
+          <p:cNvPr id="7" name="Rounded Rectangle 6"/>
           <p:cNvSpPr/>
           <p:nvPr/>
         </p:nvSpPr>
@@ -4509,7 +4658,7 @@
       </p:sp>
       <p:sp>
         <p:nvSpPr>
-          <p:cNvPr id="6" name="TextBox 5"/>
+          <p:cNvPr id="8" name="TextBox 7"/>
           <p:cNvSpPr txBox="1"/>
           <p:nvPr/>
         </p:nvSpPr>
@@ -4588,7 +4737,7 @@
       </p:sp>
       <p:sp>
         <p:nvSpPr>
-          <p:cNvPr id="7" name="Rounded Rectangle 6"/>
+          <p:cNvPr id="9" name="Rounded Rectangle 8"/>
           <p:cNvSpPr/>
           <p:nvPr/>
         </p:nvSpPr>
@@ -4633,7 +4782,7 @@
       </p:sp>
       <p:sp>
         <p:nvSpPr>
-          <p:cNvPr id="8" name="TextBox 7"/>
+          <p:cNvPr id="10" name="TextBox 9"/>
           <p:cNvSpPr txBox="1"/>
           <p:nvPr/>
         </p:nvSpPr>
@@ -4712,7 +4861,7 @@
       </p:sp>
       <p:sp>
         <p:nvSpPr>
-          <p:cNvPr id="9" name="Rounded Rectangle 8"/>
+          <p:cNvPr id="11" name="Rounded Rectangle 10"/>
           <p:cNvSpPr/>
           <p:nvPr/>
         </p:nvSpPr>
@@ -4757,7 +4906,7 @@
       </p:sp>
       <p:sp>
         <p:nvSpPr>
-          <p:cNvPr id="10" name="TextBox 9"/>
+          <p:cNvPr id="12" name="TextBox 11"/>
           <p:cNvSpPr txBox="1"/>
           <p:nvPr/>
         </p:nvSpPr>
@@ -4836,7 +4985,7 @@
       </p:sp>
       <p:sp>
         <p:nvSpPr>
-          <p:cNvPr id="11" name="Rounded Rectangle 10"/>
+          <p:cNvPr id="13" name="Rounded Rectangle 12"/>
           <p:cNvSpPr/>
           <p:nvPr/>
         </p:nvSpPr>
@@ -4881,7 +5030,7 @@
       </p:sp>
       <p:sp>
         <p:nvSpPr>
-          <p:cNvPr id="12" name="TextBox 11"/>
+          <p:cNvPr id="14" name="TextBox 13"/>
           <p:cNvSpPr txBox="1"/>
           <p:nvPr/>
         </p:nvSpPr>
@@ -4984,16 +5133,40 @@
         <p:nvPr/>
       </p:nvGrpSpPr>
       <p:grpSpPr/>
-      <p:sp>
-        <p:nvSpPr>
-          <p:cNvPr id="2" name="Rectangle 1"/>
+      <p:pic>
+        <p:nvPicPr>
+          <p:cNvPr id="2" name="Picture 1" descr="uzbek_mandala.jpg"/>
+          <p:cNvPicPr>
+            <a:picLocks noChangeAspect="1"/>
+          </p:cNvPicPr>
+          <p:nvPr/>
+        </p:nvPicPr>
+        <p:blipFill>
+          <a:blip r:embed="rId2"/>
+          <a:stretch>
+            <a:fillRect/>
+          </a:stretch>
+        </p:blipFill>
+        <p:spPr>
+          <a:xfrm>
+            <a:off x="10058400" y="-914400"/>
+            <a:ext cx="3200400" cy="3200400"/>
+          </a:xfrm>
+          <a:prstGeom prst="rect">
+            <a:avLst/>
+          </a:prstGeom>
+        </p:spPr>
+      </p:pic>
+      <p:sp>
+        <p:nvSpPr>
+          <p:cNvPr id="3" name="Rectangle 2"/>
           <p:cNvSpPr/>
           <p:nvPr/>
         </p:nvSpPr>
         <p:spPr>
           <a:xfrm>
             <a:off x="0" y="0"/>
-            <a:ext cx="12191695" cy="137160"/>
+            <a:ext cx="12191695" cy="109728"/>
           </a:xfrm>
           <a:prstGeom prst="rect">
             <a:avLst/>
@@ -5029,14 +5202,14 @@
       </p:sp>
       <p:sp>
         <p:nvSpPr>
-          <p:cNvPr id="3" name="TextBox 2"/>
+          <p:cNvPr id="4" name="TextBox 3"/>
           <p:cNvSpPr txBox="1"/>
           <p:nvPr/>
         </p:nvSpPr>
         <p:spPr>
           <a:xfrm>
-            <a:off x="457200" y="6492240"/>
-            <a:ext cx="11277295" cy="274320"/>
+            <a:off x="731520" y="6492240"/>
+            <a:ext cx="9601200" cy="274320"/>
           </a:xfrm>
           <a:prstGeom prst="rect">
             <a:avLst/>
@@ -5063,9 +5236,33 @@
           </a:p>
         </p:txBody>
       </p:sp>
-      <p:sp>
-        <p:nvSpPr>
-          <p:cNvPr id="4" name="TextBox 3"/>
+      <p:pic>
+        <p:nvPicPr>
+          <p:cNvPr id="5" name="Picture 4" descr="logo.jpg"/>
+          <p:cNvPicPr>
+            <a:picLocks noChangeAspect="1"/>
+          </p:cNvPicPr>
+          <p:nvPr/>
+        </p:nvPicPr>
+        <p:blipFill>
+          <a:blip r:embed="rId3"/>
+          <a:stretch>
+            <a:fillRect/>
+          </a:stretch>
+        </p:blipFill>
+        <p:spPr>
+          <a:xfrm>
+            <a:off x="11430000" y="6309360"/>
+            <a:ext cx="457200" cy="457200"/>
+          </a:xfrm>
+          <a:prstGeom prst="rect">
+            <a:avLst/>
+          </a:prstGeom>
+        </p:spPr>
+      </p:pic>
+      <p:sp>
+        <p:nvSpPr>
+          <p:cNvPr id="6" name="TextBox 5"/>
           <p:cNvSpPr txBox="1"/>
           <p:nvPr/>
         </p:nvSpPr>
@@ -5086,7 +5283,7 @@
           <a:lstStyle/>
           <a:p>
             <a:pPr>
-              <a:defRPr sz="3600" b="1">
+              <a:defRPr sz="3400" b="1">
                 <a:solidFill>
                   <a:srgbClr val="D4AF37"/>
                 </a:solidFill>
@@ -5101,7 +5298,7 @@
       </p:sp>
       <p:sp>
         <p:nvSpPr>
-          <p:cNvPr id="5" name="Rounded Rectangle 4"/>
+          <p:cNvPr id="7" name="Rounded Rectangle 6"/>
           <p:cNvSpPr/>
           <p:nvPr/>
         </p:nvSpPr>
@@ -5146,7 +5343,7 @@
       </p:sp>
       <p:sp>
         <p:nvSpPr>
-          <p:cNvPr id="6" name="TextBox 5"/>
+          <p:cNvPr id="8" name="TextBox 7"/>
           <p:cNvSpPr txBox="1"/>
           <p:nvPr/>
         </p:nvSpPr>
@@ -5198,7 +5395,7 @@
       </p:sp>
       <p:sp>
         <p:nvSpPr>
-          <p:cNvPr id="7" name="Rounded Rectangle 6"/>
+          <p:cNvPr id="9" name="Rounded Rectangle 8"/>
           <p:cNvSpPr/>
           <p:nvPr/>
         </p:nvSpPr>
@@ -5243,7 +5440,7 @@
       </p:sp>
       <p:sp>
         <p:nvSpPr>
-          <p:cNvPr id="8" name="TextBox 7"/>
+          <p:cNvPr id="10" name="TextBox 9"/>
           <p:cNvSpPr txBox="1"/>
           <p:nvPr/>
         </p:nvSpPr>
@@ -5295,7 +5492,7 @@
       </p:sp>
       <p:sp>
         <p:nvSpPr>
-          <p:cNvPr id="9" name="Rounded Rectangle 8"/>
+          <p:cNvPr id="11" name="Rounded Rectangle 10"/>
           <p:cNvSpPr/>
           <p:nvPr/>
         </p:nvSpPr>
@@ -5340,7 +5537,7 @@
       </p:sp>
       <p:sp>
         <p:nvSpPr>
-          <p:cNvPr id="10" name="TextBox 9"/>
+          <p:cNvPr id="12" name="TextBox 11"/>
           <p:cNvSpPr txBox="1"/>
           <p:nvPr/>
         </p:nvSpPr>
@@ -5392,7 +5589,7 @@
       </p:sp>
       <p:sp>
         <p:nvSpPr>
-          <p:cNvPr id="11" name="Rounded Rectangle 10"/>
+          <p:cNvPr id="13" name="Rounded Rectangle 12"/>
           <p:cNvSpPr/>
           <p:nvPr/>
         </p:nvSpPr>
@@ -5437,7 +5634,7 @@
       </p:sp>
       <p:sp>
         <p:nvSpPr>
-          <p:cNvPr id="12" name="TextBox 11"/>
+          <p:cNvPr id="14" name="TextBox 13"/>
           <p:cNvSpPr txBox="1"/>
           <p:nvPr/>
         </p:nvSpPr>
@@ -5513,16 +5710,40 @@
         <p:nvPr/>
       </p:nvGrpSpPr>
       <p:grpSpPr/>
-      <p:sp>
-        <p:nvSpPr>
-          <p:cNvPr id="2" name="Rectangle 1"/>
+      <p:pic>
+        <p:nvPicPr>
+          <p:cNvPr id="2" name="Picture 1" descr="uzbek_mandala.jpg"/>
+          <p:cNvPicPr>
+            <a:picLocks noChangeAspect="1"/>
+          </p:cNvPicPr>
+          <p:nvPr/>
+        </p:nvPicPr>
+        <p:blipFill>
+          <a:blip r:embed="rId2"/>
+          <a:stretch>
+            <a:fillRect/>
+          </a:stretch>
+        </p:blipFill>
+        <p:spPr>
+          <a:xfrm>
+            <a:off x="10058400" y="-914400"/>
+            <a:ext cx="3200400" cy="3200400"/>
+          </a:xfrm>
+          <a:prstGeom prst="rect">
+            <a:avLst/>
+          </a:prstGeom>
+        </p:spPr>
+      </p:pic>
+      <p:sp>
+        <p:nvSpPr>
+          <p:cNvPr id="3" name="Rectangle 2"/>
           <p:cNvSpPr/>
           <p:nvPr/>
         </p:nvSpPr>
         <p:spPr>
           <a:xfrm>
             <a:off x="0" y="0"/>
-            <a:ext cx="12191695" cy="137160"/>
+            <a:ext cx="12191695" cy="109728"/>
           </a:xfrm>
           <a:prstGeom prst="rect">
             <a:avLst/>
@@ -5558,14 +5779,14 @@
       </p:sp>
       <p:sp>
         <p:nvSpPr>
-          <p:cNvPr id="3" name="TextBox 2"/>
+          <p:cNvPr id="4" name="TextBox 3"/>
           <p:cNvSpPr txBox="1"/>
           <p:nvPr/>
         </p:nvSpPr>
         <p:spPr>
           <a:xfrm>
-            <a:off x="457200" y="6492240"/>
-            <a:ext cx="11277295" cy="274320"/>
+            <a:off x="731520" y="6492240"/>
+            <a:ext cx="9601200" cy="274320"/>
           </a:xfrm>
           <a:prstGeom prst="rect">
             <a:avLst/>
@@ -5592,9 +5813,33 @@
           </a:p>
         </p:txBody>
       </p:sp>
-      <p:sp>
-        <p:nvSpPr>
-          <p:cNvPr id="4" name="TextBox 3"/>
+      <p:pic>
+        <p:nvPicPr>
+          <p:cNvPr id="5" name="Picture 4" descr="logo.jpg"/>
+          <p:cNvPicPr>
+            <a:picLocks noChangeAspect="1"/>
+          </p:cNvPicPr>
+          <p:nvPr/>
+        </p:nvPicPr>
+        <p:blipFill>
+          <a:blip r:embed="rId3"/>
+          <a:stretch>
+            <a:fillRect/>
+          </a:stretch>
+        </p:blipFill>
+        <p:spPr>
+          <a:xfrm>
+            <a:off x="11430000" y="6309360"/>
+            <a:ext cx="457200" cy="457200"/>
+          </a:xfrm>
+          <a:prstGeom prst="rect">
+            <a:avLst/>
+          </a:prstGeom>
+        </p:spPr>
+      </p:pic>
+      <p:sp>
+        <p:nvSpPr>
+          <p:cNvPr id="6" name="TextBox 5"/>
           <p:cNvSpPr txBox="1"/>
           <p:nvPr/>
         </p:nvSpPr>
@@ -5615,7 +5860,7 @@
           <a:lstStyle/>
           <a:p>
             <a:pPr>
-              <a:defRPr sz="3600" b="1">
+              <a:defRPr sz="3400" b="1">
                 <a:solidFill>
                   <a:srgbClr val="D4AF37"/>
                 </a:solidFill>
@@ -5630,7 +5875,7 @@
       </p:sp>
       <p:sp>
         <p:nvSpPr>
-          <p:cNvPr id="5" name="Rounded Rectangle 4"/>
+          <p:cNvPr id="7" name="Rounded Rectangle 6"/>
           <p:cNvSpPr/>
           <p:nvPr/>
         </p:nvSpPr>
@@ -5675,7 +5920,7 @@
       </p:sp>
       <p:sp>
         <p:nvSpPr>
-          <p:cNvPr id="6" name="TextBox 5"/>
+          <p:cNvPr id="8" name="TextBox 7"/>
           <p:cNvSpPr txBox="1"/>
           <p:nvPr/>
         </p:nvSpPr>
@@ -5778,7 +6023,7 @@
       </p:sp>
       <p:sp>
         <p:nvSpPr>
-          <p:cNvPr id="7" name="Rounded Rectangle 6"/>
+          <p:cNvPr id="9" name="Rounded Rectangle 8"/>
           <p:cNvSpPr/>
           <p:nvPr/>
         </p:nvSpPr>
@@ -5823,7 +6068,7 @@
       </p:sp>
       <p:sp>
         <p:nvSpPr>
-          <p:cNvPr id="8" name="TextBox 7"/>
+          <p:cNvPr id="10" name="TextBox 9"/>
           <p:cNvSpPr txBox="1"/>
           <p:nvPr/>
         </p:nvSpPr>
@@ -5926,7 +6171,7 @@
       </p:sp>
       <p:sp>
         <p:nvSpPr>
-          <p:cNvPr id="9" name="Rounded Rectangle 8"/>
+          <p:cNvPr id="11" name="Rounded Rectangle 10"/>
           <p:cNvSpPr/>
           <p:nvPr/>
         </p:nvSpPr>
@@ -5971,7 +6216,7 @@
       </p:sp>
       <p:sp>
         <p:nvSpPr>
-          <p:cNvPr id="10" name="TextBox 9"/>
+          <p:cNvPr id="12" name="TextBox 11"/>
           <p:cNvSpPr txBox="1"/>
           <p:nvPr/>
         </p:nvSpPr>
@@ -6098,16 +6343,40 @@
         <p:nvPr/>
       </p:nvGrpSpPr>
       <p:grpSpPr/>
-      <p:sp>
-        <p:nvSpPr>
-          <p:cNvPr id="2" name="Rectangle 1"/>
+      <p:pic>
+        <p:nvPicPr>
+          <p:cNvPr id="2" name="Picture 1" descr="uzbek_mandala.jpg"/>
+          <p:cNvPicPr>
+            <a:picLocks noChangeAspect="1"/>
+          </p:cNvPicPr>
+          <p:nvPr/>
+        </p:nvPicPr>
+        <p:blipFill>
+          <a:blip r:embed="rId2"/>
+          <a:stretch>
+            <a:fillRect/>
+          </a:stretch>
+        </p:blipFill>
+        <p:spPr>
+          <a:xfrm>
+            <a:off x="10058400" y="-914400"/>
+            <a:ext cx="3200400" cy="3200400"/>
+          </a:xfrm>
+          <a:prstGeom prst="rect">
+            <a:avLst/>
+          </a:prstGeom>
+        </p:spPr>
+      </p:pic>
+      <p:sp>
+        <p:nvSpPr>
+          <p:cNvPr id="3" name="Rectangle 2"/>
           <p:cNvSpPr/>
           <p:nvPr/>
         </p:nvSpPr>
         <p:spPr>
           <a:xfrm>
             <a:off x="0" y="0"/>
-            <a:ext cx="12191695" cy="137160"/>
+            <a:ext cx="12191695" cy="109728"/>
           </a:xfrm>
           <a:prstGeom prst="rect">
             <a:avLst/>
@@ -6143,14 +6412,14 @@
       </p:sp>
       <p:sp>
         <p:nvSpPr>
-          <p:cNvPr id="3" name="TextBox 2"/>
+          <p:cNvPr id="4" name="TextBox 3"/>
           <p:cNvSpPr txBox="1"/>
           <p:nvPr/>
         </p:nvSpPr>
         <p:spPr>
           <a:xfrm>
-            <a:off x="457200" y="6492240"/>
-            <a:ext cx="11277295" cy="274320"/>
+            <a:off x="731520" y="6492240"/>
+            <a:ext cx="9601200" cy="274320"/>
           </a:xfrm>
           <a:prstGeom prst="rect">
             <a:avLst/>
@@ -6177,9 +6446,33 @@
           </a:p>
         </p:txBody>
       </p:sp>
-      <p:sp>
-        <p:nvSpPr>
-          <p:cNvPr id="4" name="TextBox 3"/>
+      <p:pic>
+        <p:nvPicPr>
+          <p:cNvPr id="5" name="Picture 4" descr="logo.jpg"/>
+          <p:cNvPicPr>
+            <a:picLocks noChangeAspect="1"/>
+          </p:cNvPicPr>
+          <p:nvPr/>
+        </p:nvPicPr>
+        <p:blipFill>
+          <a:blip r:embed="rId3"/>
+          <a:stretch>
+            <a:fillRect/>
+          </a:stretch>
+        </p:blipFill>
+        <p:spPr>
+          <a:xfrm>
+            <a:off x="11430000" y="6309360"/>
+            <a:ext cx="457200" cy="457200"/>
+          </a:xfrm>
+          <a:prstGeom prst="rect">
+            <a:avLst/>
+          </a:prstGeom>
+        </p:spPr>
+      </p:pic>
+      <p:sp>
+        <p:nvSpPr>
+          <p:cNvPr id="6" name="TextBox 5"/>
           <p:cNvSpPr txBox="1"/>
           <p:nvPr/>
         </p:nvSpPr>
@@ -6200,7 +6493,7 @@
           <a:lstStyle/>
           <a:p>
             <a:pPr>
-              <a:defRPr sz="3600" b="1">
+              <a:defRPr sz="3400" b="1">
                 <a:solidFill>
                   <a:srgbClr val="D4AF37"/>
                 </a:solidFill>
@@ -6215,7 +6508,7 @@
       </p:sp>
       <p:sp>
         <p:nvSpPr>
-          <p:cNvPr id="5" name="Rounded Rectangle 4"/>
+          <p:cNvPr id="7" name="Rounded Rectangle 6"/>
           <p:cNvSpPr/>
           <p:nvPr/>
         </p:nvSpPr>
@@ -6260,7 +6553,7 @@
       </p:sp>
       <p:sp>
         <p:nvSpPr>
-          <p:cNvPr id="6" name="TextBox 5"/>
+          <p:cNvPr id="8" name="TextBox 7"/>
           <p:cNvSpPr txBox="1"/>
           <p:nvPr/>
         </p:nvSpPr>
@@ -6395,7 +6688,7 @@
       </p:sp>
       <p:sp>
         <p:nvSpPr>
-          <p:cNvPr id="7" name="Rounded Rectangle 6"/>
+          <p:cNvPr id="9" name="Rounded Rectangle 8"/>
           <p:cNvSpPr/>
           <p:nvPr/>
         </p:nvSpPr>
@@ -6440,7 +6733,7 @@
       </p:sp>
       <p:sp>
         <p:nvSpPr>
-          <p:cNvPr id="8" name="TextBox 7"/>
+          <p:cNvPr id="10" name="TextBox 9"/>
           <p:cNvSpPr txBox="1"/>
           <p:nvPr/>
         </p:nvSpPr>
@@ -6599,16 +6892,40 @@
         <p:nvPr/>
       </p:nvGrpSpPr>
       <p:grpSpPr/>
-      <p:sp>
-        <p:nvSpPr>
-          <p:cNvPr id="2" name="Rectangle 1"/>
+      <p:pic>
+        <p:nvPicPr>
+          <p:cNvPr id="2" name="Picture 1" descr="uzbek_mandala.jpg"/>
+          <p:cNvPicPr>
+            <a:picLocks noChangeAspect="1"/>
+          </p:cNvPicPr>
+          <p:nvPr/>
+        </p:nvPicPr>
+        <p:blipFill>
+          <a:blip r:embed="rId2"/>
+          <a:stretch>
+            <a:fillRect/>
+          </a:stretch>
+        </p:blipFill>
+        <p:spPr>
+          <a:xfrm>
+            <a:off x="10058400" y="-914400"/>
+            <a:ext cx="3200400" cy="3200400"/>
+          </a:xfrm>
+          <a:prstGeom prst="rect">
+            <a:avLst/>
+          </a:prstGeom>
+        </p:spPr>
+      </p:pic>
+      <p:sp>
+        <p:nvSpPr>
+          <p:cNvPr id="3" name="Rectangle 2"/>
           <p:cNvSpPr/>
           <p:nvPr/>
         </p:nvSpPr>
         <p:spPr>
           <a:xfrm>
             <a:off x="0" y="0"/>
-            <a:ext cx="12191695" cy="137160"/>
+            <a:ext cx="12191695" cy="109728"/>
           </a:xfrm>
           <a:prstGeom prst="rect">
             <a:avLst/>
@@ -6644,14 +6961,14 @@
       </p:sp>
       <p:sp>
         <p:nvSpPr>
-          <p:cNvPr id="3" name="TextBox 2"/>
+          <p:cNvPr id="4" name="TextBox 3"/>
           <p:cNvSpPr txBox="1"/>
           <p:nvPr/>
         </p:nvSpPr>
         <p:spPr>
           <a:xfrm>
-            <a:off x="457200" y="6492240"/>
-            <a:ext cx="11277295" cy="274320"/>
+            <a:off x="731520" y="6492240"/>
+            <a:ext cx="9601200" cy="274320"/>
           </a:xfrm>
           <a:prstGeom prst="rect">
             <a:avLst/>
@@ -6678,9 +6995,33 @@
           </a:p>
         </p:txBody>
       </p:sp>
-      <p:sp>
-        <p:nvSpPr>
-          <p:cNvPr id="4" name="TextBox 3"/>
+      <p:pic>
+        <p:nvPicPr>
+          <p:cNvPr id="5" name="Picture 4" descr="logo.jpg"/>
+          <p:cNvPicPr>
+            <a:picLocks noChangeAspect="1"/>
+          </p:cNvPicPr>
+          <p:nvPr/>
+        </p:nvPicPr>
+        <p:blipFill>
+          <a:blip r:embed="rId3"/>
+          <a:stretch>
+            <a:fillRect/>
+          </a:stretch>
+        </p:blipFill>
+        <p:spPr>
+          <a:xfrm>
+            <a:off x="11430000" y="6309360"/>
+            <a:ext cx="457200" cy="457200"/>
+          </a:xfrm>
+          <a:prstGeom prst="rect">
+            <a:avLst/>
+          </a:prstGeom>
+        </p:spPr>
+      </p:pic>
+      <p:sp>
+        <p:nvSpPr>
+          <p:cNvPr id="6" name="TextBox 5"/>
           <p:cNvSpPr txBox="1"/>
           <p:nvPr/>
         </p:nvSpPr>
@@ -6701,7 +7042,7 @@
           <a:lstStyle/>
           <a:p>
             <a:pPr>
-              <a:defRPr sz="3600" b="1">
+              <a:defRPr sz="3400" b="1">
                 <a:solidFill>
                   <a:srgbClr val="D4AF37"/>
                 </a:solidFill>
@@ -6716,7 +7057,7 @@
       </p:sp>
       <p:sp>
         <p:nvSpPr>
-          <p:cNvPr id="5" name="TextBox 4"/>
+          <p:cNvPr id="7" name="TextBox 6"/>
           <p:cNvSpPr txBox="1"/>
           <p:nvPr/>
         </p:nvSpPr>
@@ -6859,7 +7200,7 @@
       </p:sp>
       <p:sp>
         <p:nvSpPr>
-          <p:cNvPr id="6" name="Rounded Rectangle 5"/>
+          <p:cNvPr id="8" name="Rounded Rectangle 7"/>
           <p:cNvSpPr/>
           <p:nvPr/>
         </p:nvSpPr>
@@ -6904,7 +7245,7 @@
       </p:sp>
       <p:sp>
         <p:nvSpPr>
-          <p:cNvPr id="7" name="TextBox 6"/>
+          <p:cNvPr id="9" name="TextBox 8"/>
           <p:cNvSpPr txBox="1"/>
           <p:nvPr/>
         </p:nvSpPr>

</xml_diff>

<commit_message>
docs: update investor pitch deck slides and scripts with contact info
</commit_message>
<xml_diff>
--- a/Samarqand_CrafTour_Investor_Pitch_Deck.pptx
+++ b/Samarqand_CrafTour_Investor_Pitch_Deck.pptx
@@ -13,6 +13,10 @@
     <p:sldId id="261" r:id="rId12"/>
     <p:sldId id="262" r:id="rId13"/>
     <p:sldId id="263" r:id="rId14"/>
+    <p:sldId id="264" r:id="rId15"/>
+    <p:sldId id="265" r:id="rId16"/>
+    <p:sldId id="266" r:id="rId17"/>
+    <p:sldId id="267" r:id="rId18"/>
   </p:sldIdLst>
   <p:sldSz cx="12191695" cy="6858000" type="screen4x3"/>
   <p:notesSz cx="6858000" cy="9144000"/>
@@ -3202,7 +3206,7 @@
         </p:nvSpPr>
         <p:spPr>
           <a:xfrm>
-            <a:off x="914400" y="2103120"/>
+            <a:off x="914400" y="2011680"/>
             <a:ext cx="5669280" cy="3657600"/>
           </a:xfrm>
           <a:prstGeom prst="rect">
@@ -3217,7 +3221,7 @@
           <a:lstStyle/>
           <a:p>
             <a:pPr algn="l">
-              <a:defRPr sz="4600" b="1">
+              <a:defRPr sz="4400" b="1">
                 <a:solidFill>
                   <a:srgbClr val="D4AF37"/>
                 </a:solidFill>
@@ -3225,15 +3229,19 @@
               </a:defRPr>
             </a:pPr>
             <a:r>
-              <a:t>SAMARQAND CRAFTOUR</a:t>
+              <a:t>UZBEK-TRIP</a:t>
+            </a:r>
+            <a:br/>
+            <a:r>
+              <a:t>PLATFORMASI</a:t>
             </a:r>
           </a:p>
           <a:p>
             <a:pPr algn="l">
               <a:spcBef>
-                <a:spcPts val="800"/>
+                <a:spcPts val="1000"/>
               </a:spcBef>
-              <a:defRPr sz="1800">
+              <a:defRPr sz="1600" b="1">
                 <a:solidFill>
                   <a:srgbClr val="FFFFFF"/>
                 </a:solidFill>
@@ -3241,7 +3249,7 @@
               </a:defRPr>
             </a:pPr>
             <a:r>
-              <a:t>Moslashuvchan va Shaxsiy Turizm Platformasi</a:t>
+              <a:t>Menejment, Marketing, Audit va Iqtisodiyot</a:t>
             </a:r>
           </a:p>
           <a:p>
@@ -3249,7 +3257,7 @@
               <a:spcBef>
                 <a:spcPts val="1500"/>
               </a:spcBef>
-              <a:defRPr sz="1300">
+              <a:defRPr sz="1200">
                 <a:solidFill>
                   <a:srgbClr val="94A3B8"/>
                 </a:solidFill>
@@ -3257,7 +3265,7 @@
               </a:defRPr>
             </a:pPr>
             <a:r>
-              <a:t>Sayyohlar uchun interaktiv marshrut konstruktori va shaffof band qilish ekotizimi.</a:t>
+              <a:t>Sayohatlarni real vaqtda rejalashtirish, GPS navigatsiyasi, n8n avtomatizatsiyasi hamda hamkorlar uchun unit-iqtisodiy yechimlar ekotizimi.</a:t>
             </a:r>
           </a:p>
         </p:txBody>
@@ -3293,7 +3301,1353 @@
               </a:defRPr>
             </a:pPr>
             <a:r>
-              <a:t>INVESTITSIYA TAQDIMOTI  |  2026</a:t>
+              <a:t>BIZNES HAMKORLAR VA INVESTORLAR UCHUN TAQDIMOT  |  2026</a:t>
+            </a:r>
+          </a:p>
+        </p:txBody>
+      </p:sp>
+    </p:spTree>
+  </p:cSld>
+  <p:clrMapOvr>
+    <a:masterClrMapping/>
+  </p:clrMapOvr>
+</p:sld>
+</file>
+
+<file path=ppt/slides/slide10.xml><?xml version="1.0" encoding="utf-8"?>
+<p:sld xmlns:a="http://schemas.openxmlformats.org/drawingml/2006/main" xmlns:p="http://schemas.openxmlformats.org/presentationml/2006/main" xmlns:r="http://schemas.openxmlformats.org/officeDocument/2006/relationships">
+  <p:cSld>
+    <p:bg>
+      <p:bgPr>
+        <a:solidFill>
+          <a:srgbClr val="0A0F1D"/>
+        </a:solidFill>
+        <a:effectLst/>
+      </p:bgPr>
+    </p:bg>
+    <p:spTree>
+      <p:nvGrpSpPr>
+        <p:cNvPr id="1" name=""/>
+        <p:cNvGrpSpPr/>
+        <p:nvPr/>
+      </p:nvGrpSpPr>
+      <p:grpSpPr/>
+      <p:pic>
+        <p:nvPicPr>
+          <p:cNvPr id="2" name="Picture 1" descr="uzbek_mandala.jpg"/>
+          <p:cNvPicPr>
+            <a:picLocks noChangeAspect="1"/>
+          </p:cNvPicPr>
+          <p:nvPr/>
+        </p:nvPicPr>
+        <p:blipFill>
+          <a:blip r:embed="rId2"/>
+          <a:stretch>
+            <a:fillRect/>
+          </a:stretch>
+        </p:blipFill>
+        <p:spPr>
+          <a:xfrm>
+            <a:off x="10058400" y="-914400"/>
+            <a:ext cx="3200400" cy="3200400"/>
+          </a:xfrm>
+          <a:prstGeom prst="rect">
+            <a:avLst/>
+          </a:prstGeom>
+        </p:spPr>
+      </p:pic>
+      <p:sp>
+        <p:nvSpPr>
+          <p:cNvPr id="3" name="Rectangle 2"/>
+          <p:cNvSpPr/>
+          <p:nvPr/>
+        </p:nvSpPr>
+        <p:spPr>
+          <a:xfrm>
+            <a:off x="0" y="0"/>
+            <a:ext cx="12191695" cy="109728"/>
+          </a:xfrm>
+          <a:prstGeom prst="rect">
+            <a:avLst/>
+          </a:prstGeom>
+          <a:solidFill>
+            <a:srgbClr val="D4AF37"/>
+          </a:solidFill>
+          <a:ln>
+            <a:noFill/>
+          </a:ln>
+        </p:spPr>
+        <p:style>
+          <a:lnRef idx="1">
+            <a:schemeClr val="accent1"/>
+          </a:lnRef>
+          <a:fillRef idx="3">
+            <a:schemeClr val="accent1"/>
+          </a:fillRef>
+          <a:effectRef idx="2">
+            <a:schemeClr val="accent1"/>
+          </a:effectRef>
+          <a:fontRef idx="minor">
+            <a:schemeClr val="lt1"/>
+          </a:fontRef>
+        </p:style>
+        <p:txBody>
+          <a:bodyPr rtlCol="0" anchor="ctr"/>
+          <a:lstStyle/>
+          <a:p>
+            <a:pPr algn="ctr"/>
+          </a:p>
+        </p:txBody>
+      </p:sp>
+      <p:sp>
+        <p:nvSpPr>
+          <p:cNvPr id="4" name="TextBox 3"/>
+          <p:cNvSpPr txBox="1"/>
+          <p:nvPr/>
+        </p:nvSpPr>
+        <p:spPr>
+          <a:xfrm>
+            <a:off x="731520" y="6492240"/>
+            <a:ext cx="9601200" cy="274320"/>
+          </a:xfrm>
+          <a:prstGeom prst="rect">
+            <a:avLst/>
+          </a:prstGeom>
+          <a:noFill/>
+        </p:spPr>
+        <p:txBody>
+          <a:bodyPr wrap="none" lIns="0" rIns="0" tIns="0" bIns="0">
+            <a:spAutoFit/>
+          </a:bodyPr>
+          <a:lstStyle/>
+          <a:p>
+            <a:pPr>
+              <a:defRPr sz="900" b="1">
+                <a:solidFill>
+                  <a:srgbClr val="475569"/>
+                </a:solidFill>
+                <a:latin typeface="Segoe UI"/>
+              </a:defRPr>
+            </a:pPr>
+            <a:r>
+              <a:t>UZBEK-TRIP (SAMARQAND CRAFTOUR)  |  HAMKORLIK TAQDIMOTI 2026</a:t>
+            </a:r>
+          </a:p>
+        </p:txBody>
+      </p:sp>
+      <p:pic>
+        <p:nvPicPr>
+          <p:cNvPr id="5" name="Picture 4" descr="logo.jpg"/>
+          <p:cNvPicPr>
+            <a:picLocks noChangeAspect="1"/>
+          </p:cNvPicPr>
+          <p:nvPr/>
+        </p:nvPicPr>
+        <p:blipFill>
+          <a:blip r:embed="rId3"/>
+          <a:stretch>
+            <a:fillRect/>
+          </a:stretch>
+        </p:blipFill>
+        <p:spPr>
+          <a:xfrm>
+            <a:off x="11430000" y="6309360"/>
+            <a:ext cx="457200" cy="457200"/>
+          </a:xfrm>
+          <a:prstGeom prst="rect">
+            <a:avLst/>
+          </a:prstGeom>
+        </p:spPr>
+      </p:pic>
+      <p:sp>
+        <p:nvSpPr>
+          <p:cNvPr id="6" name="TextBox 5"/>
+          <p:cNvSpPr txBox="1"/>
+          <p:nvPr/>
+        </p:nvSpPr>
+        <p:spPr>
+          <a:xfrm>
+            <a:off x="731520" y="457200"/>
+            <a:ext cx="10728655" cy="731520"/>
+          </a:xfrm>
+          <a:prstGeom prst="rect">
+            <a:avLst/>
+          </a:prstGeom>
+          <a:noFill/>
+        </p:spPr>
+        <p:txBody>
+          <a:bodyPr wrap="square" lIns="0" rIns="0" tIns="0" bIns="0">
+            <a:spAutoFit/>
+          </a:bodyPr>
+          <a:lstStyle/>
+          <a:p>
+            <a:pPr>
+              <a:defRPr sz="3000" b="1">
+                <a:solidFill>
+                  <a:srgbClr val="D4AF37"/>
+                </a:solidFill>
+                <a:latin typeface="Georgia"/>
+              </a:defRPr>
+            </a:pPr>
+            <a:r>
+              <a:t>KELAJAKDAGI STRATEGIK REJALAR</a:t>
+            </a:r>
+          </a:p>
+        </p:txBody>
+      </p:sp>
+      <p:sp>
+        <p:nvSpPr>
+          <p:cNvPr id="7" name="Rounded Rectangle 6"/>
+          <p:cNvSpPr/>
+          <p:nvPr/>
+        </p:nvSpPr>
+        <p:spPr>
+          <a:xfrm>
+            <a:off x="731520" y="1645920"/>
+            <a:ext cx="3291840" cy="4114800"/>
+          </a:xfrm>
+          <a:prstGeom prst="roundRect">
+            <a:avLst/>
+          </a:prstGeom>
+          <a:solidFill>
+            <a:srgbClr val="121A2F"/>
+          </a:solidFill>
+          <a:ln w="19050">
+            <a:solidFill>
+              <a:srgbClr val="D4AF37"/>
+            </a:solidFill>
+          </a:ln>
+        </p:spPr>
+        <p:style>
+          <a:lnRef idx="1">
+            <a:schemeClr val="accent1"/>
+          </a:lnRef>
+          <a:fillRef idx="3">
+            <a:schemeClr val="accent1"/>
+          </a:fillRef>
+          <a:effectRef idx="2">
+            <a:schemeClr val="accent1"/>
+          </a:effectRef>
+          <a:fontRef idx="minor">
+            <a:schemeClr val="lt1"/>
+          </a:fontRef>
+        </p:style>
+        <p:txBody>
+          <a:bodyPr rtlCol="0" anchor="ctr"/>
+          <a:lstStyle/>
+          <a:p>
+            <a:pPr algn="ctr"/>
+          </a:p>
+        </p:txBody>
+      </p:sp>
+      <p:sp>
+        <p:nvSpPr>
+          <p:cNvPr id="8" name="TextBox 7"/>
+          <p:cNvSpPr txBox="1"/>
+          <p:nvPr/>
+        </p:nvSpPr>
+        <p:spPr>
+          <a:xfrm>
+            <a:off x="914400" y="1828800"/>
+            <a:ext cx="2926080" cy="3749040"/>
+          </a:xfrm>
+          <a:prstGeom prst="rect">
+            <a:avLst/>
+          </a:prstGeom>
+          <a:noFill/>
+        </p:spPr>
+        <p:txBody>
+          <a:bodyPr wrap="square">
+            <a:spAutoFit/>
+          </a:bodyPr>
+          <a:lstStyle/>
+          <a:p>
+            <a:pPr>
+              <a:defRPr sz="2800" b="1">
+                <a:solidFill>
+                  <a:srgbClr val="009B9E"/>
+                </a:solidFill>
+                <a:latin typeface="Georgia"/>
+              </a:defRPr>
+            </a:pPr>
+            <a:r>
+              <a:t>01</a:t>
+            </a:r>
+          </a:p>
+          <a:p>
+            <a:pPr>
+              <a:spcBef>
+                <a:spcPts val="1000"/>
+              </a:spcBef>
+              <a:spcAft>
+                <a:spcPts val="1000"/>
+              </a:spcAft>
+              <a:defRPr sz="1700" b="1">
+                <a:solidFill>
+                  <a:srgbClr val="D4AF37"/>
+                </a:solidFill>
+                <a:latin typeface="Georgia"/>
+              </a:defRPr>
+            </a:pPr>
+            <a:r>
+              <a:t>UzRailways Integratsiyasi</a:t>
+            </a:r>
+          </a:p>
+          <a:p>
+            <a:pPr>
+              <a:spcAft>
+                <a:spcPts val="1500"/>
+              </a:spcAft>
+              <a:defRPr sz="1200">
+                <a:solidFill>
+                  <a:srgbClr val="94A3B8"/>
+                </a:solidFill>
+                <a:latin typeface="Segoe UI"/>
+              </a:defRPr>
+            </a:pPr>
+            <a:r>
+              <a:t>Platforma ichida Afrosiyob tezyurar poyezdi chiptalarini avtomatik sotish tizimini yo'lga qo'yish (UzRailways API orqali).</a:t>
+            </a:r>
+          </a:p>
+          <a:p>
+            <a:pPr>
+              <a:defRPr sz="1200" b="1">
+                <a:solidFill>
+                  <a:srgbClr val="FFFFFF"/>
+                </a:solidFill>
+                <a:latin typeface="Segoe UI"/>
+              </a:defRPr>
+            </a:pPr>
+            <a:r>
+              <a:t>Maqsad: Poyezd Chiptalari</a:t>
+            </a:r>
+          </a:p>
+        </p:txBody>
+      </p:sp>
+      <p:sp>
+        <p:nvSpPr>
+          <p:cNvPr id="9" name="Rounded Rectangle 8"/>
+          <p:cNvSpPr/>
+          <p:nvPr/>
+        </p:nvSpPr>
+        <p:spPr>
+          <a:xfrm>
+            <a:off x="4389120" y="1645920"/>
+            <a:ext cx="3291840" cy="4114800"/>
+          </a:xfrm>
+          <a:prstGeom prst="roundRect">
+            <a:avLst/>
+          </a:prstGeom>
+          <a:solidFill>
+            <a:srgbClr val="121A2F"/>
+          </a:solidFill>
+          <a:ln w="19050">
+            <a:solidFill>
+              <a:srgbClr val="D4AF37"/>
+            </a:solidFill>
+          </a:ln>
+        </p:spPr>
+        <p:style>
+          <a:lnRef idx="1">
+            <a:schemeClr val="accent1"/>
+          </a:lnRef>
+          <a:fillRef idx="3">
+            <a:schemeClr val="accent1"/>
+          </a:fillRef>
+          <a:effectRef idx="2">
+            <a:schemeClr val="accent1"/>
+          </a:effectRef>
+          <a:fontRef idx="minor">
+            <a:schemeClr val="lt1"/>
+          </a:fontRef>
+        </p:style>
+        <p:txBody>
+          <a:bodyPr rtlCol="0" anchor="ctr"/>
+          <a:lstStyle/>
+          <a:p>
+            <a:pPr algn="ctr"/>
+          </a:p>
+        </p:txBody>
+      </p:sp>
+      <p:sp>
+        <p:nvSpPr>
+          <p:cNvPr id="10" name="TextBox 9"/>
+          <p:cNvSpPr txBox="1"/>
+          <p:nvPr/>
+        </p:nvSpPr>
+        <p:spPr>
+          <a:xfrm>
+            <a:off x="4572000" y="1828800"/>
+            <a:ext cx="2926080" cy="3749040"/>
+          </a:xfrm>
+          <a:prstGeom prst="rect">
+            <a:avLst/>
+          </a:prstGeom>
+          <a:noFill/>
+        </p:spPr>
+        <p:txBody>
+          <a:bodyPr wrap="square">
+            <a:spAutoFit/>
+          </a:bodyPr>
+          <a:lstStyle/>
+          <a:p>
+            <a:pPr>
+              <a:defRPr sz="2800" b="1">
+                <a:solidFill>
+                  <a:srgbClr val="009B9E"/>
+                </a:solidFill>
+                <a:latin typeface="Georgia"/>
+              </a:defRPr>
+            </a:pPr>
+            <a:r>
+              <a:t>02</a:t>
+            </a:r>
+          </a:p>
+          <a:p>
+            <a:pPr>
+              <a:spcBef>
+                <a:spcPts val="1000"/>
+              </a:spcBef>
+              <a:spcAft>
+                <a:spcPts val="1000"/>
+              </a:spcAft>
+              <a:defRPr sz="1700" b="1">
+                <a:solidFill>
+                  <a:srgbClr val="D4AF37"/>
+                </a:solidFill>
+                <a:latin typeface="Georgia"/>
+              </a:defRPr>
+            </a:pPr>
+            <a:r>
+              <a:t>Milliy Avia-chiptalar</a:t>
+            </a:r>
+          </a:p>
+          <a:p>
+            <a:pPr>
+              <a:spcAft>
+                <a:spcPts val="1500"/>
+              </a:spcAft>
+              <a:defRPr sz="1200">
+                <a:solidFill>
+                  <a:srgbClr val="94A3B8"/>
+                </a:solidFill>
+                <a:latin typeface="Segoe UI"/>
+              </a:defRPr>
+            </a:pPr>
+            <a:r>
+              <a:t>Xalqaro va ichki reys chiptalarini dynamic ravishda platformaga ulash. Sayohat konstruktorida poyezd + samolyot integratsiyasi.</a:t>
+            </a:r>
+          </a:p>
+          <a:p>
+            <a:pPr>
+              <a:defRPr sz="1200" b="1">
+                <a:solidFill>
+                  <a:srgbClr val="FFFFFF"/>
+                </a:solidFill>
+                <a:latin typeface="Segoe UI"/>
+              </a:defRPr>
+            </a:pPr>
+            <a:r>
+              <a:t>Maqsad: Aviakompaniyalar</a:t>
+            </a:r>
+          </a:p>
+        </p:txBody>
+      </p:sp>
+      <p:sp>
+        <p:nvSpPr>
+          <p:cNvPr id="11" name="Rounded Rectangle 10"/>
+          <p:cNvSpPr/>
+          <p:nvPr/>
+        </p:nvSpPr>
+        <p:spPr>
+          <a:xfrm>
+            <a:off x="8046720" y="1645920"/>
+            <a:ext cx="3291840" cy="4114800"/>
+          </a:xfrm>
+          <a:prstGeom prst="roundRect">
+            <a:avLst/>
+          </a:prstGeom>
+          <a:solidFill>
+            <a:srgbClr val="121A2F"/>
+          </a:solidFill>
+          <a:ln w="19050">
+            <a:solidFill>
+              <a:srgbClr val="D4AF37"/>
+            </a:solidFill>
+          </a:ln>
+        </p:spPr>
+        <p:style>
+          <a:lnRef idx="1">
+            <a:schemeClr val="accent1"/>
+          </a:lnRef>
+          <a:fillRef idx="3">
+            <a:schemeClr val="accent1"/>
+          </a:fillRef>
+          <a:effectRef idx="2">
+            <a:schemeClr val="accent1"/>
+          </a:effectRef>
+          <a:fontRef idx="minor">
+            <a:schemeClr val="lt1"/>
+          </a:fontRef>
+        </p:style>
+        <p:txBody>
+          <a:bodyPr rtlCol="0" anchor="ctr"/>
+          <a:lstStyle/>
+          <a:p>
+            <a:pPr algn="ctr"/>
+          </a:p>
+        </p:txBody>
+      </p:sp>
+      <p:sp>
+        <p:nvSpPr>
+          <p:cNvPr id="12" name="TextBox 11"/>
+          <p:cNvSpPr txBox="1"/>
+          <p:nvPr/>
+        </p:nvSpPr>
+        <p:spPr>
+          <a:xfrm>
+            <a:off x="8229600" y="1828800"/>
+            <a:ext cx="2926080" cy="3749040"/>
+          </a:xfrm>
+          <a:prstGeom prst="rect">
+            <a:avLst/>
+          </a:prstGeom>
+          <a:noFill/>
+        </p:spPr>
+        <p:txBody>
+          <a:bodyPr wrap="square">
+            <a:spAutoFit/>
+          </a:bodyPr>
+          <a:lstStyle/>
+          <a:p>
+            <a:pPr>
+              <a:defRPr sz="2800" b="1">
+                <a:solidFill>
+                  <a:srgbClr val="009B9E"/>
+                </a:solidFill>
+                <a:latin typeface="Georgia"/>
+              </a:defRPr>
+            </a:pPr>
+            <a:r>
+              <a:t>03</a:t>
+            </a:r>
+          </a:p>
+          <a:p>
+            <a:pPr>
+              <a:spcBef>
+                <a:spcPts val="1000"/>
+              </a:spcBef>
+              <a:spcAft>
+                <a:spcPts val="1000"/>
+              </a:spcAft>
+              <a:defRPr sz="1700" b="1">
+                <a:solidFill>
+                  <a:srgbClr val="D4AF37"/>
+                </a:solidFill>
+                <a:latin typeface="Georgia"/>
+              </a:defRPr>
+            </a:pPr>
+            <a:r>
+              <a:t>Ovozli Navigatsiya</a:t>
+            </a:r>
+          </a:p>
+          <a:p>
+            <a:pPr>
+              <a:spcAft>
+                <a:spcPts val="1500"/>
+              </a:spcAft>
+              <a:defRPr sz="1200">
+                <a:solidFill>
+                  <a:srgbClr val="94A3B8"/>
+                </a:solidFill>
+                <a:latin typeface="Segoe UI"/>
+              </a:defRPr>
+            </a:pPr>
+            <a:r>
+              <a:t>Sayyohlar tarixiy obidalarda yurganda avtomatik ishga tushadigan localized ovozli audioprezentatsiya (multilingual voice guidance).</a:t>
+            </a:r>
+          </a:p>
+          <a:p>
+            <a:pPr>
+              <a:defRPr sz="1200" b="1">
+                <a:solidFill>
+                  <a:srgbClr val="FFFFFF"/>
+                </a:solidFill>
+                <a:latin typeface="Segoe UI"/>
+              </a:defRPr>
+            </a:pPr>
+            <a:r>
+              <a:t>Maqsad: Smart Audio Guide</a:t>
+            </a:r>
+          </a:p>
+        </p:txBody>
+      </p:sp>
+    </p:spTree>
+  </p:cSld>
+  <p:clrMapOvr>
+    <a:masterClrMapping/>
+  </p:clrMapOvr>
+</p:sld>
+</file>
+
+<file path=ppt/slides/slide11.xml><?xml version="1.0" encoding="utf-8"?>
+<p:sld xmlns:a="http://schemas.openxmlformats.org/drawingml/2006/main" xmlns:p="http://schemas.openxmlformats.org/presentationml/2006/main" xmlns:r="http://schemas.openxmlformats.org/officeDocument/2006/relationships">
+  <p:cSld>
+    <p:bg>
+      <p:bgPr>
+        <a:solidFill>
+          <a:srgbClr val="0A0F1D"/>
+        </a:solidFill>
+        <a:effectLst/>
+      </p:bgPr>
+    </p:bg>
+    <p:spTree>
+      <p:nvGrpSpPr>
+        <p:cNvPr id="1" name=""/>
+        <p:cNvGrpSpPr/>
+        <p:nvPr/>
+      </p:nvGrpSpPr>
+      <p:grpSpPr/>
+      <p:pic>
+        <p:nvPicPr>
+          <p:cNvPr id="2" name="Picture 1" descr="uzbek_mandala.jpg"/>
+          <p:cNvPicPr>
+            <a:picLocks noChangeAspect="1"/>
+          </p:cNvPicPr>
+          <p:nvPr/>
+        </p:nvPicPr>
+        <p:blipFill>
+          <a:blip r:embed="rId2"/>
+          <a:stretch>
+            <a:fillRect/>
+          </a:stretch>
+        </p:blipFill>
+        <p:spPr>
+          <a:xfrm>
+            <a:off x="10058400" y="-914400"/>
+            <a:ext cx="3200400" cy="3200400"/>
+          </a:xfrm>
+          <a:prstGeom prst="rect">
+            <a:avLst/>
+          </a:prstGeom>
+        </p:spPr>
+      </p:pic>
+      <p:sp>
+        <p:nvSpPr>
+          <p:cNvPr id="3" name="Rectangle 2"/>
+          <p:cNvSpPr/>
+          <p:nvPr/>
+        </p:nvSpPr>
+        <p:spPr>
+          <a:xfrm>
+            <a:off x="0" y="0"/>
+            <a:ext cx="12191695" cy="109728"/>
+          </a:xfrm>
+          <a:prstGeom prst="rect">
+            <a:avLst/>
+          </a:prstGeom>
+          <a:solidFill>
+            <a:srgbClr val="D4AF37"/>
+          </a:solidFill>
+          <a:ln>
+            <a:noFill/>
+          </a:ln>
+        </p:spPr>
+        <p:style>
+          <a:lnRef idx="1">
+            <a:schemeClr val="accent1"/>
+          </a:lnRef>
+          <a:fillRef idx="3">
+            <a:schemeClr val="accent1"/>
+          </a:fillRef>
+          <a:effectRef idx="2">
+            <a:schemeClr val="accent1"/>
+          </a:effectRef>
+          <a:fontRef idx="minor">
+            <a:schemeClr val="lt1"/>
+          </a:fontRef>
+        </p:style>
+        <p:txBody>
+          <a:bodyPr rtlCol="0" anchor="ctr"/>
+          <a:lstStyle/>
+          <a:p>
+            <a:pPr algn="ctr"/>
+          </a:p>
+        </p:txBody>
+      </p:sp>
+      <p:sp>
+        <p:nvSpPr>
+          <p:cNvPr id="4" name="TextBox 3"/>
+          <p:cNvSpPr txBox="1"/>
+          <p:nvPr/>
+        </p:nvSpPr>
+        <p:spPr>
+          <a:xfrm>
+            <a:off x="731520" y="6492240"/>
+            <a:ext cx="9601200" cy="274320"/>
+          </a:xfrm>
+          <a:prstGeom prst="rect">
+            <a:avLst/>
+          </a:prstGeom>
+          <a:noFill/>
+        </p:spPr>
+        <p:txBody>
+          <a:bodyPr wrap="none" lIns="0" rIns="0" tIns="0" bIns="0">
+            <a:spAutoFit/>
+          </a:bodyPr>
+          <a:lstStyle/>
+          <a:p>
+            <a:pPr>
+              <a:defRPr sz="900" b="1">
+                <a:solidFill>
+                  <a:srgbClr val="475569"/>
+                </a:solidFill>
+                <a:latin typeface="Segoe UI"/>
+              </a:defRPr>
+            </a:pPr>
+            <a:r>
+              <a:t>UZBEK-TRIP (SAMARQAND CRAFTOUR)  |  HAMKORLIK TAQDIMOTI 2026</a:t>
+            </a:r>
+          </a:p>
+        </p:txBody>
+      </p:sp>
+      <p:pic>
+        <p:nvPicPr>
+          <p:cNvPr id="5" name="Picture 4" descr="logo.jpg"/>
+          <p:cNvPicPr>
+            <a:picLocks noChangeAspect="1"/>
+          </p:cNvPicPr>
+          <p:nvPr/>
+        </p:nvPicPr>
+        <p:blipFill>
+          <a:blip r:embed="rId3"/>
+          <a:stretch>
+            <a:fillRect/>
+          </a:stretch>
+        </p:blipFill>
+        <p:spPr>
+          <a:xfrm>
+            <a:off x="11430000" y="6309360"/>
+            <a:ext cx="457200" cy="457200"/>
+          </a:xfrm>
+          <a:prstGeom prst="rect">
+            <a:avLst/>
+          </a:prstGeom>
+        </p:spPr>
+      </p:pic>
+      <p:sp>
+        <p:nvSpPr>
+          <p:cNvPr id="6" name="TextBox 5"/>
+          <p:cNvSpPr txBox="1"/>
+          <p:nvPr/>
+        </p:nvSpPr>
+        <p:spPr>
+          <a:xfrm>
+            <a:off x="731520" y="457200"/>
+            <a:ext cx="10728655" cy="731520"/>
+          </a:xfrm>
+          <a:prstGeom prst="rect">
+            <a:avLst/>
+          </a:prstGeom>
+          <a:noFill/>
+        </p:spPr>
+        <p:txBody>
+          <a:bodyPr wrap="square" lIns="0" rIns="0" tIns="0" bIns="0">
+            <a:spAutoFit/>
+          </a:bodyPr>
+          <a:lstStyle/>
+          <a:p>
+            <a:pPr>
+              <a:defRPr sz="3000" b="1">
+                <a:solidFill>
+                  <a:srgbClr val="D4AF37"/>
+                </a:solidFill>
+                <a:latin typeface="Georgia"/>
+              </a:defRPr>
+            </a:pPr>
+            <a:r>
+              <a:t>INVESTITSIYA TAKLIFI VA BUDJET TAQSIMOTI</a:t>
+            </a:r>
+          </a:p>
+        </p:txBody>
+      </p:sp>
+      <p:sp>
+        <p:nvSpPr>
+          <p:cNvPr id="7" name="TextBox 6"/>
+          <p:cNvSpPr txBox="1"/>
+          <p:nvPr/>
+        </p:nvSpPr>
+        <p:spPr>
+          <a:xfrm>
+            <a:off x="731520" y="1645920"/>
+            <a:ext cx="4572000" cy="4114800"/>
+          </a:xfrm>
+          <a:prstGeom prst="rect">
+            <a:avLst/>
+          </a:prstGeom>
+          <a:noFill/>
+        </p:spPr>
+        <p:txBody>
+          <a:bodyPr wrap="square">
+            <a:spAutoFit/>
+          </a:bodyPr>
+          <a:lstStyle/>
+          <a:p>
+            <a:pPr>
+              <a:spcAft>
+                <a:spcPts val="1000"/>
+              </a:spcAft>
+              <a:defRPr sz="1400" b="1">
+                <a:solidFill>
+                  <a:srgbClr val="009B9E"/>
+                </a:solidFill>
+                <a:latin typeface="Segoe UI"/>
+              </a:defRPr>
+            </a:pPr>
+            <a:r>
+              <a:t>MOLIYAVIY EHTIYOJ</a:t>
+            </a:r>
+          </a:p>
+          <a:p>
+            <a:pPr>
+              <a:spcAft>
+                <a:spcPts val="1500"/>
+              </a:spcAft>
+              <a:defRPr sz="3600" b="1">
+                <a:solidFill>
+                  <a:srgbClr val="D4AF37"/>
+                </a:solidFill>
+                <a:latin typeface="Georgia"/>
+              </a:defRPr>
+            </a:pPr>
+            <a:r>
+              <a:t>$100,000 Seed Round</a:t>
+            </a:r>
+          </a:p>
+          <a:p>
+            <a:pPr>
+              <a:spcAft>
+                <a:spcPts val="1000"/>
+              </a:spcAft>
+              <a:defRPr sz="1300">
+                <a:solidFill>
+                  <a:srgbClr val="FFFFFF"/>
+                </a:solidFill>
+                <a:latin typeface="Segoe UI"/>
+              </a:defRPr>
+            </a:pPr>
+            <a:r>
+              <a:t>Ushbu sarmoya loyihaning operatsion faoliyatini kengaytirish va 1 yillik rivojlanish bosqichlari uchun sarflanadi.</a:t>
+            </a:r>
+          </a:p>
+          <a:p>
+            <a:pPr>
+              <a:spcAft>
+                <a:spcPts val="500"/>
+              </a:spcAft>
+              <a:defRPr sz="1200" b="1">
+                <a:solidFill>
+                  <a:srgbClr val="D4AF37"/>
+                </a:solidFill>
+                <a:latin typeface="Segoe UI"/>
+              </a:defRPr>
+            </a:pPr>
+            <a:r>
+              <a:t>✔ Dasturiy Rivojlanish (40%): </a:t>
+            </a:r>
+            <a:r>
+              <a:rPr b="0">
+                <a:solidFill>
+                  <a:srgbClr val="94A3B8"/>
+                </a:solidFill>
+              </a:rPr>
+              <a:t>iOS / Android mobil ilovalarini tayyorlash.</a:t>
+            </a:r>
+          </a:p>
+          <a:p>
+            <a:pPr>
+              <a:spcAft>
+                <a:spcPts val="500"/>
+              </a:spcAft>
+              <a:defRPr sz="1200" b="1">
+                <a:solidFill>
+                  <a:srgbClr val="D4AF37"/>
+                </a:solidFill>
+                <a:latin typeface="Segoe UI"/>
+              </a:defRPr>
+            </a:pPr>
+            <a:r>
+              <a:t>✔ Marketing va Jalb Etish (35%): </a:t>
+            </a:r>
+            <a:r>
+              <a:rPr b="0">
+                <a:solidFill>
+                  <a:srgbClr val="94A3B8"/>
+                </a:solidFill>
+              </a:rPr>
+              <a:t>B2C va B2B mehmonxona kampaniyalari.</a:t>
+            </a:r>
+          </a:p>
+          <a:p>
+            <a:pPr>
+              <a:spcAft>
+                <a:spcPts val="500"/>
+              </a:spcAft>
+              <a:defRPr sz="1200" b="1">
+                <a:solidFill>
+                  <a:srgbClr val="D4AF37"/>
+                </a:solidFill>
+                <a:latin typeface="Segoe UI"/>
+              </a:defRPr>
+            </a:pPr>
+            <a:r>
+              <a:t>✔ Operatsion Xarajatlar (25%): </a:t>
+            </a:r>
+            <a:r>
+              <a:rPr b="0">
+                <a:solidFill>
+                  <a:srgbClr val="94A3B8"/>
+                </a:solidFill>
+              </a:rPr>
+              <a:t>Haydovchilar auditini o'tkazish va ofis faoliyati.</a:t>
+            </a:r>
+          </a:p>
+        </p:txBody>
+      </p:sp>
+      <p:sp>
+        <p:nvSpPr>
+          <p:cNvPr id="8" name="Rounded Rectangle 7"/>
+          <p:cNvSpPr/>
+          <p:nvPr/>
+        </p:nvSpPr>
+        <p:spPr>
+          <a:xfrm>
+            <a:off x="5943600" y="1645920"/>
+            <a:ext cx="5486400" cy="4114800"/>
+          </a:xfrm>
+          <a:prstGeom prst="roundRect">
+            <a:avLst/>
+          </a:prstGeom>
+          <a:solidFill>
+            <a:srgbClr val="121A2F"/>
+          </a:solidFill>
+          <a:ln w="19050">
+            <a:solidFill>
+              <a:srgbClr val="D4AF37"/>
+            </a:solidFill>
+          </a:ln>
+        </p:spPr>
+        <p:style>
+          <a:lnRef idx="1">
+            <a:schemeClr val="accent1"/>
+          </a:lnRef>
+          <a:fillRef idx="3">
+            <a:schemeClr val="accent1"/>
+          </a:fillRef>
+          <a:effectRef idx="2">
+            <a:schemeClr val="accent1"/>
+          </a:effectRef>
+          <a:fontRef idx="minor">
+            <a:schemeClr val="lt1"/>
+          </a:fontRef>
+        </p:style>
+        <p:txBody>
+          <a:bodyPr rtlCol="0" anchor="ctr"/>
+          <a:lstStyle/>
+          <a:p>
+            <a:pPr algn="ctr"/>
+          </a:p>
+        </p:txBody>
+      </p:sp>
+      <p:sp>
+        <p:nvSpPr>
+          <p:cNvPr id="9" name="TextBox 8"/>
+          <p:cNvSpPr txBox="1"/>
+          <p:nvPr/>
+        </p:nvSpPr>
+        <p:spPr>
+          <a:xfrm>
+            <a:off x="6309360" y="1920240"/>
+            <a:ext cx="4754880" cy="3566160"/>
+          </a:xfrm>
+          <a:prstGeom prst="rect">
+            <a:avLst/>
+          </a:prstGeom>
+          <a:noFill/>
+        </p:spPr>
+        <p:txBody>
+          <a:bodyPr wrap="square">
+            <a:spAutoFit/>
+          </a:bodyPr>
+          <a:lstStyle/>
+          <a:p>
+            <a:pPr>
+              <a:spcAft>
+                <a:spcPts val="1500"/>
+              </a:spcAft>
+              <a:defRPr sz="2000" b="1">
+                <a:solidFill>
+                  <a:srgbClr val="D4AF37"/>
+                </a:solidFill>
+                <a:latin typeface="Georgia"/>
+              </a:defRPr>
+            </a:pPr>
+            <a:r>
+              <a:t>🤝 Hamkorlik Shartlari</a:t>
+            </a:r>
+          </a:p>
+          <a:p>
+            <a:pPr>
+              <a:spcAft>
+                <a:spcPts val="800"/>
+              </a:spcAft>
+              <a:defRPr sz="1200">
+                <a:solidFill>
+                  <a:srgbClr val="94A3B8"/>
+                </a:solidFill>
+                <a:latin typeface="Segoe UI"/>
+              </a:defRPr>
+            </a:pPr>
+            <a:r>
+              <a:t>⚡ 10-15% gacha ulush (Equity) investitsiya evaziga.</a:t>
+            </a:r>
+          </a:p>
+          <a:p>
+            <a:pPr>
+              <a:spcAft>
+                <a:spcPts val="800"/>
+              </a:spcAft>
+              <a:defRPr sz="1200">
+                <a:solidFill>
+                  <a:srgbClr val="94A3B8"/>
+                </a:solidFill>
+                <a:latin typeface="Segoe UI"/>
+              </a:defRPr>
+            </a:pPr>
+            <a:r>
+              <a:t>⚡ Mehmonxonalar va restorantlar uchun B2B hamkorlikda alohida referral / keshbek tizimi.</a:t>
+            </a:r>
+          </a:p>
+          <a:p>
+            <a:pPr>
+              <a:spcAft>
+                <a:spcPts val="800"/>
+              </a:spcAft>
+              <a:defRPr sz="1200">
+                <a:solidFill>
+                  <a:srgbClr val="94A3B8"/>
+                </a:solidFill>
+                <a:latin typeface="Segoe UI"/>
+              </a:defRPr>
+            </a:pPr>
+            <a:r>
+              <a:t>⚡ Tezyurar poyezd va aviabiletlar integratsiyasida qo'shma aksiyalar va hamkorlik imkoniyatlari.</a:t>
+            </a:r>
+          </a:p>
+          <a:p>
+            <a:pPr>
+              <a:spcAft>
+                <a:spcPts val="800"/>
+              </a:spcAft>
+              <a:defRPr sz="1200">
+                <a:solidFill>
+                  <a:srgbClr val="94A3B8"/>
+                </a:solidFill>
+                <a:latin typeface="Segoe UI"/>
+              </a:defRPr>
+            </a:pPr>
+            <a:r>
+              <a:t>⚡ Strategik boshqaruv kengashida ishtirok etish huquqi.</a:t>
+            </a:r>
+          </a:p>
+        </p:txBody>
+      </p:sp>
+    </p:spTree>
+  </p:cSld>
+  <p:clrMapOvr>
+    <a:masterClrMapping/>
+  </p:clrMapOvr>
+</p:sld>
+</file>
+
+<file path=ppt/slides/slide12.xml><?xml version="1.0" encoding="utf-8"?>
+<p:sld xmlns:a="http://schemas.openxmlformats.org/drawingml/2006/main" xmlns:p="http://schemas.openxmlformats.org/presentationml/2006/main" xmlns:r="http://schemas.openxmlformats.org/officeDocument/2006/relationships">
+  <p:cSld>
+    <p:bg>
+      <p:bgPr>
+        <a:solidFill>
+          <a:srgbClr val="0A0F1D"/>
+        </a:solidFill>
+        <a:effectLst/>
+      </p:bgPr>
+    </p:bg>
+    <p:spTree>
+      <p:nvGrpSpPr>
+        <p:cNvPr id="1" name=""/>
+        <p:cNvGrpSpPr/>
+        <p:nvPr/>
+      </p:nvGrpSpPr>
+      <p:grpSpPr/>
+      <p:pic>
+        <p:nvPicPr>
+          <p:cNvPr id="2" name="Picture 1" descr="uzbek_mandala.jpg"/>
+          <p:cNvPicPr>
+            <a:picLocks noChangeAspect="1"/>
+          </p:cNvPicPr>
+          <p:nvPr/>
+        </p:nvPicPr>
+        <p:blipFill>
+          <a:blip r:embed="rId2"/>
+          <a:stretch>
+            <a:fillRect/>
+          </a:stretch>
+        </p:blipFill>
+        <p:spPr>
+          <a:xfrm>
+            <a:off x="10058400" y="-914400"/>
+            <a:ext cx="3200400" cy="3200400"/>
+          </a:xfrm>
+          <a:prstGeom prst="rect">
+            <a:avLst/>
+          </a:prstGeom>
+        </p:spPr>
+      </p:pic>
+      <p:sp>
+        <p:nvSpPr>
+          <p:cNvPr id="3" name="Rectangle 2"/>
+          <p:cNvSpPr/>
+          <p:nvPr/>
+        </p:nvSpPr>
+        <p:spPr>
+          <a:xfrm>
+            <a:off x="0" y="0"/>
+            <a:ext cx="12191695" cy="109728"/>
+          </a:xfrm>
+          <a:prstGeom prst="rect">
+            <a:avLst/>
+          </a:prstGeom>
+          <a:solidFill>
+            <a:srgbClr val="D4AF37"/>
+          </a:solidFill>
+          <a:ln>
+            <a:noFill/>
+          </a:ln>
+        </p:spPr>
+        <p:style>
+          <a:lnRef idx="1">
+            <a:schemeClr val="accent1"/>
+          </a:lnRef>
+          <a:fillRef idx="3">
+            <a:schemeClr val="accent1"/>
+          </a:fillRef>
+          <a:effectRef idx="2">
+            <a:schemeClr val="accent1"/>
+          </a:effectRef>
+          <a:fontRef idx="minor">
+            <a:schemeClr val="lt1"/>
+          </a:fontRef>
+        </p:style>
+        <p:txBody>
+          <a:bodyPr rtlCol="0" anchor="ctr"/>
+          <a:lstStyle/>
+          <a:p>
+            <a:pPr algn="ctr"/>
+          </a:p>
+        </p:txBody>
+      </p:sp>
+      <p:sp>
+        <p:nvSpPr>
+          <p:cNvPr id="4" name="TextBox 3"/>
+          <p:cNvSpPr txBox="1"/>
+          <p:nvPr/>
+        </p:nvSpPr>
+        <p:spPr>
+          <a:xfrm>
+            <a:off x="731520" y="6492240"/>
+            <a:ext cx="9601200" cy="274320"/>
+          </a:xfrm>
+          <a:prstGeom prst="rect">
+            <a:avLst/>
+          </a:prstGeom>
+          <a:noFill/>
+        </p:spPr>
+        <p:txBody>
+          <a:bodyPr wrap="none" lIns="0" rIns="0" tIns="0" bIns="0">
+            <a:spAutoFit/>
+          </a:bodyPr>
+          <a:lstStyle/>
+          <a:p>
+            <a:pPr>
+              <a:defRPr sz="900" b="1">
+                <a:solidFill>
+                  <a:srgbClr val="475569"/>
+                </a:solidFill>
+                <a:latin typeface="Segoe UI"/>
+              </a:defRPr>
+            </a:pPr>
+            <a:r>
+              <a:t>UZBEK-TRIP (SAMARQAND CRAFTOUR)  |  HAMKORLIK TAQDIMOTI 2026</a:t>
+            </a:r>
+          </a:p>
+        </p:txBody>
+      </p:sp>
+      <p:pic>
+        <p:nvPicPr>
+          <p:cNvPr id="5" name="Picture 4" descr="logo.jpg"/>
+          <p:cNvPicPr>
+            <a:picLocks noChangeAspect="1"/>
+          </p:cNvPicPr>
+          <p:nvPr/>
+        </p:nvPicPr>
+        <p:blipFill>
+          <a:blip r:embed="rId3"/>
+          <a:stretch>
+            <a:fillRect/>
+          </a:stretch>
+        </p:blipFill>
+        <p:spPr>
+          <a:xfrm>
+            <a:off x="11430000" y="6309360"/>
+            <a:ext cx="457200" cy="457200"/>
+          </a:xfrm>
+          <a:prstGeom prst="rect">
+            <a:avLst/>
+          </a:prstGeom>
+        </p:spPr>
+      </p:pic>
+      <p:sp>
+        <p:nvSpPr>
+          <p:cNvPr id="6" name="Rectangle 5"/>
+          <p:cNvSpPr/>
+          <p:nvPr/>
+        </p:nvSpPr>
+        <p:spPr>
+          <a:xfrm>
+            <a:off x="1828800" y="1371600"/>
+            <a:ext cx="8534095" cy="4114800"/>
+          </a:xfrm>
+          <a:prstGeom prst="rect">
+            <a:avLst/>
+          </a:prstGeom>
+          <a:solidFill>
+            <a:srgbClr val="121A2F"/>
+          </a:solidFill>
+          <a:ln w="25400">
+            <a:solidFill>
+              <a:srgbClr val="D4AF37"/>
+            </a:solidFill>
+          </a:ln>
+        </p:spPr>
+        <p:style>
+          <a:lnRef idx="1">
+            <a:schemeClr val="accent1"/>
+          </a:lnRef>
+          <a:fillRef idx="3">
+            <a:schemeClr val="accent1"/>
+          </a:fillRef>
+          <a:effectRef idx="2">
+            <a:schemeClr val="accent1"/>
+          </a:effectRef>
+          <a:fontRef idx="minor">
+            <a:schemeClr val="lt1"/>
+          </a:fontRef>
+        </p:style>
+        <p:txBody>
+          <a:bodyPr rtlCol="0" anchor="ctr"/>
+          <a:lstStyle/>
+          <a:p>
+            <a:pPr algn="ctr"/>
+          </a:p>
+        </p:txBody>
+      </p:sp>
+      <p:sp>
+        <p:nvSpPr>
+          <p:cNvPr id="7" name="TextBox 6"/>
+          <p:cNvSpPr txBox="1"/>
+          <p:nvPr/>
+        </p:nvSpPr>
+        <p:spPr>
+          <a:xfrm>
+            <a:off x="2286000" y="1828800"/>
+            <a:ext cx="7619695" cy="3200400"/>
+          </a:xfrm>
+          <a:prstGeom prst="rect">
+            <a:avLst/>
+          </a:prstGeom>
+          <a:noFill/>
+        </p:spPr>
+        <p:txBody>
+          <a:bodyPr wrap="square">
+            <a:spAutoFit/>
+          </a:bodyPr>
+          <a:lstStyle/>
+          <a:p>
+            <a:pPr algn="ctr">
+              <a:spcAft>
+                <a:spcPts val="1000"/>
+              </a:spcAft>
+              <a:defRPr sz="3600" b="1">
+                <a:solidFill>
+                  <a:srgbClr val="D4AF37"/>
+                </a:solidFill>
+                <a:latin typeface="Georgia"/>
+              </a:defRPr>
+            </a:pPr>
+            <a:r>
+              <a:t>KATTA RAHMAT!</a:t>
+            </a:r>
+          </a:p>
+          <a:p>
+            <a:pPr algn="ctr">
+              <a:spcAft>
+                <a:spcPts val="2500"/>
+              </a:spcAft>
+              <a:defRPr sz="1600">
+                <a:solidFill>
+                  <a:srgbClr val="FFFFFF"/>
+                </a:solidFill>
+                <a:latin typeface="Segoe UI"/>
+              </a:defRPr>
+            </a:pPr>
+            <a:r>
+              <a:t>O'zbekistonda Zamonaviy va Shaxsiy Turizm Ekotizimini Birgalikda Yarataylik.</a:t>
+            </a:r>
+          </a:p>
+          <a:p>
+            <a:pPr algn="ctr">
+              <a:spcAft>
+                <a:spcPts val="1500"/>
+              </a:spcAft>
+              <a:defRPr sz="1400">
+                <a:solidFill>
+                  <a:srgbClr val="94A3B8"/>
+                </a:solidFill>
+                <a:latin typeface="Segoe UI"/>
+              </a:defRPr>
+            </a:pPr>
+            <a:r>
+              <a:t>📞 Aloqa: +998 (94) 019-64-20</a:t>
+            </a:r>
+            <a:br/>
+            <a:r>
+              <a:t>📧 Email: mikemukhriddin@gmail.com</a:t>
+            </a:r>
+            <a:br/>
+            <a:r>
+              <a:t>🌐 Veb-sayt: uzbek-trip.vercel.app</a:t>
+            </a:r>
+          </a:p>
+          <a:p>
+            <a:pPr algn="ctr">
+              <a:defRPr sz="1300" b="1" i="1">
+                <a:solidFill>
+                  <a:srgbClr val="009B9E"/>
+                </a:solidFill>
+                <a:latin typeface="Segoe UI"/>
+              </a:defRPr>
+            </a:pPr>
+            <a:r>
+              <a:t>Savollar bormi? Biz har qanday hamkorlikka tayyormiz!</a:t>
             </a:r>
           </a:p>
         </p:txBody>
@@ -3422,7 +4776,7 @@
               </a:defRPr>
             </a:pPr>
             <a:r>
-              <a:t>SAMARQAND CRAFTOUR  |  INVESTITSIYA TAQDIMOTI 2026</a:t>
+              <a:t>UZBEK-TRIP (SAMARQAND CRAFTOUR)  |  HAMKORLIK TAQDIMOTI 2026</a:t>
             </a:r>
           </a:p>
         </p:txBody>
@@ -3474,7 +4828,7 @@
           <a:lstStyle/>
           <a:p>
             <a:pPr>
-              <a:defRPr sz="3400" b="1">
+              <a:defRPr sz="3000" b="1">
                 <a:solidFill>
                   <a:srgbClr val="D4AF37"/>
                 </a:solidFill>
@@ -3482,7 +4836,7 @@
               </a:defRPr>
             </a:pPr>
             <a:r>
-              <a:t>TURIZMDAGI ASOSIY MUAMMOLAR</a:t>
+              <a:t>BOZOR MUAMMOLARI VA IMKONIYAT</a:t>
             </a:r>
           </a:p>
         </p:txBody>
@@ -3582,7 +4936,7 @@
               </a:defRPr>
             </a:pPr>
             <a:r>
-              <a:t>Turlar Qotib Qolganligi</a:t>
+              <a:t>Tashkiliy Qiyinchiliklar</a:t>
             </a:r>
           </a:p>
           <a:p>
@@ -3598,7 +4952,7 @@
               </a:defRPr>
             </a:pPr>
             <a:r>
-              <a:t>An'anaviy turpaketlar juda qattiq rejalashtirilgan. Zamonaviy sayyohlar tayyor shablonlardan charchagan va o'z marshrutlarini shaxsiy qiziqishlariga moslashni xohlashadi.</a:t>
+              <a:t>Sayyohlar gidlar, haydovchilar va marshrutlarni turli joylardan qidirishga majbur. Yagona, tezkor va ishonchli buyurtma berish vositasi mavjud emas.</a:t>
             </a:r>
           </a:p>
           <a:p>
@@ -3611,7 +4965,7 @@
               </a:defRPr>
             </a:pPr>
             <a:r>
-              <a:t>Tog'lar, hunarmandchilik ustaxonalari va gastronomik lokatsiyalar e'tibordan chetda qoladi.</a:t>
+              <a:t>Operatsion menejmentning parchalanganligi.</a:t>
             </a:r>
           </a:p>
         </p:txBody>
@@ -3711,7 +5065,7 @@
               </a:defRPr>
             </a:pPr>
             <a:r>
-              <a:t>Narxlar Shaffof Emasligi</a:t>
+              <a:t>Shaffof Emas Narxlar</a:t>
             </a:r>
           </a:p>
           <a:p>
@@ -3727,7 +5081,7 @@
               </a:defRPr>
             </a:pPr>
             <a:r>
-              <a:t>Gidlar va haydovchilar bozori tartibga solinmagan. Yashirin komissiyalar, narxlarning tez-tez o'zgarishi va sayyohlar uchun oldindan aniq xarajatlarni bilish imkoni yo'qligi.</a:t>
+              <a:t>Turizm bozorida narxlar sun'iy oshirilgan. Sayyoh oldindan aniq xizmatlar uchun qancha pul to'lashini va narx qanday shakllanishini ko'ra olmaydi.</a:t>
             </a:r>
           </a:p>
           <a:p>
@@ -3740,7 +5094,7 @@
               </a:defRPr>
             </a:pPr>
             <a:r>
-              <a:t>Muzokaralar va narx ustida tortishuvlar sayohat sifatini pasaytiradi.</a:t>
+              <a:t>Yashirin komissiyalar va noaniqlik.</a:t>
             </a:r>
           </a:p>
         </p:txBody>
@@ -3840,7 +5194,7 @@
               </a:defRPr>
             </a:pPr>
             <a:r>
-              <a:t>Ishonchli Band Qilish Muammosi</a:t>
+              <a:t>Sifat va Audit Kamchiligi</a:t>
             </a:r>
           </a:p>
           <a:p>
@@ -3856,7 +5210,7 @@
               </a:defRPr>
             </a:pPr>
             <a:r>
-              <a:t>Professional tillarni biluvchi sertifikatlangan gidlar va tajribali haydovchilarni oldindan bitta platformada xavfsiz va kafolatlangan holda band qilish imkoniyati yo'q.</a:t>
+              <a:t>Haydovchi va gidlarning sifati oldindan tekshirilmaydi. Xavfsizlik va xizmat darajasi kafolatlanmaganligi sayyohlar ishonchini yo'qotadi.</a:t>
             </a:r>
           </a:p>
           <a:p>
@@ -3869,7 +5223,7 @@
               </a:defRPr>
             </a:pPr>
             <a:r>
-              <a:t>Kutilmagan bekor qilishlar va sifatsiz xizmat ko'rsatish xavfi yuqori.</a:t>
+              <a:t>Audit va reyting tizimining yo'qligi.</a:t>
             </a:r>
           </a:p>
         </p:txBody>
@@ -3998,7 +5352,7 @@
               </a:defRPr>
             </a:pPr>
             <a:r>
-              <a:t>SAMARQAND CRAFTOUR  |  INVESTITSIYA TAQDIMOTI 2026</a:t>
+              <a:t>UZBEK-TRIP (SAMARQAND CRAFTOUR)  |  HAMKORLIK TAQDIMOTI 2026</a:t>
             </a:r>
           </a:p>
         </p:txBody>
@@ -4050,7 +5404,7 @@
           <a:lstStyle/>
           <a:p>
             <a:pPr>
-              <a:defRPr sz="3400" b="1">
+              <a:defRPr sz="3000" b="1">
                 <a:solidFill>
                   <a:srgbClr val="D4AF37"/>
                 </a:solidFill>
@@ -4058,7 +5412,7 @@
               </a:defRPr>
             </a:pPr>
             <a:r>
-              <a:t>YECHIM: SAMARQAND CRAFTOUR PLATFORMASI</a:t>
+              <a:t>OPERATSION MENEJMENT VA STRUKTURA</a:t>
             </a:r>
           </a:p>
         </p:txBody>
@@ -4097,7 +5451,7 @@
               </a:defRPr>
             </a:pPr>
             <a:r>
-              <a:t>Biz sayyohlarga to'liq erkinlik va shaffoflik beramiz.</a:t>
+              <a:t>Samarali Boshqaruv Model</a:t>
             </a:r>
           </a:p>
           <a:p>
@@ -4113,12 +5467,12 @@
               </a:defRPr>
             </a:pPr>
             <a:r>
-              <a:t>Samarqand CrafTour — bu shunchaki gid yoki mashina buyurtma qilish ilovasi emas. Bu sayyohlarning shaxsiy qiziqishlariga moslashuvchan, real vaqt rejimida ishlovchi aqlli sayohat konstruktoridir.</a:t>
-            </a:r>
-          </a:p>
-          <a:p>
-            <a:pPr>
-              <a:defRPr sz="1300">
+              <a:t>Inson omilini kamaytirgan holda, platforma barcha buyurtmalar, haydovchilar va gidlar faoliyatini markazlashgan boshqaruv paneli orqali nazorat qiladi.</a:t>
+            </a:r>
+          </a:p>
+          <a:p>
+            <a:pPr>
+              <a:defRPr sz="1200">
                 <a:solidFill>
                   <a:srgbClr val="009B9E"/>
                 </a:solidFill>
@@ -4126,7 +5480,7 @@
               </a:defRPr>
             </a:pPr>
             <a:r>
-              <a:t>Sayyoh o'z sayohatini xuddi 'Lego' g'ishtchalari kabi mustaqil teradi va yakuniy narxni soniyalarda ko'radi.</a:t>
+              <a:t>Barcha jarayonlar avtomatlashtirilgan bo'lib, dispetcherlar va operatsion xodimlarga bo'lgan ehtiyojni 90% gacha kamaytiradi.</a:t>
             </a:r>
           </a:p>
         </p:txBody>
@@ -4207,7 +5561,7 @@
               </a:defRPr>
             </a:pPr>
             <a:r>
-              <a:t>🗺 Interaktiv Marshrut Quruvchi</a:t>
+              <a:t>🚗 Haydovchilar Menejmenti</a:t>
             </a:r>
           </a:p>
           <a:p>
@@ -4223,7 +5577,7 @@
               </a:defRPr>
             </a:pPr>
             <a:r>
-              <a:t>Tarixiy maskanlar (Registon, Shohi Zinda), tabiat (Omonqo'ton dovoni) va gastronomiyani (Osh markazlari) birlashtiruvchi interaktiv xarita.</a:t>
+              <a:t>Avtomobillar sig'imi, turi (sedan, minivan, avtobus) va yo'nalish tariflari bo'yicha real vaqtda avtomatik boshqaruv va band qilish.</a:t>
             </a:r>
           </a:p>
         </p:txBody>
@@ -4304,7 +5658,7 @@
               </a:defRPr>
             </a:pPr>
             <a:r>
-              <a:t>🚗 Shaffof Narxlar va Avtomatik Hisob</a:t>
+              <a:t>🗣 Gidlar Boshqaruvi</a:t>
             </a:r>
           </a:p>
           <a:p>
@@ -4320,7 +5674,7 @@
               </a:defRPr>
             </a:pPr>
             <a:r>
-              <a:t>Yashirin komissiyalarsiz real vaqtda transport turi va gid tillari (En, Ru, Es, Fr, Uz) tariflari asosida narxni avtomatik hisoblash.</a:t>
+              <a:t>Gidlar o'z tillari (EN, RU, ES, FR, UZ) va bandlik kalendarlari asosida tizimga integratsiya qilingan.</a:t>
             </a:r>
           </a:p>
         </p:txBody>
@@ -4401,7 +5755,7 @@
               </a:defRPr>
             </a:pPr>
             <a:r>
-              <a:t>👤 Tezkor OTP Tasdiqlash va Kafolat</a:t>
+              <a:t>📊 Admin Dashboard</a:t>
             </a:r>
           </a:p>
           <a:p>
@@ -4417,7 +5771,7 @@
               </a:defRPr>
             </a:pPr>
             <a:r>
-              <a:t>Email yoki WhatsApp orqali bir lahzada OTP kod bilan tasdiqlash va sayohatni muvofiqlashtiruvchi boshqaruv tizimi.</a:t>
+              <a:t>Platforma ma'murlari uchun barcha faol turlarni kuzatish, kelib tushgan to'lovlarni nazorat qilish va hisobotlarni shakllantirish paneli.</a:t>
             </a:r>
           </a:p>
         </p:txBody>
@@ -4546,7 +5900,7 @@
               </a:defRPr>
             </a:pPr>
             <a:r>
-              <a:t>SAMARQAND CRAFTOUR  |  INVESTITSIYA TAQDIMOTI 2026</a:t>
+              <a:t>UZBEK-TRIP (SAMARQAND CRAFTOUR)  |  HAMKORLIK TAQDIMOTI 2026</a:t>
             </a:r>
           </a:p>
         </p:txBody>
@@ -4598,7 +5952,7 @@
           <a:lstStyle/>
           <a:p>
             <a:pPr>
-              <a:defRPr sz="3400" b="1">
+              <a:defRPr sz="3000" b="1">
                 <a:solidFill>
                   <a:srgbClr val="D4AF37"/>
                 </a:solidFill>
@@ -4606,7 +5960,7 @@
               </a:defRPr>
             </a:pPr>
             <a:r>
-              <a:t>MAHSULOT DEMOTSIYASI: 4 TA ODDIY QADAM</a:t>
+              <a:t>MARKETING VA MIJOZLARNI JALB QILISH</a:t>
             </a:r>
           </a:p>
         </p:txBody>
@@ -4620,7 +5974,7 @@
         <p:spPr>
           <a:xfrm>
             <a:off x="731520" y="1645920"/>
-            <a:ext cx="2377440" cy="4114800"/>
+            <a:ext cx="3291840" cy="4114800"/>
           </a:xfrm>
           <a:prstGeom prst="roundRect">
             <a:avLst/>
@@ -4665,7 +6019,7 @@
         <p:spPr>
           <a:xfrm>
             <a:off x="868680" y="1828800"/>
-            <a:ext cx="2103120" cy="3749040"/>
+            <a:ext cx="3017520" cy="3749040"/>
           </a:xfrm>
           <a:prstGeom prst="rect">
             <a:avLst/>
@@ -4687,21 +6041,21 @@
               </a:defRPr>
             </a:pPr>
             <a:r>
-              <a:t>1-QADAM</a:t>
+              <a:t>B2C RAQAMLI MARKETING</a:t>
             </a:r>
           </a:p>
           <a:p>
             <a:pPr algn="ctr">
               <a:spcBef>
-                <a:spcPts val="1500"/>
+                <a:spcPts val="1000"/>
               </a:spcBef>
               <a:spcAft>
-                <a:spcPts val="1500"/>
+                <a:spcPts val="1000"/>
               </a:spcAft>
-              <a:defRPr sz="4000"/>
-            </a:pPr>
-            <a:r>
-              <a:t>🗺</a:t>
+              <a:defRPr sz="3200"/>
+            </a:pPr>
+            <a:r>
+              <a:t>📱</a:t>
             </a:r>
           </a:p>
           <a:p>
@@ -4717,7 +6071,7 @@
               </a:defRPr>
             </a:pPr>
             <a:r>
-              <a:t>Marshrut Tuzish</a:t>
+              <a:t>Target Reklama &amp; SEO</a:t>
             </a:r>
           </a:p>
           <a:p>
@@ -4730,7 +6084,7 @@
               </a:defRPr>
             </a:pPr>
             <a:r>
-              <a:t>Sayyoh Registon, Shohi Zinda, Konigil eko-qishlog'i va tog'larni xaritadan tanlab, o'z yo'nalishini belgilaydi.</a:t>
+              <a:t>Google Ads, Instagram va Facebook orqali O'zbekistonga sayohat rejalashtirayotgan xorijiy sayyohlarni maqsadli jalb qilish. Saytning xalqaro SEO optimallashtirilishi organik trafikni oshiradi.</a:t>
             </a:r>
           </a:p>
         </p:txBody>
@@ -4743,8 +6097,8 @@
         </p:nvSpPr>
         <p:spPr>
           <a:xfrm>
-            <a:off x="3383280" y="1645920"/>
-            <a:ext cx="2377440" cy="4114800"/>
+            <a:off x="4389120" y="1645920"/>
+            <a:ext cx="3291840" cy="4114800"/>
           </a:xfrm>
           <a:prstGeom prst="roundRect">
             <a:avLst/>
@@ -4788,8 +6142,8 @@
         </p:nvSpPr>
         <p:spPr>
           <a:xfrm>
-            <a:off x="3520440" y="1828800"/>
-            <a:ext cx="2103120" cy="3749040"/>
+            <a:off x="4526280" y="1828800"/>
+            <a:ext cx="3017520" cy="3749040"/>
           </a:xfrm>
           <a:prstGeom prst="rect">
             <a:avLst/>
@@ -4811,21 +6165,21 @@
               </a:defRPr>
             </a:pPr>
             <a:r>
-              <a:t>2-QADAM</a:t>
+              <a:t>B2B HAMKORLIK</a:t>
             </a:r>
           </a:p>
           <a:p>
             <a:pPr algn="ctr">
               <a:spcBef>
-                <a:spcPts val="1500"/>
+                <a:spcPts val="1000"/>
               </a:spcBef>
               <a:spcAft>
-                <a:spcPts val="1500"/>
+                <a:spcPts val="1000"/>
               </a:spcAft>
-              <a:defRPr sz="4000"/>
-            </a:pPr>
-            <a:r>
-              <a:t>🚗</a:t>
+              <a:defRPr sz="3200"/>
+            </a:pPr>
+            <a:r>
+              <a:t>🏨</a:t>
             </a:r>
           </a:p>
           <a:p>
@@ -4841,7 +6195,7 @@
               </a:defRPr>
             </a:pPr>
             <a:r>
-              <a:t>Transport Tanlash</a:t>
+              <a:t>Mehmonxonalar va Hostellar</a:t>
             </a:r>
           </a:p>
           <a:p>
@@ -4854,7 +6208,7 @@
               </a:defRPr>
             </a:pPr>
             <a:r>
-              <a:t>Cobalt, Gentra, Minivan yoki katta sayyohlar guruhi uchun Isuzu avtobuslarini sig'im va narx bo'yicha tanlaydi.</a:t>
+              <a:t>Samarqand va Toshkentdagi 50+ yirik mehmonxonalar bilan hamkorlik shartnomalari. Har bir xonada platformaga yo'naltiruvchi maxsus QR-kod stikerlari o'rnatiladi.</a:t>
             </a:r>
           </a:p>
         </p:txBody>
@@ -4867,8 +6221,8 @@
         </p:nvSpPr>
         <p:spPr>
           <a:xfrm>
-            <a:off x="6035040" y="1645920"/>
-            <a:ext cx="2377440" cy="4114800"/>
+            <a:off x="8046720" y="1645920"/>
+            <a:ext cx="3291840" cy="4114800"/>
           </a:xfrm>
           <a:prstGeom prst="roundRect">
             <a:avLst/>
@@ -4912,8 +6266,8 @@
         </p:nvSpPr>
         <p:spPr>
           <a:xfrm>
-            <a:off x="6172200" y="1828800"/>
-            <a:ext cx="2103120" cy="3749040"/>
+            <a:off x="8183880" y="1828800"/>
+            <a:ext cx="3017520" cy="3749040"/>
           </a:xfrm>
           <a:prstGeom prst="rect">
             <a:avLst/>
@@ -4935,18 +6289,18 @@
               </a:defRPr>
             </a:pPr>
             <a:r>
-              <a:t>3-QADAM</a:t>
+              <a:t>INFLUENCER MARKETING</a:t>
             </a:r>
           </a:p>
           <a:p>
             <a:pPr algn="ctr">
               <a:spcBef>
-                <a:spcPts val="1500"/>
+                <a:spcPts val="1000"/>
               </a:spcBef>
               <a:spcAft>
-                <a:spcPts val="1500"/>
+                <a:spcPts val="1000"/>
               </a:spcAft>
-              <a:defRPr sz="4000"/>
+              <a:defRPr sz="3200"/>
             </a:pPr>
             <a:r>
               <a:t>🗣</a:t>
@@ -4965,7 +6319,7 @@
               </a:defRPr>
             </a:pPr>
             <a:r>
-              <a:t>Gidni Tanlang</a:t>
+              <a:t>Sayohat Blogerlari</a:t>
             </a:r>
           </a:p>
           <a:p>
@@ -4978,131 +6332,7 @@
               </a:defRPr>
             </a:pPr>
             <a:r>
-              <a:t>Ingliz, rus, fransuz yoki ispan tillarida so'zlashuvchi gidlar ro'yxatidan o'ziga mosini tanlaydi.</a:t>
-            </a:r>
-          </a:p>
-        </p:txBody>
-      </p:sp>
-      <p:sp>
-        <p:nvSpPr>
-          <p:cNvPr id="13" name="Rounded Rectangle 12"/>
-          <p:cNvSpPr/>
-          <p:nvPr/>
-        </p:nvSpPr>
-        <p:spPr>
-          <a:xfrm>
-            <a:off x="8686800" y="1645920"/>
-            <a:ext cx="2377440" cy="4114800"/>
-          </a:xfrm>
-          <a:prstGeom prst="roundRect">
-            <a:avLst/>
-          </a:prstGeom>
-          <a:solidFill>
-            <a:srgbClr val="121A2F"/>
-          </a:solidFill>
-          <a:ln w="19050">
-            <a:solidFill>
-              <a:srgbClr val="D4AF37"/>
-            </a:solidFill>
-          </a:ln>
-        </p:spPr>
-        <p:style>
-          <a:lnRef idx="1">
-            <a:schemeClr val="accent1"/>
-          </a:lnRef>
-          <a:fillRef idx="3">
-            <a:schemeClr val="accent1"/>
-          </a:fillRef>
-          <a:effectRef idx="2">
-            <a:schemeClr val="accent1"/>
-          </a:effectRef>
-          <a:fontRef idx="minor">
-            <a:schemeClr val="lt1"/>
-          </a:fontRef>
-        </p:style>
-        <p:txBody>
-          <a:bodyPr rtlCol="0" anchor="ctr"/>
-          <a:lstStyle/>
-          <a:p>
-            <a:pPr algn="ctr"/>
-          </a:p>
-        </p:txBody>
-      </p:sp>
-      <p:sp>
-        <p:nvSpPr>
-          <p:cNvPr id="14" name="TextBox 13"/>
-          <p:cNvSpPr txBox="1"/>
-          <p:nvPr/>
-        </p:nvSpPr>
-        <p:spPr>
-          <a:xfrm>
-            <a:off x="8823960" y="1828800"/>
-            <a:ext cx="2103120" cy="3749040"/>
-          </a:xfrm>
-          <a:prstGeom prst="rect">
-            <a:avLst/>
-          </a:prstGeom>
-          <a:noFill/>
-        </p:spPr>
-        <p:txBody>
-          <a:bodyPr wrap="square">
-            <a:spAutoFit/>
-          </a:bodyPr>
-          <a:lstStyle/>
-          <a:p>
-            <a:pPr algn="ctr">
-              <a:defRPr sz="1100" b="1">
-                <a:solidFill>
-                  <a:srgbClr val="009B9E"/>
-                </a:solidFill>
-                <a:latin typeface="Segoe UI"/>
-              </a:defRPr>
-            </a:pPr>
-            <a:r>
-              <a:t>4-QADAM</a:t>
-            </a:r>
-          </a:p>
-          <a:p>
-            <a:pPr algn="ctr">
-              <a:spcBef>
-                <a:spcPts val="1500"/>
-              </a:spcBef>
-              <a:spcAft>
-                <a:spcPts val="1500"/>
-              </a:spcAft>
-              <a:defRPr sz="4000"/>
-            </a:pPr>
-            <a:r>
-              <a:t>👤</a:t>
-            </a:r>
-          </a:p>
-          <a:p>
-            <a:pPr algn="ctr">
-              <a:spcAft>
-                <a:spcPts val="1000"/>
-              </a:spcAft>
-              <a:defRPr sz="1600" b="1">
-                <a:solidFill>
-                  <a:srgbClr val="D4AF37"/>
-                </a:solidFill>
-                <a:latin typeface="Georgia"/>
-              </a:defRPr>
-            </a:pPr>
-            <a:r>
-              <a:t>OTP Tasdiqlash</a:t>
-            </a:r>
-          </a:p>
-          <a:p>
-            <a:pPr algn="ctr">
-              <a:defRPr sz="1100">
-                <a:solidFill>
-                  <a:srgbClr val="94A3B8"/>
-                </a:solidFill>
-                <a:latin typeface="Segoe UI"/>
-              </a:defRPr>
-            </a:pPr>
-            <a:r>
-              <a:t>Aloqa ma'lumotlarini kiritadi. WhatsApp/Email orqali yuborilgan OTP kodni kiritib, buyurtmani darhol band qiladi.</a:t>
+              <a:t>Chet ellik taniqli travel-blogerlarni taklif qilish va ularning real sayohatlarini xaritada jonli kuzatish (live tracking) orqali virusli marketing kampaniyalarini amalga oshirish.</a:t>
             </a:r>
           </a:p>
         </p:txBody>
@@ -5231,7 +6461,7 @@
               </a:defRPr>
             </a:pPr>
             <a:r>
-              <a:t>SAMARQAND CRAFTOUR  |  INVESTITSIYA TAQDIMOTI 2026</a:t>
+              <a:t>UZBEK-TRIP (SAMARQAND CRAFTOUR)  |  HAMKORLIK TAQDIMOTI 2026</a:t>
             </a:r>
           </a:p>
         </p:txBody>
@@ -5283,7 +6513,7 @@
           <a:lstStyle/>
           <a:p>
             <a:pPr>
-              <a:defRPr sz="3400" b="1">
+              <a:defRPr sz="3000" b="1">
                 <a:solidFill>
                   <a:srgbClr val="D4AF37"/>
                 </a:solidFill>
@@ -5291,66 +6521,21 @@
               </a:defRPr>
             </a:pPr>
             <a:r>
-              <a:t>BOZOR IMKONIYATLARI VA O'SISH SUR'ATI</a:t>
-            </a:r>
-          </a:p>
-        </p:txBody>
-      </p:sp>
-      <p:sp>
-        <p:nvSpPr>
-          <p:cNvPr id="7" name="Rounded Rectangle 6"/>
-          <p:cNvSpPr/>
+              <a:t>AUDIT VA SIFAT NAZORATI TIZIMI</a:t>
+            </a:r>
+          </a:p>
+        </p:txBody>
+      </p:sp>
+      <p:sp>
+        <p:nvSpPr>
+          <p:cNvPr id="7" name="TextBox 6"/>
+          <p:cNvSpPr txBox="1"/>
           <p:nvPr/>
         </p:nvSpPr>
         <p:spPr>
           <a:xfrm>
             <a:off x="731520" y="1645920"/>
-            <a:ext cx="3291840" cy="2011680"/>
-          </a:xfrm>
-          <a:prstGeom prst="roundRect">
-            <a:avLst/>
-          </a:prstGeom>
-          <a:solidFill>
-            <a:srgbClr val="121A2F"/>
-          </a:solidFill>
-          <a:ln w="19050">
-            <a:solidFill>
-              <a:srgbClr val="009B9E"/>
-            </a:solidFill>
-          </a:ln>
-        </p:spPr>
-        <p:style>
-          <a:lnRef idx="1">
-            <a:schemeClr val="accent1"/>
-          </a:lnRef>
-          <a:fillRef idx="3">
-            <a:schemeClr val="accent1"/>
-          </a:fillRef>
-          <a:effectRef idx="2">
-            <a:schemeClr val="accent1"/>
-          </a:effectRef>
-          <a:fontRef idx="minor">
-            <a:schemeClr val="lt1"/>
-          </a:fontRef>
-        </p:style>
-        <p:txBody>
-          <a:bodyPr rtlCol="0" anchor="ctr"/>
-          <a:lstStyle/>
-          <a:p>
-            <a:pPr algn="ctr"/>
-          </a:p>
-        </p:txBody>
-      </p:sp>
-      <p:sp>
-        <p:nvSpPr>
-          <p:cNvPr id="8" name="TextBox 7"/>
-          <p:cNvSpPr txBox="1"/>
-          <p:nvPr/>
-        </p:nvSpPr>
-        <p:spPr>
-          <a:xfrm>
-            <a:off x="914400" y="1783080"/>
-            <a:ext cx="2926080" cy="1737360"/>
+            <a:ext cx="4114800" cy="4114800"/>
           </a:xfrm>
           <a:prstGeom prst="rect">
             <a:avLst/>
@@ -5363,240 +6548,62 @@
           </a:bodyPr>
           <a:lstStyle/>
           <a:p>
-            <a:pPr algn="ctr">
-              <a:defRPr sz="4800" b="1">
-                <a:solidFill>
-                  <a:srgbClr val="D4AF37"/>
+            <a:pPr>
+              <a:spcAft>
+                <a:spcPts val="1500"/>
+              </a:spcAft>
+              <a:defRPr sz="2600" b="1">
+                <a:solidFill>
+                  <a:srgbClr val="FFFFFF"/>
                 </a:solidFill>
                 <a:latin typeface="Georgia"/>
               </a:defRPr>
             </a:pPr>
             <a:r>
-              <a:t>+45%</a:t>
-            </a:r>
-          </a:p>
-          <a:p>
-            <a:pPr algn="ctr">
-              <a:spcBef>
-                <a:spcPts val="500"/>
-              </a:spcBef>
-              <a:defRPr sz="1300" b="1">
-                <a:solidFill>
-                  <a:srgbClr val="FFFFFF"/>
+              <a:t>Kafolatlangan Sifat</a:t>
+            </a:r>
+          </a:p>
+          <a:p>
+            <a:pPr>
+              <a:spcAft>
+                <a:spcPts val="1500"/>
+              </a:spcAft>
+              <a:defRPr sz="1400">
+                <a:solidFill>
+                  <a:srgbClr val="94A3B8"/>
                 </a:solidFill>
                 <a:latin typeface="Segoe UI"/>
               </a:defRPr>
             </a:pPr>
             <a:r>
-              <a:t>Turizm Oqimining Yillik O'sishi</a:t>
-            </a:r>
-          </a:p>
-        </p:txBody>
-      </p:sp>
-      <p:sp>
-        <p:nvSpPr>
-          <p:cNvPr id="9" name="Rounded Rectangle 8"/>
+              <a:t>Sayohat davomida eng yuqori darajada xavfsizlik va xizmat sifatini ta'minlash maqsadida platformamizda ko'p bosqichli audit tizimi joriy qilingan.</a:t>
+            </a:r>
+          </a:p>
+          <a:p>
+            <a:pPr>
+              <a:defRPr sz="1200">
+                <a:solidFill>
+                  <a:srgbClr val="009B9E"/>
+                </a:solidFill>
+                <a:latin typeface="Segoe UI"/>
+              </a:defRPr>
+            </a:pPr>
+            <a:r>
+              <a:t>Har bir haydovchi va gid muntazam tekshiruvdan o'tkaziladi.</a:t>
+            </a:r>
+          </a:p>
+        </p:txBody>
+      </p:sp>
+      <p:sp>
+        <p:nvSpPr>
+          <p:cNvPr id="8" name="Rounded Rectangle 7"/>
           <p:cNvSpPr/>
           <p:nvPr/>
         </p:nvSpPr>
         <p:spPr>
           <a:xfrm>
-            <a:off x="4389120" y="1645920"/>
-            <a:ext cx="3291840" cy="2011680"/>
-          </a:xfrm>
-          <a:prstGeom prst="roundRect">
-            <a:avLst/>
-          </a:prstGeom>
-          <a:solidFill>
-            <a:srgbClr val="121A2F"/>
-          </a:solidFill>
-          <a:ln w="19050">
-            <a:solidFill>
-              <a:srgbClr val="009B9E"/>
-            </a:solidFill>
-          </a:ln>
-        </p:spPr>
-        <p:style>
-          <a:lnRef idx="1">
-            <a:schemeClr val="accent1"/>
-          </a:lnRef>
-          <a:fillRef idx="3">
-            <a:schemeClr val="accent1"/>
-          </a:fillRef>
-          <a:effectRef idx="2">
-            <a:schemeClr val="accent1"/>
-          </a:effectRef>
-          <a:fontRef idx="minor">
-            <a:schemeClr val="lt1"/>
-          </a:fontRef>
-        </p:style>
-        <p:txBody>
-          <a:bodyPr rtlCol="0" anchor="ctr"/>
-          <a:lstStyle/>
-          <a:p>
-            <a:pPr algn="ctr"/>
-          </a:p>
-        </p:txBody>
-      </p:sp>
-      <p:sp>
-        <p:nvSpPr>
-          <p:cNvPr id="10" name="TextBox 9"/>
-          <p:cNvSpPr txBox="1"/>
-          <p:nvPr/>
-        </p:nvSpPr>
-        <p:spPr>
-          <a:xfrm>
-            <a:off x="4572000" y="1783080"/>
-            <a:ext cx="2926080" cy="1737360"/>
-          </a:xfrm>
-          <a:prstGeom prst="rect">
-            <a:avLst/>
-          </a:prstGeom>
-          <a:noFill/>
-        </p:spPr>
-        <p:txBody>
-          <a:bodyPr wrap="square">
-            <a:spAutoFit/>
-          </a:bodyPr>
-          <a:lstStyle/>
-          <a:p>
-            <a:pPr algn="ctr">
-              <a:defRPr sz="4800" b="1">
-                <a:solidFill>
-                  <a:srgbClr val="D4AF37"/>
-                </a:solidFill>
-                <a:latin typeface="Georgia"/>
-              </a:defRPr>
-            </a:pPr>
-            <a:r>
-              <a:t>68%</a:t>
-            </a:r>
-          </a:p>
-          <a:p>
-            <a:pPr algn="ctr">
-              <a:spcBef>
-                <a:spcPts val="500"/>
-              </a:spcBef>
-              <a:defRPr sz="1300" b="1">
-                <a:solidFill>
-                  <a:srgbClr val="FFFFFF"/>
-                </a:solidFill>
-                <a:latin typeface="Segoe UI"/>
-              </a:defRPr>
-            </a:pPr>
-            <a:r>
-              <a:t>Mustaqil Sayohatchilar Ulushi</a:t>
-            </a:r>
-          </a:p>
-        </p:txBody>
-      </p:sp>
-      <p:sp>
-        <p:nvSpPr>
-          <p:cNvPr id="11" name="Rounded Rectangle 10"/>
-          <p:cNvSpPr/>
-          <p:nvPr/>
-        </p:nvSpPr>
-        <p:spPr>
-          <a:xfrm>
-            <a:off x="8046720" y="1645920"/>
-            <a:ext cx="3291840" cy="2011680"/>
-          </a:xfrm>
-          <a:prstGeom prst="roundRect">
-            <a:avLst/>
-          </a:prstGeom>
-          <a:solidFill>
-            <a:srgbClr val="121A2F"/>
-          </a:solidFill>
-          <a:ln w="19050">
-            <a:solidFill>
-              <a:srgbClr val="009B9E"/>
-            </a:solidFill>
-          </a:ln>
-        </p:spPr>
-        <p:style>
-          <a:lnRef idx="1">
-            <a:schemeClr val="accent1"/>
-          </a:lnRef>
-          <a:fillRef idx="3">
-            <a:schemeClr val="accent1"/>
-          </a:fillRef>
-          <a:effectRef idx="2">
-            <a:schemeClr val="accent1"/>
-          </a:effectRef>
-          <a:fontRef idx="minor">
-            <a:schemeClr val="lt1"/>
-          </a:fontRef>
-        </p:style>
-        <p:txBody>
-          <a:bodyPr rtlCol="0" anchor="ctr"/>
-          <a:lstStyle/>
-          <a:p>
-            <a:pPr algn="ctr"/>
-          </a:p>
-        </p:txBody>
-      </p:sp>
-      <p:sp>
-        <p:nvSpPr>
-          <p:cNvPr id="12" name="TextBox 11"/>
-          <p:cNvSpPr txBox="1"/>
-          <p:nvPr/>
-        </p:nvSpPr>
-        <p:spPr>
-          <a:xfrm>
-            <a:off x="8229600" y="1783080"/>
-            <a:ext cx="2926080" cy="1737360"/>
-          </a:xfrm>
-          <a:prstGeom prst="rect">
-            <a:avLst/>
-          </a:prstGeom>
-          <a:noFill/>
-        </p:spPr>
-        <p:txBody>
-          <a:bodyPr wrap="square">
-            <a:spAutoFit/>
-          </a:bodyPr>
-          <a:lstStyle/>
-          <a:p>
-            <a:pPr algn="ctr">
-              <a:defRPr sz="4800" b="1">
-                <a:solidFill>
-                  <a:srgbClr val="D4AF37"/>
-                </a:solidFill>
-                <a:latin typeface="Georgia"/>
-              </a:defRPr>
-            </a:pPr>
-            <a:r>
-              <a:t>$1.2B+</a:t>
-            </a:r>
-          </a:p>
-          <a:p>
-            <a:pPr algn="ctr">
-              <a:spcBef>
-                <a:spcPts val="500"/>
-              </a:spcBef>
-              <a:defRPr sz="1300" b="1">
-                <a:solidFill>
-                  <a:srgbClr val="FFFFFF"/>
-                </a:solidFill>
-                <a:latin typeface="Segoe UI"/>
-              </a:defRPr>
-            </a:pPr>
-            <a:r>
-              <a:t>O'zbekistondagi Turizm Bozori</a:t>
-            </a:r>
-          </a:p>
-        </p:txBody>
-      </p:sp>
-      <p:sp>
-        <p:nvSpPr>
-          <p:cNvPr id="13" name="Rounded Rectangle 12"/>
-          <p:cNvSpPr/>
-          <p:nvPr/>
-        </p:nvSpPr>
-        <p:spPr>
-          <a:xfrm>
-            <a:off x="731520" y="3931920"/>
-            <a:ext cx="10728655" cy="1828800"/>
+            <a:off x="5303520" y="1645920"/>
+            <a:ext cx="6126480" cy="1188720"/>
           </a:xfrm>
           <a:prstGeom prst="roundRect">
             <a:avLst/>
@@ -5634,14 +6641,14 @@
       </p:sp>
       <p:sp>
         <p:nvSpPr>
-          <p:cNvPr id="14" name="TextBox 13"/>
+          <p:cNvPr id="9" name="TextBox 8"/>
           <p:cNvSpPr txBox="1"/>
           <p:nvPr/>
         </p:nvSpPr>
         <p:spPr>
           <a:xfrm>
-            <a:off x="1005840" y="4114800"/>
-            <a:ext cx="10180015" cy="1463040"/>
+            <a:off x="5486400" y="1737360"/>
+            <a:ext cx="5760720" cy="1005840"/>
           </a:xfrm>
           <a:prstGeom prst="rect">
             <a:avLst/>
@@ -5655,10 +6662,7 @@
           <a:lstStyle/>
           <a:p>
             <a:pPr>
-              <a:spcAft>
-                <a:spcPts val="600"/>
-              </a:spcAft>
-              <a:defRPr sz="1800" b="1">
+              <a:defRPr sz="1600" b="1">
                 <a:solidFill>
                   <a:srgbClr val="D4AF37"/>
                 </a:solidFill>
@@ -5666,12 +6670,15 @@
               </a:defRPr>
             </a:pPr>
             <a:r>
-              <a:t>🎯 Maqsadli Segment: Muqobil va Eko-Turizm</a:t>
-            </a:r>
-          </a:p>
-          <a:p>
-            <a:pPr>
-              <a:defRPr sz="1200">
+              <a:t>🔒 OTP Tasdiqlash &amp; Anti-Fraud</a:t>
+            </a:r>
+          </a:p>
+          <a:p>
+            <a:pPr>
+              <a:spcBef>
+                <a:spcPts val="400"/>
+              </a:spcBef>
+              <a:defRPr sz="1150">
                 <a:solidFill>
                   <a:srgbClr val="94A3B8"/>
                 </a:solidFill>
@@ -5679,7 +6686,201 @@
               </a:defRPr>
             </a:pPr>
             <a:r>
-              <a:t>Sayyohlar faqatgina Registon yoki tarixiy obidalarni emas, balki Urgut tog'lari, Omonqo'ton qarag'ayzorlari, Konigil qog'oz fabrikasi kabi ekologik maskanlarni va milliy palov tayyorlash jarayonlarini mustaqil ko'rishni istashadi. Platformamiz aynan shu segmentga tezkor va kafolatlangan xizmat ko'rsatuvchi birinchi vositadir.</a:t>
+              <a:t>Buyurtmani rasmiylashtirishda email/WhatsApp orqali majburiy OTP kod kiritiladi. Bu soxta buyurtmalarni 100% oldini oladi.</a:t>
+            </a:r>
+          </a:p>
+        </p:txBody>
+      </p:sp>
+      <p:sp>
+        <p:nvSpPr>
+          <p:cNvPr id="10" name="Rounded Rectangle 9"/>
+          <p:cNvSpPr/>
+          <p:nvPr/>
+        </p:nvSpPr>
+        <p:spPr>
+          <a:xfrm>
+            <a:off x="5303520" y="3017520"/>
+            <a:ext cx="6126480" cy="1188720"/>
+          </a:xfrm>
+          <a:prstGeom prst="roundRect">
+            <a:avLst/>
+          </a:prstGeom>
+          <a:solidFill>
+            <a:srgbClr val="121A2F"/>
+          </a:solidFill>
+          <a:ln w="19050">
+            <a:solidFill>
+              <a:srgbClr val="D4AF37"/>
+            </a:solidFill>
+          </a:ln>
+        </p:spPr>
+        <p:style>
+          <a:lnRef idx="1">
+            <a:schemeClr val="accent1"/>
+          </a:lnRef>
+          <a:fillRef idx="3">
+            <a:schemeClr val="accent1"/>
+          </a:fillRef>
+          <a:effectRef idx="2">
+            <a:schemeClr val="accent1"/>
+          </a:effectRef>
+          <a:fontRef idx="minor">
+            <a:schemeClr val="lt1"/>
+          </a:fontRef>
+        </p:style>
+        <p:txBody>
+          <a:bodyPr rtlCol="0" anchor="ctr"/>
+          <a:lstStyle/>
+          <a:p>
+            <a:pPr algn="ctr"/>
+          </a:p>
+        </p:txBody>
+      </p:sp>
+      <p:sp>
+        <p:nvSpPr>
+          <p:cNvPr id="11" name="TextBox 10"/>
+          <p:cNvSpPr txBox="1"/>
+          <p:nvPr/>
+        </p:nvSpPr>
+        <p:spPr>
+          <a:xfrm>
+            <a:off x="5486400" y="3108960"/>
+            <a:ext cx="5760720" cy="1005840"/>
+          </a:xfrm>
+          <a:prstGeom prst="rect">
+            <a:avLst/>
+          </a:prstGeom>
+          <a:noFill/>
+        </p:spPr>
+        <p:txBody>
+          <a:bodyPr wrap="square">
+            <a:spAutoFit/>
+          </a:bodyPr>
+          <a:lstStyle/>
+          <a:p>
+            <a:pPr>
+              <a:defRPr sz="1600" b="1">
+                <a:solidFill>
+                  <a:srgbClr val="D4AF37"/>
+                </a:solidFill>
+                <a:latin typeface="Georgia"/>
+              </a:defRPr>
+            </a:pPr>
+            <a:r>
+              <a:t>🚗 Avtotransport Texnik Auditi</a:t>
+            </a:r>
+          </a:p>
+          <a:p>
+            <a:pPr>
+              <a:spcBef>
+                <a:spcPts val="400"/>
+              </a:spcBef>
+              <a:defRPr sz="1150">
+                <a:solidFill>
+                  <a:srgbClr val="94A3B8"/>
+                </a:solidFill>
+                <a:latin typeface="Segoe UI"/>
+              </a:defRPr>
+            </a:pPr>
+            <a:r>
+              <a:t>Hamkorlikdagi barcha transport vositalari konditsioner, tozalik va xavfsizlik kamarlari bo'yicha yillik texnik auditdan o'tadi.</a:t>
+            </a:r>
+          </a:p>
+        </p:txBody>
+      </p:sp>
+      <p:sp>
+        <p:nvSpPr>
+          <p:cNvPr id="12" name="Rounded Rectangle 11"/>
+          <p:cNvSpPr/>
+          <p:nvPr/>
+        </p:nvSpPr>
+        <p:spPr>
+          <a:xfrm>
+            <a:off x="5303520" y="4389120"/>
+            <a:ext cx="6126480" cy="1188720"/>
+          </a:xfrm>
+          <a:prstGeom prst="roundRect">
+            <a:avLst/>
+          </a:prstGeom>
+          <a:solidFill>
+            <a:srgbClr val="121A2F"/>
+          </a:solidFill>
+          <a:ln w="19050">
+            <a:solidFill>
+              <a:srgbClr val="D4AF37"/>
+            </a:solidFill>
+          </a:ln>
+        </p:spPr>
+        <p:style>
+          <a:lnRef idx="1">
+            <a:schemeClr val="accent1"/>
+          </a:lnRef>
+          <a:fillRef idx="3">
+            <a:schemeClr val="accent1"/>
+          </a:fillRef>
+          <a:effectRef idx="2">
+            <a:schemeClr val="accent1"/>
+          </a:effectRef>
+          <a:fontRef idx="minor">
+            <a:schemeClr val="lt1"/>
+          </a:fontRef>
+        </p:style>
+        <p:txBody>
+          <a:bodyPr rtlCol="0" anchor="ctr"/>
+          <a:lstStyle/>
+          <a:p>
+            <a:pPr algn="ctr"/>
+          </a:p>
+        </p:txBody>
+      </p:sp>
+      <p:sp>
+        <p:nvSpPr>
+          <p:cNvPr id="13" name="TextBox 12"/>
+          <p:cNvSpPr txBox="1"/>
+          <p:nvPr/>
+        </p:nvSpPr>
+        <p:spPr>
+          <a:xfrm>
+            <a:off x="5486400" y="4480560"/>
+            <a:ext cx="5760720" cy="1005840"/>
+          </a:xfrm>
+          <a:prstGeom prst="rect">
+            <a:avLst/>
+          </a:prstGeom>
+          <a:noFill/>
+        </p:spPr>
+        <p:txBody>
+          <a:bodyPr wrap="square">
+            <a:spAutoFit/>
+          </a:bodyPr>
+          <a:lstStyle/>
+          <a:p>
+            <a:pPr>
+              <a:defRPr sz="1600" b="1">
+                <a:solidFill>
+                  <a:srgbClr val="D4AF37"/>
+                </a:solidFill>
+                <a:latin typeface="Georgia"/>
+              </a:defRPr>
+            </a:pPr>
+            <a:r>
+              <a:t>🗣 Gidlar Litsenziya Nazorati</a:t>
+            </a:r>
+          </a:p>
+          <a:p>
+            <a:pPr>
+              <a:spcBef>
+                <a:spcPts val="400"/>
+              </a:spcBef>
+              <a:defRPr sz="1150">
+                <a:solidFill>
+                  <a:srgbClr val="94A3B8"/>
+                </a:solidFill>
+                <a:latin typeface="Segoe UI"/>
+              </a:defRPr>
+            </a:pPr>
+            <a:r>
+              <a:t>Tizimga faqat davlat tomonidan litsenziyalangan, chet tillarini bilish darajasi tasdiqlangan professional gidlar jalb etiladi.</a:t>
             </a:r>
           </a:p>
         </p:txBody>
@@ -5808,7 +7009,7 @@
               </a:defRPr>
             </a:pPr>
             <a:r>
-              <a:t>SAMARQAND CRAFTOUR  |  INVESTITSIYA TAQDIMOTI 2026</a:t>
+              <a:t>UZBEK-TRIP (SAMARQAND CRAFTOUR)  |  HAMKORLIK TAQDIMOTI 2026</a:t>
             </a:r>
           </a:p>
         </p:txBody>
@@ -5860,7 +7061,7 @@
           <a:lstStyle/>
           <a:p>
             <a:pPr>
-              <a:defRPr sz="3400" b="1">
+              <a:defRPr sz="3000" b="1">
                 <a:solidFill>
                   <a:srgbClr val="D4AF37"/>
                 </a:solidFill>
@@ -5868,7 +7069,7 @@
               </a:defRPr>
             </a:pPr>
             <a:r>
-              <a:t>BIZNES MODEL VA DAROMAD MANBALARI</a:t>
+              <a:t>IQTISODIY YONDASHUV VA UNIT-IQTISODIYOT</a:t>
             </a:r>
           </a:p>
         </p:txBody>
@@ -5882,7 +7083,346 @@
         <p:spPr>
           <a:xfrm>
             <a:off x="731520" y="1645920"/>
-            <a:ext cx="3291840" cy="4114800"/>
+            <a:ext cx="3291840" cy="2011680"/>
+          </a:xfrm>
+          <a:prstGeom prst="roundRect">
+            <a:avLst/>
+          </a:prstGeom>
+          <a:solidFill>
+            <a:srgbClr val="121A2F"/>
+          </a:solidFill>
+          <a:ln w="19050">
+            <a:solidFill>
+              <a:srgbClr val="009B9E"/>
+            </a:solidFill>
+          </a:ln>
+        </p:spPr>
+        <p:style>
+          <a:lnRef idx="1">
+            <a:schemeClr val="accent1"/>
+          </a:lnRef>
+          <a:fillRef idx="3">
+            <a:schemeClr val="accent1"/>
+          </a:fillRef>
+          <a:effectRef idx="2">
+            <a:schemeClr val="accent1"/>
+          </a:effectRef>
+          <a:fontRef idx="minor">
+            <a:schemeClr val="lt1"/>
+          </a:fontRef>
+        </p:style>
+        <p:txBody>
+          <a:bodyPr rtlCol="0" anchor="ctr"/>
+          <a:lstStyle/>
+          <a:p>
+            <a:pPr algn="ctr"/>
+          </a:p>
+        </p:txBody>
+      </p:sp>
+      <p:sp>
+        <p:nvSpPr>
+          <p:cNvPr id="8" name="TextBox 7"/>
+          <p:cNvSpPr txBox="1"/>
+          <p:nvPr/>
+        </p:nvSpPr>
+        <p:spPr>
+          <a:xfrm>
+            <a:off x="914400" y="1783080"/>
+            <a:ext cx="2926080" cy="1737360"/>
+          </a:xfrm>
+          <a:prstGeom prst="rect">
+            <a:avLst/>
+          </a:prstGeom>
+          <a:noFill/>
+        </p:spPr>
+        <p:txBody>
+          <a:bodyPr wrap="square">
+            <a:spAutoFit/>
+          </a:bodyPr>
+          <a:lstStyle/>
+          <a:p>
+            <a:pPr algn="ctr">
+              <a:defRPr sz="4800" b="1">
+                <a:solidFill>
+                  <a:srgbClr val="D4AF37"/>
+                </a:solidFill>
+                <a:latin typeface="Georgia"/>
+              </a:defRPr>
+            </a:pPr>
+            <a:r>
+              <a:t>15%</a:t>
+            </a:r>
+          </a:p>
+          <a:p>
+            <a:pPr algn="ctr">
+              <a:spcBef>
+                <a:spcPts val="500"/>
+              </a:spcBef>
+              <a:defRPr sz="1300" b="1">
+                <a:solidFill>
+                  <a:srgbClr val="FFFFFF"/>
+                </a:solidFill>
+                <a:latin typeface="Segoe UI"/>
+              </a:defRPr>
+            </a:pPr>
+            <a:r>
+              <a:t>Platforma Komissiyasi</a:t>
+            </a:r>
+          </a:p>
+          <a:p>
+            <a:pPr algn="ctr">
+              <a:spcBef>
+                <a:spcPts val="500"/>
+              </a:spcBef>
+              <a:defRPr sz="1000">
+                <a:solidFill>
+                  <a:srgbClr val="94A3B8"/>
+                </a:solidFill>
+                <a:latin typeface="Segoe UI"/>
+              </a:defRPr>
+            </a:pPr>
+            <a:r>
+              <a:t>Gidlar, haydovchilar va restoranlar to'lovlaridan platforma foydasi.</a:t>
+            </a:r>
+          </a:p>
+        </p:txBody>
+      </p:sp>
+      <p:sp>
+        <p:nvSpPr>
+          <p:cNvPr id="9" name="Rounded Rectangle 8"/>
+          <p:cNvSpPr/>
+          <p:nvPr/>
+        </p:nvSpPr>
+        <p:spPr>
+          <a:xfrm>
+            <a:off x="4389120" y="1645920"/>
+            <a:ext cx="3291840" cy="2011680"/>
+          </a:xfrm>
+          <a:prstGeom prst="roundRect">
+            <a:avLst/>
+          </a:prstGeom>
+          <a:solidFill>
+            <a:srgbClr val="121A2F"/>
+          </a:solidFill>
+          <a:ln w="19050">
+            <a:solidFill>
+              <a:srgbClr val="009B9E"/>
+            </a:solidFill>
+          </a:ln>
+        </p:spPr>
+        <p:style>
+          <a:lnRef idx="1">
+            <a:schemeClr val="accent1"/>
+          </a:lnRef>
+          <a:fillRef idx="3">
+            <a:schemeClr val="accent1"/>
+          </a:fillRef>
+          <a:effectRef idx="2">
+            <a:schemeClr val="accent1"/>
+          </a:effectRef>
+          <a:fontRef idx="minor">
+            <a:schemeClr val="lt1"/>
+          </a:fontRef>
+        </p:style>
+        <p:txBody>
+          <a:bodyPr rtlCol="0" anchor="ctr"/>
+          <a:lstStyle/>
+          <a:p>
+            <a:pPr algn="ctr"/>
+          </a:p>
+        </p:txBody>
+      </p:sp>
+      <p:sp>
+        <p:nvSpPr>
+          <p:cNvPr id="10" name="TextBox 9"/>
+          <p:cNvSpPr txBox="1"/>
+          <p:nvPr/>
+        </p:nvSpPr>
+        <p:spPr>
+          <a:xfrm>
+            <a:off x="4572000" y="1783080"/>
+            <a:ext cx="2926080" cy="1737360"/>
+          </a:xfrm>
+          <a:prstGeom prst="rect">
+            <a:avLst/>
+          </a:prstGeom>
+          <a:noFill/>
+        </p:spPr>
+        <p:txBody>
+          <a:bodyPr wrap="square">
+            <a:spAutoFit/>
+          </a:bodyPr>
+          <a:lstStyle/>
+          <a:p>
+            <a:pPr algn="ctr">
+              <a:defRPr sz="4800" b="1">
+                <a:solidFill>
+                  <a:srgbClr val="D4AF37"/>
+                </a:solidFill>
+                <a:latin typeface="Georgia"/>
+              </a:defRPr>
+            </a:pPr>
+            <a:r>
+              <a:t>$120</a:t>
+            </a:r>
+          </a:p>
+          <a:p>
+            <a:pPr algn="ctr">
+              <a:spcBef>
+                <a:spcPts val="500"/>
+              </a:spcBef>
+              <a:defRPr sz="1300" b="1">
+                <a:solidFill>
+                  <a:srgbClr val="FFFFFF"/>
+                </a:solidFill>
+                <a:latin typeface="Segoe UI"/>
+              </a:defRPr>
+            </a:pPr>
+            <a:r>
+              <a:t>O'rtacha Buyurtma Narxi</a:t>
+            </a:r>
+          </a:p>
+          <a:p>
+            <a:pPr algn="ctr">
+              <a:spcBef>
+                <a:spcPts val="500"/>
+              </a:spcBef>
+              <a:defRPr sz="1000">
+                <a:solidFill>
+                  <a:srgbClr val="94A3B8"/>
+                </a:solidFill>
+                <a:latin typeface="Segoe UI"/>
+              </a:defRPr>
+            </a:pPr>
+            <a:r>
+              <a:t>1 sayohat davomida bitta sayyoh tomonidan transport va gidlar uchun qilinadigan xarajat.</a:t>
+            </a:r>
+          </a:p>
+        </p:txBody>
+      </p:sp>
+      <p:sp>
+        <p:nvSpPr>
+          <p:cNvPr id="11" name="Rounded Rectangle 10"/>
+          <p:cNvSpPr/>
+          <p:nvPr/>
+        </p:nvSpPr>
+        <p:spPr>
+          <a:xfrm>
+            <a:off x="8046720" y="1645920"/>
+            <a:ext cx="3291840" cy="2011680"/>
+          </a:xfrm>
+          <a:prstGeom prst="roundRect">
+            <a:avLst/>
+          </a:prstGeom>
+          <a:solidFill>
+            <a:srgbClr val="121A2F"/>
+          </a:solidFill>
+          <a:ln w="19050">
+            <a:solidFill>
+              <a:srgbClr val="009B9E"/>
+            </a:solidFill>
+          </a:ln>
+        </p:spPr>
+        <p:style>
+          <a:lnRef idx="1">
+            <a:schemeClr val="accent1"/>
+          </a:lnRef>
+          <a:fillRef idx="3">
+            <a:schemeClr val="accent1"/>
+          </a:fillRef>
+          <a:effectRef idx="2">
+            <a:schemeClr val="accent1"/>
+          </a:effectRef>
+          <a:fontRef idx="minor">
+            <a:schemeClr val="lt1"/>
+          </a:fontRef>
+        </p:style>
+        <p:txBody>
+          <a:bodyPr rtlCol="0" anchor="ctr"/>
+          <a:lstStyle/>
+          <a:p>
+            <a:pPr algn="ctr"/>
+          </a:p>
+        </p:txBody>
+      </p:sp>
+      <p:sp>
+        <p:nvSpPr>
+          <p:cNvPr id="12" name="TextBox 11"/>
+          <p:cNvSpPr txBox="1"/>
+          <p:nvPr/>
+        </p:nvSpPr>
+        <p:spPr>
+          <a:xfrm>
+            <a:off x="8229600" y="1783080"/>
+            <a:ext cx="2926080" cy="1737360"/>
+          </a:xfrm>
+          <a:prstGeom prst="rect">
+            <a:avLst/>
+          </a:prstGeom>
+          <a:noFill/>
+        </p:spPr>
+        <p:txBody>
+          <a:bodyPr wrap="square">
+            <a:spAutoFit/>
+          </a:bodyPr>
+          <a:lstStyle/>
+          <a:p>
+            <a:pPr algn="ctr">
+              <a:defRPr sz="4800" b="1">
+                <a:solidFill>
+                  <a:srgbClr val="D4AF37"/>
+                </a:solidFill>
+                <a:latin typeface="Georgia"/>
+              </a:defRPr>
+            </a:pPr>
+            <a:r>
+              <a:t>$18</a:t>
+            </a:r>
+          </a:p>
+          <a:p>
+            <a:pPr algn="ctr">
+              <a:spcBef>
+                <a:spcPts val="500"/>
+              </a:spcBef>
+              <a:defRPr sz="1300" b="1">
+                <a:solidFill>
+                  <a:srgbClr val="FFFFFF"/>
+                </a:solidFill>
+                <a:latin typeface="Segoe UI"/>
+              </a:defRPr>
+            </a:pPr>
+            <a:r>
+              <a:t>Mijozdan Olinadigan Sof Foyda</a:t>
+            </a:r>
+          </a:p>
+          <a:p>
+            <a:pPr algn="ctr">
+              <a:spcBef>
+                <a:spcPts val="500"/>
+              </a:spcBef>
+              <a:defRPr sz="1000">
+                <a:solidFill>
+                  <a:srgbClr val="94A3B8"/>
+                </a:solidFill>
+                <a:latin typeface="Segoe UI"/>
+              </a:defRPr>
+            </a:pPr>
+            <a:r>
+              <a:t>Har bir jalb etilgan sayyohdan komissiya hisobiga platformaga tushadigan o'rtacha foyda.</a:t>
+            </a:r>
+          </a:p>
+        </p:txBody>
+      </p:sp>
+      <p:sp>
+        <p:nvSpPr>
+          <p:cNvPr id="13" name="Rounded Rectangle 12"/>
+          <p:cNvSpPr/>
+          <p:nvPr/>
+        </p:nvSpPr>
+        <p:spPr>
+          <a:xfrm>
+            <a:off x="731520" y="3931920"/>
+            <a:ext cx="10728655" cy="1828800"/>
           </a:xfrm>
           <a:prstGeom prst="roundRect">
             <a:avLst/>
@@ -5920,14 +7460,14 @@
       </p:sp>
       <p:sp>
         <p:nvSpPr>
-          <p:cNvPr id="8" name="TextBox 7"/>
+          <p:cNvPr id="14" name="TextBox 13"/>
           <p:cNvSpPr txBox="1"/>
           <p:nvPr/>
         </p:nvSpPr>
         <p:spPr>
           <a:xfrm>
-            <a:off x="914400" y="1828800"/>
-            <a:ext cx="2926080" cy="3749040"/>
+            <a:off x="1005840" y="4114800"/>
+            <a:ext cx="10180015" cy="1463040"/>
           </a:xfrm>
           <a:prstGeom prst="rect">
             <a:avLst/>
@@ -5942,7 +7482,7 @@
           <a:p>
             <a:pPr>
               <a:spcAft>
-                <a:spcPts val="1000"/>
+                <a:spcPts val="600"/>
               </a:spcAft>
               <a:defRPr sz="1800" b="1">
                 <a:solidFill>
@@ -5952,367 +7492,20 @@
               </a:defRPr>
             </a:pPr>
             <a:r>
-              <a:t>Platforma Komissiyasi</a:t>
-            </a:r>
-          </a:p>
-          <a:p>
-            <a:pPr>
-              <a:spcAft>
-                <a:spcPts val="1000"/>
-              </a:spcAft>
-              <a:defRPr sz="2200" b="1">
-                <a:solidFill>
-                  <a:srgbClr val="009B9E"/>
-                </a:solidFill>
-                <a:latin typeface="Georgia"/>
-              </a:defRPr>
-            </a:pPr>
-            <a:r>
-              <a:t>15%</a:t>
-            </a:r>
-          </a:p>
-          <a:p>
-            <a:pPr>
-              <a:spcAft>
-                <a:spcPts val="1500"/>
-              </a:spcAft>
+              <a:t>🎯 Past CAC (Mijozni jalb qilish narxi) va Yuqori ROI</a:t>
+            </a:r>
+          </a:p>
+          <a:p>
+            <a:pPr>
               <a:defRPr sz="1200">
                 <a:solidFill>
-                  <a:srgbClr val="FFFFFF"/>
+                  <a:srgbClr val="94A3B8"/>
                 </a:solidFill>
                 <a:latin typeface="Segoe UI"/>
               </a:defRPr>
             </a:pPr>
             <a:r>
-              <a:t>Platforma orqali band qilingan har bir transport va gid xizmati uchun komissiya to'lovi.</a:t>
-            </a:r>
-          </a:p>
-          <a:p>
-            <a:pPr>
-              <a:spcAft>
-                <a:spcPts val="500"/>
-              </a:spcAft>
-              <a:defRPr sz="1100">
-                <a:solidFill>
-                  <a:srgbClr val="94A3B8"/>
-                </a:solidFill>
-                <a:latin typeface="Segoe UI"/>
-              </a:defRPr>
-            </a:pPr>
-            <a:r>
-              <a:t>• Haydovchilar shahar va tog' tariflaridan 15% ulush.</a:t>
-            </a:r>
-          </a:p>
-          <a:p>
-            <a:pPr>
-              <a:spcAft>
-                <a:spcPts val="500"/>
-              </a:spcAft>
-              <a:defRPr sz="1100">
-                <a:solidFill>
-                  <a:srgbClr val="94A3B8"/>
-                </a:solidFill>
-                <a:latin typeface="Segoe UI"/>
-              </a:defRPr>
-            </a:pPr>
-            <a:r>
-              <a:t>• Gidlar kunlik til tariflaridan 15% platforma ulushi.</a:t>
-            </a:r>
-          </a:p>
-        </p:txBody>
-      </p:sp>
-      <p:sp>
-        <p:nvSpPr>
-          <p:cNvPr id="9" name="Rounded Rectangle 8"/>
-          <p:cNvSpPr/>
-          <p:nvPr/>
-        </p:nvSpPr>
-        <p:spPr>
-          <a:xfrm>
-            <a:off x="4389120" y="1645920"/>
-            <a:ext cx="3291840" cy="4114800"/>
-          </a:xfrm>
-          <a:prstGeom prst="roundRect">
-            <a:avLst/>
-          </a:prstGeom>
-          <a:solidFill>
-            <a:srgbClr val="121A2F"/>
-          </a:solidFill>
-          <a:ln w="19050">
-            <a:solidFill>
-              <a:srgbClr val="D4AF37"/>
-            </a:solidFill>
-          </a:ln>
-        </p:spPr>
-        <p:style>
-          <a:lnRef idx="1">
-            <a:schemeClr val="accent1"/>
-          </a:lnRef>
-          <a:fillRef idx="3">
-            <a:schemeClr val="accent1"/>
-          </a:fillRef>
-          <a:effectRef idx="2">
-            <a:schemeClr val="accent1"/>
-          </a:effectRef>
-          <a:fontRef idx="minor">
-            <a:schemeClr val="lt1"/>
-          </a:fontRef>
-        </p:style>
-        <p:txBody>
-          <a:bodyPr rtlCol="0" anchor="ctr"/>
-          <a:lstStyle/>
-          <a:p>
-            <a:pPr algn="ctr"/>
-          </a:p>
-        </p:txBody>
-      </p:sp>
-      <p:sp>
-        <p:nvSpPr>
-          <p:cNvPr id="10" name="TextBox 9"/>
-          <p:cNvSpPr txBox="1"/>
-          <p:nvPr/>
-        </p:nvSpPr>
-        <p:spPr>
-          <a:xfrm>
-            <a:off x="4572000" y="1828800"/>
-            <a:ext cx="2926080" cy="3749040"/>
-          </a:xfrm>
-          <a:prstGeom prst="rect">
-            <a:avLst/>
-          </a:prstGeom>
-          <a:noFill/>
-        </p:spPr>
-        <p:txBody>
-          <a:bodyPr wrap="square">
-            <a:spAutoFit/>
-          </a:bodyPr>
-          <a:lstStyle/>
-          <a:p>
-            <a:pPr>
-              <a:spcAft>
-                <a:spcPts val="1000"/>
-              </a:spcAft>
-              <a:defRPr sz="1800" b="1">
-                <a:solidFill>
-                  <a:srgbClr val="D4AF37"/>
-                </a:solidFill>
-                <a:latin typeface="Georgia"/>
-              </a:defRPr>
-            </a:pPr>
-            <a:r>
-              <a:t>B2B Hamkorlik shartnomalari</a:t>
-            </a:r>
-          </a:p>
-          <a:p>
-            <a:pPr>
-              <a:spcAft>
-                <a:spcPts val="1000"/>
-              </a:spcAft>
-              <a:defRPr sz="2200" b="1">
-                <a:solidFill>
-                  <a:srgbClr val="009B9E"/>
-                </a:solidFill>
-                <a:latin typeface="Georgia"/>
-              </a:defRPr>
-            </a:pPr>
-            <a:r>
-              <a:t>Keshbek &amp; Reklama</a:t>
-            </a:r>
-          </a:p>
-          <a:p>
-            <a:pPr>
-              <a:spcAft>
-                <a:spcPts val="1500"/>
-              </a:spcAft>
-              <a:defRPr sz="1200">
-                <a:solidFill>
-                  <a:srgbClr val="FFFFFF"/>
-                </a:solidFill>
-                <a:latin typeface="Segoe UI"/>
-              </a:defRPr>
-            </a:pPr>
-            <a:r>
-              <a:t>Tashrif buyuriladigan gastronomik va hunarmandchilik nuqtalaridan olinadigan komissiya to'lovlari.</a:t>
-            </a:r>
-          </a:p>
-          <a:p>
-            <a:pPr>
-              <a:spcAft>
-                <a:spcPts val="500"/>
-              </a:spcAft>
-              <a:defRPr sz="1100">
-                <a:solidFill>
-                  <a:srgbClr val="94A3B8"/>
-                </a:solidFill>
-                <a:latin typeface="Segoe UI"/>
-              </a:defRPr>
-            </a:pPr>
-            <a:r>
-              <a:t>• Konigil eco-village, Karimbek restorani va Milliy palov markazlari integratsiyasi.</a:t>
-            </a:r>
-          </a:p>
-          <a:p>
-            <a:pPr>
-              <a:spcAft>
-                <a:spcPts val="500"/>
-              </a:spcAft>
-              <a:defRPr sz="1100">
-                <a:solidFill>
-                  <a:srgbClr val="94A3B8"/>
-                </a:solidFill>
-                <a:latin typeface="Segoe UI"/>
-              </a:defRPr>
-            </a:pPr>
-            <a:r>
-              <a:t>• Kopaytirilgan mijozlar oqimidan belgilangan ulush.</a:t>
-            </a:r>
-          </a:p>
-        </p:txBody>
-      </p:sp>
-      <p:sp>
-        <p:nvSpPr>
-          <p:cNvPr id="11" name="Rounded Rectangle 10"/>
-          <p:cNvSpPr/>
-          <p:nvPr/>
-        </p:nvSpPr>
-        <p:spPr>
-          <a:xfrm>
-            <a:off x="8046720" y="1645920"/>
-            <a:ext cx="3291840" cy="4114800"/>
-          </a:xfrm>
-          <a:prstGeom prst="roundRect">
-            <a:avLst/>
-          </a:prstGeom>
-          <a:solidFill>
-            <a:srgbClr val="121A2F"/>
-          </a:solidFill>
-          <a:ln w="19050">
-            <a:solidFill>
-              <a:srgbClr val="D4AF37"/>
-            </a:solidFill>
-          </a:ln>
-        </p:spPr>
-        <p:style>
-          <a:lnRef idx="1">
-            <a:schemeClr val="accent1"/>
-          </a:lnRef>
-          <a:fillRef idx="3">
-            <a:schemeClr val="accent1"/>
-          </a:fillRef>
-          <a:effectRef idx="2">
-            <a:schemeClr val="accent1"/>
-          </a:effectRef>
-          <a:fontRef idx="minor">
-            <a:schemeClr val="lt1"/>
-          </a:fontRef>
-        </p:style>
-        <p:txBody>
-          <a:bodyPr rtlCol="0" anchor="ctr"/>
-          <a:lstStyle/>
-          <a:p>
-            <a:pPr algn="ctr"/>
-          </a:p>
-        </p:txBody>
-      </p:sp>
-      <p:sp>
-        <p:nvSpPr>
-          <p:cNvPr id="12" name="TextBox 11"/>
-          <p:cNvSpPr txBox="1"/>
-          <p:nvPr/>
-        </p:nvSpPr>
-        <p:spPr>
-          <a:xfrm>
-            <a:off x="8229600" y="1828800"/>
-            <a:ext cx="2926080" cy="3749040"/>
-          </a:xfrm>
-          <a:prstGeom prst="rect">
-            <a:avLst/>
-          </a:prstGeom>
-          <a:noFill/>
-        </p:spPr>
-        <p:txBody>
-          <a:bodyPr wrap="square">
-            <a:spAutoFit/>
-          </a:bodyPr>
-          <a:lstStyle/>
-          <a:p>
-            <a:pPr>
-              <a:spcAft>
-                <a:spcPts val="1000"/>
-              </a:spcAft>
-              <a:defRPr sz="1800" b="1">
-                <a:solidFill>
-                  <a:srgbClr val="D4AF37"/>
-                </a:solidFill>
-                <a:latin typeface="Georgia"/>
-              </a:defRPr>
-            </a:pPr>
-            <a:r>
-              <a:t>Kelajakdagi Integratsiyalar</a:t>
-            </a:r>
-          </a:p>
-          <a:p>
-            <a:pPr>
-              <a:spcAft>
-                <a:spcPts val="1000"/>
-              </a:spcAft>
-              <a:defRPr sz="2200" b="1">
-                <a:solidFill>
-                  <a:srgbClr val="009B9E"/>
-                </a:solidFill>
-                <a:latin typeface="Georgia"/>
-              </a:defRPr>
-            </a:pPr>
-            <a:r>
-              <a:t>Premium &amp; Sotuvlar</a:t>
-            </a:r>
-          </a:p>
-          <a:p>
-            <a:pPr>
-              <a:spcAft>
-                <a:spcPts val="1500"/>
-              </a:spcAft>
-              <a:defRPr sz="1200">
-                <a:solidFill>
-                  <a:srgbClr val="FFFFFF"/>
-                </a:solidFill>
-                <a:latin typeface="Segoe UI"/>
-              </a:defRPr>
-            </a:pPr>
-            <a:r>
-              <a:t>Platformani kengaytirish orqali chiptalar va tayyor turlarni sotish imkoniyati.</a:t>
-            </a:r>
-          </a:p>
-          <a:p>
-            <a:pPr>
-              <a:spcAft>
-                <a:spcPts val="500"/>
-              </a:spcAft>
-              <a:defRPr sz="1100">
-                <a:solidFill>
-                  <a:srgbClr val="94A3B8"/>
-                </a:solidFill>
-                <a:latin typeface="Segoe UI"/>
-              </a:defRPr>
-            </a:pPr>
-            <a:r>
-              <a:t>• Afrosiyob tezurar poyezdi va tarixiy obidalar chiptalarini ilova ichida sotish.</a:t>
-            </a:r>
-          </a:p>
-          <a:p>
-            <a:pPr>
-              <a:spcAft>
-                <a:spcPts val="500"/>
-              </a:spcAft>
-              <a:defRPr sz="1100">
-                <a:solidFill>
-                  <a:srgbClr val="94A3B8"/>
-                </a:solidFill>
-                <a:latin typeface="Segoe UI"/>
-              </a:defRPr>
-            </a:pPr>
-            <a:r>
-              <a:t>• Tayyor premium yo'nalishli turlar konstruktori.</a:t>
+              <a:t>Bizning marketing modelimiz bevosita mehmonxonalar, QR-kod integratsiyalari va organik qidiruvga asoslangan. Shu sababli mijozni jalb qilish tannarxi (CAC) o'rtacha $2-$3 ni tashkil etadi. Bu esa har bir buyurtmadan kamida 6 barobar sof daromad (ROI) olishni ta'minlaydi.</a:t>
             </a:r>
           </a:p>
         </p:txBody>
@@ -6441,7 +7634,7 @@
               </a:defRPr>
             </a:pPr>
             <a:r>
-              <a:t>SAMARQAND CRAFTOUR  |  INVESTITSIYA TAQDIMOTI 2026</a:t>
+              <a:t>UZBEK-TRIP (SAMARQAND CRAFTOUR)  |  HAMKORLIK TAQDIMOTI 2026</a:t>
             </a:r>
           </a:p>
         </p:txBody>
@@ -6493,7 +7686,7 @@
           <a:lstStyle/>
           <a:p>
             <a:pPr>
-              <a:defRPr sz="3400" b="1">
+              <a:defRPr sz="3000" b="1">
                 <a:solidFill>
                   <a:srgbClr val="D4AF37"/>
                 </a:solidFill>
@@ -6501,7 +7694,7 @@
               </a:defRPr>
             </a:pPr>
             <a:r>
-              <a:t>TEXNOLOGIK STACK VA AVTOMATIZATSIYA (N8N)</a:t>
+              <a:t>MOLIYAVIY PROYEKSIYALAR VA KO'RSATKICHLAR</a:t>
             </a:r>
           </a:p>
         </p:txBody>
@@ -6515,7 +7708,7 @@
         <p:spPr>
           <a:xfrm>
             <a:off x="731520" y="1645920"/>
-            <a:ext cx="5120640" cy="4114800"/>
+            <a:ext cx="3291840" cy="4114800"/>
           </a:xfrm>
           <a:prstGeom prst="roundRect">
             <a:avLst/>
@@ -6559,8 +7752,8 @@
         </p:nvSpPr>
         <p:spPr>
           <a:xfrm>
-            <a:off x="1005840" y="1920240"/>
-            <a:ext cx="4572000" cy="3566160"/>
+            <a:off x="914400" y="1828800"/>
+            <a:ext cx="2926080" cy="3749040"/>
           </a:xfrm>
           <a:prstGeom prst="rect">
             <a:avLst/>
@@ -6575,9 +7768,9 @@
           <a:p>
             <a:pPr>
               <a:spcAft>
-                <a:spcPts val="1500"/>
+                <a:spcPts val="1000"/>
               </a:spcAft>
-              <a:defRPr sz="2000" b="1">
+              <a:defRPr sz="1800" b="1">
                 <a:solidFill>
                   <a:srgbClr val="D4AF37"/>
                 </a:solidFill>
@@ -6585,7 +7778,7 @@
               </a:defRPr>
             </a:pPr>
             <a:r>
-              <a:t>💻 Platforma Arxitekturasi</a:t>
+              <a:t>2026-yil (Samarqand)</a:t>
             </a:r>
           </a:p>
           <a:p>
@@ -6593,7 +7786,23 @@
               <a:spcAft>
                 <a:spcPts val="1000"/>
               </a:spcAft>
-              <a:defRPr sz="1200" b="1">
+              <a:defRPr sz="2200" b="1">
+                <a:solidFill>
+                  <a:srgbClr val="009B9E"/>
+                </a:solidFill>
+                <a:latin typeface="Georgia"/>
+              </a:defRPr>
+            </a:pPr>
+            <a:r>
+              <a:t>$150,000</a:t>
+            </a:r>
+          </a:p>
+          <a:p>
+            <a:pPr>
+              <a:spcAft>
+                <a:spcPts val="1500"/>
+              </a:spcAft>
+              <a:defRPr sz="1200">
                 <a:solidFill>
                   <a:srgbClr val="FFFFFF"/>
                 </a:solidFill>
@@ -6601,87 +7810,39 @@
               </a:defRPr>
             </a:pPr>
             <a:r>
-              <a:t>Next.js 16 (App Router): </a:t>
-            </a:r>
-            <a:r>
-              <a:rPr b="0">
+              <a:t>Samarqand shahrida loyihani to'liq yo'lga qo'yish va 10,000 dan ortiq turlarni muvaffaqiyatli band qilish.</a:t>
+            </a:r>
+          </a:p>
+          <a:p>
+            <a:pPr>
+              <a:spcAft>
+                <a:spcPts val="500"/>
+              </a:spcAft>
+              <a:defRPr sz="1100">
                 <a:solidFill>
                   <a:srgbClr val="94A3B8"/>
                 </a:solidFill>
-              </a:rPr>
-              <a:t>Tezkor yuklanish, SEO optimallashtirish va xavfsiz Server Component'lar.</a:t>
+                <a:latin typeface="Segoe UI"/>
+              </a:defRPr>
+            </a:pPr>
+            <a:r>
+              <a:t>• 150+ gid va haydovchilar tarmog'i.</a:t>
             </a:r>
           </a:p>
           <a:p>
             <a:pPr>
               <a:spcAft>
-                <a:spcPts val="1000"/>
+                <a:spcPts val="500"/>
               </a:spcAft>
-              <a:defRPr sz="1200" b="1">
-                <a:solidFill>
-                  <a:srgbClr val="FFFFFF"/>
+              <a:defRPr sz="1100">
+                <a:solidFill>
+                  <a:srgbClr val="94A3B8"/>
                 </a:solidFill>
                 <a:latin typeface="Segoe UI"/>
               </a:defRPr>
             </a:pPr>
             <a:r>
-              <a:t>Supabase (PostgreSQL &amp; Auth): </a:t>
-            </a:r>
-            <a:r>
-              <a:rPr b="0">
-                <a:solidFill>
-                  <a:srgbClr val="94A3B8"/>
-                </a:solidFill>
-              </a:rPr>
-              <a:t>Sayyohlar ma'lumotlari, real vaqt rejimidagi gid va haydovchilar bazasi.</a:t>
-            </a:r>
-          </a:p>
-          <a:p>
-            <a:pPr>
-              <a:spcAft>
-                <a:spcPts val="1000"/>
-              </a:spcAft>
-              <a:defRPr sz="1200" b="1">
-                <a:solidFill>
-                  <a:srgbClr val="FFFFFF"/>
-                </a:solidFill>
-                <a:latin typeface="Segoe UI"/>
-              </a:defRPr>
-            </a:pPr>
-            <a:r>
-              <a:t>Leaflet.js Interactive Maps: </a:t>
-            </a:r>
-            <a:r>
-              <a:rPr b="0">
-                <a:solidFill>
-                  <a:srgbClr val="94A3B8"/>
-                </a:solidFill>
-              </a:rPr>
-              <a:t>Hech qanday og'ir Google Maps to'lovlarisiz sayyohning marshrutini xaritada tekin chizish.</a:t>
-            </a:r>
-          </a:p>
-          <a:p>
-            <a:pPr>
-              <a:spcAft>
-                <a:spcPts val="1000"/>
-              </a:spcAft>
-              <a:defRPr sz="1200" b="1">
-                <a:solidFill>
-                  <a:srgbClr val="FFFFFF"/>
-                </a:solidFill>
-                <a:latin typeface="Segoe UI"/>
-              </a:defRPr>
-            </a:pPr>
-            <a:r>
-              <a:t>Nodemailer Email System: </a:t>
-            </a:r>
-            <a:r>
-              <a:rPr b="0">
-                <a:solidFill>
-                  <a:srgbClr val="94A3B8"/>
-                </a:solidFill>
-              </a:rPr>
-              <a:t>Tasdiqlash OTP kodlarini va yakuniy vaucherni mijozga yuborish tizimi.</a:t>
+              <a:t>• O'rtacha aylanma: $1.2 Million.</a:t>
             </a:r>
           </a:p>
         </p:txBody>
@@ -6694,8 +7855,8 @@
         </p:nvSpPr>
         <p:spPr>
           <a:xfrm>
-            <a:off x="6217920" y="1645920"/>
-            <a:ext cx="5120640" cy="4114800"/>
+            <a:off x="4389120" y="1645920"/>
+            <a:ext cx="3291840" cy="4114800"/>
           </a:xfrm>
           <a:prstGeom prst="roundRect">
             <a:avLst/>
@@ -6739,8 +7900,8 @@
         </p:nvSpPr>
         <p:spPr>
           <a:xfrm>
-            <a:off x="6492240" y="1920240"/>
-            <a:ext cx="4572000" cy="3566160"/>
+            <a:off x="4572000" y="1828800"/>
+            <a:ext cx="2926080" cy="3749040"/>
           </a:xfrm>
           <a:prstGeom prst="rect">
             <a:avLst/>
@@ -6755,9 +7916,9 @@
           <a:p>
             <a:pPr>
               <a:spcAft>
-                <a:spcPts val="1500"/>
+                <a:spcPts val="1000"/>
               </a:spcAft>
-              <a:defRPr sz="2000" b="1">
+              <a:defRPr sz="1800" b="1">
                 <a:solidFill>
                   <a:srgbClr val="D4AF37"/>
                 </a:solidFill>
@@ -6765,7 +7926,7 @@
               </a:defRPr>
             </a:pPr>
             <a:r>
-              <a:t>⚡ n8n va WhatsApp Avtomatizatsiyasi</a:t>
+              <a:t>2027-yil (Kengayish)</a:t>
             </a:r>
           </a:p>
           <a:p>
@@ -6773,47 +7934,147 @@
               <a:spcAft>
                 <a:spcPts val="1000"/>
               </a:spcAft>
-              <a:defRPr sz="1200" b="1">
+              <a:defRPr sz="2200" b="1">
                 <a:solidFill>
                   <a:srgbClr val="009B9E"/>
                 </a:solidFill>
+                <a:latin typeface="Georgia"/>
+              </a:defRPr>
+            </a:pPr>
+            <a:r>
+              <a:t>$600,000</a:t>
+            </a:r>
+          </a:p>
+          <a:p>
+            <a:pPr>
+              <a:spcAft>
+                <a:spcPts val="1500"/>
+              </a:spcAft>
+              <a:defRPr sz="1200">
+                <a:solidFill>
+                  <a:srgbClr val="FFFFFF"/>
+                </a:solidFill>
                 <a:latin typeface="Segoe UI"/>
               </a:defRPr>
             </a:pPr>
             <a:r>
-              <a:t>• n8n workflow integratsiyasi — </a:t>
-            </a:r>
-            <a:r>
-              <a:rPr b="0">
+              <a:t>Toshkent, Buxoro, Xiva va Qoraqalpog'iston shaharlarini integratsiya qilish hamda turlarni ko'paytirish.</a:t>
+            </a:r>
+          </a:p>
+          <a:p>
+            <a:pPr>
+              <a:spcAft>
+                <a:spcPts val="500"/>
+              </a:spcAft>
+              <a:defRPr sz="1100">
                 <a:solidFill>
                   <a:srgbClr val="94A3B8"/>
                 </a:solidFill>
-              </a:rPr>
-              <a:t>Buyurtmalar boshqaruvi va monitoringi n8n platformasiga ulangan.</a:t>
-            </a:r>
-          </a:p>
+                <a:latin typeface="Segoe UI"/>
+              </a:defRPr>
+            </a:pPr>
+            <a:r>
+              <a:t>• 600+ gid va haydovchilar tarmog'i.</a:t>
+            </a:r>
+          </a:p>
+          <a:p>
+            <a:pPr>
+              <a:spcAft>
+                <a:spcPts val="500"/>
+              </a:spcAft>
+              <a:defRPr sz="1100">
+                <a:solidFill>
+                  <a:srgbClr val="94A3B8"/>
+                </a:solidFill>
+                <a:latin typeface="Segoe UI"/>
+              </a:defRPr>
+            </a:pPr>
+            <a:r>
+              <a:t>• B2B va mehmonxonalar bilan hamkorlik.</a:t>
+            </a:r>
+          </a:p>
+        </p:txBody>
+      </p:sp>
+      <p:sp>
+        <p:nvSpPr>
+          <p:cNvPr id="11" name="Rounded Rectangle 10"/>
+          <p:cNvSpPr/>
+          <p:nvPr/>
+        </p:nvSpPr>
+        <p:spPr>
+          <a:xfrm>
+            <a:off x="8046720" y="1645920"/>
+            <a:ext cx="3291840" cy="4114800"/>
+          </a:xfrm>
+          <a:prstGeom prst="roundRect">
+            <a:avLst/>
+          </a:prstGeom>
+          <a:solidFill>
+            <a:srgbClr val="121A2F"/>
+          </a:solidFill>
+          <a:ln w="19050">
+            <a:solidFill>
+              <a:srgbClr val="D4AF37"/>
+            </a:solidFill>
+          </a:ln>
+        </p:spPr>
+        <p:style>
+          <a:lnRef idx="1">
+            <a:schemeClr val="accent1"/>
+          </a:lnRef>
+          <a:fillRef idx="3">
+            <a:schemeClr val="accent1"/>
+          </a:fillRef>
+          <a:effectRef idx="2">
+            <a:schemeClr val="accent1"/>
+          </a:effectRef>
+          <a:fontRef idx="minor">
+            <a:schemeClr val="lt1"/>
+          </a:fontRef>
+        </p:style>
+        <p:txBody>
+          <a:bodyPr rtlCol="0" anchor="ctr"/>
+          <a:lstStyle/>
+          <a:p>
+            <a:pPr algn="ctr"/>
+          </a:p>
+        </p:txBody>
+      </p:sp>
+      <p:sp>
+        <p:nvSpPr>
+          <p:cNvPr id="12" name="TextBox 11"/>
+          <p:cNvSpPr txBox="1"/>
+          <p:nvPr/>
+        </p:nvSpPr>
+        <p:spPr>
+          <a:xfrm>
+            <a:off x="8229600" y="1828800"/>
+            <a:ext cx="2926080" cy="3749040"/>
+          </a:xfrm>
+          <a:prstGeom prst="rect">
+            <a:avLst/>
+          </a:prstGeom>
+          <a:noFill/>
+        </p:spPr>
+        <p:txBody>
+          <a:bodyPr wrap="square">
+            <a:spAutoFit/>
+          </a:bodyPr>
+          <a:lstStyle/>
           <a:p>
             <a:pPr>
               <a:spcAft>
                 <a:spcPts val="1000"/>
               </a:spcAft>
-              <a:defRPr sz="1200" b="1">
-                <a:solidFill>
-                  <a:srgbClr val="009B9E"/>
-                </a:solidFill>
-                <a:latin typeface="Segoe UI"/>
-              </a:defRPr>
-            </a:pPr>
-            <a:r>
-              <a:t>• Avtomatik xabar yetkazish — </a:t>
-            </a:r>
-            <a:r>
-              <a:rPr b="0">
-                <a:solidFill>
-                  <a:srgbClr val="94A3B8"/>
-                </a:solidFill>
-              </a:rPr>
-              <a:t>Sayyoh buyurtmani tasdiqlagach, haydovchi va gidning WhatsApp / Telegramiga darhol xabar ketadi.</a:t>
+              <a:defRPr sz="1800" b="1">
+                <a:solidFill>
+                  <a:srgbClr val="D4AF37"/>
+                </a:solidFill>
+                <a:latin typeface="Georgia"/>
+              </a:defRPr>
+            </a:pPr>
+            <a:r>
+              <a:t>2028-yil (Milliy Lider)</a:t>
             </a:r>
           </a:p>
           <a:p>
@@ -6821,47 +8082,63 @@
               <a:spcAft>
                 <a:spcPts val="1000"/>
               </a:spcAft>
-              <a:defRPr sz="1200" b="1">
+              <a:defRPr sz="2200" b="1">
                 <a:solidFill>
                   <a:srgbClr val="009B9E"/>
                 </a:solidFill>
+                <a:latin typeface="Georgia"/>
+              </a:defRPr>
+            </a:pPr>
+            <a:r>
+              <a:t>$1,800,000</a:t>
+            </a:r>
+          </a:p>
+          <a:p>
+            <a:pPr>
+              <a:spcAft>
+                <a:spcPts val="1500"/>
+              </a:spcAft>
+              <a:defRPr sz="1200">
+                <a:solidFill>
+                  <a:srgbClr val="FFFFFF"/>
+                </a:solidFill>
                 <a:latin typeface="Segoe UI"/>
               </a:defRPr>
             </a:pPr>
             <a:r>
-              <a:t>• Marshrut va aloqa ma'lumotlari — </a:t>
-            </a:r>
-            <a:r>
-              <a:rPr b="0">
+              <a:t>O'zbekistondagi eng yirik mustaqil shaxsiy sayohat konstruktoriga aylanish va super-app integratsiyasi.</a:t>
+            </a:r>
+          </a:p>
+          <a:p>
+            <a:pPr>
+              <a:spcAft>
+                <a:spcPts val="500"/>
+              </a:spcAft>
+              <a:defRPr sz="1100">
                 <a:solidFill>
                   <a:srgbClr val="94A3B8"/>
                 </a:solidFill>
-              </a:rPr>
-              <a:t>Xabarda sayyohning to'liq marshruti, poyezd/samolyot kelish vaqti va telefon raqami avtomatik taqdim etiladi.</a:t>
+                <a:latin typeface="Segoe UI"/>
+              </a:defRPr>
+            </a:pPr>
+            <a:r>
+              <a:t>• 2,000+ hamkorlar tarmog'i.</a:t>
             </a:r>
           </a:p>
           <a:p>
             <a:pPr>
               <a:spcAft>
-                <a:spcPts val="1000"/>
+                <a:spcPts val="500"/>
               </a:spcAft>
-              <a:defRPr sz="1200" b="1">
-                <a:solidFill>
-                  <a:srgbClr val="009B9E"/>
+              <a:defRPr sz="1100">
+                <a:solidFill>
+                  <a:srgbClr val="94A3B8"/>
                 </a:solidFill>
                 <a:latin typeface="Segoe UI"/>
               </a:defRPr>
             </a:pPr>
             <a:r>
-              <a:t>• Operatsion xarajatlarni 90% kamaytirish — </a:t>
-            </a:r>
-            <a:r>
-              <a:rPr b="0">
-                <a:solidFill>
-                  <a:srgbClr val="94A3B8"/>
-                </a:solidFill>
-              </a:rPr>
-              <a:t>Menejerlarning qo'lda aloqa qilish vaqtini tejaydi, inson omilini kamaytiradi.</a:t>
+              <a:t>• Afrosiyob chiptalari va mehmonxona bron.</a:t>
             </a:r>
           </a:p>
         </p:txBody>
@@ -6990,7 +8267,7 @@
               </a:defRPr>
             </a:pPr>
             <a:r>
-              <a:t>SAMARQAND CRAFTOUR  |  INVESTITSIYA TAQDIMOTI 2026</a:t>
+              <a:t>UZBEK-TRIP (SAMARQAND CRAFTOUR)  |  HAMKORLIK TAQDIMOTI 2026</a:t>
             </a:r>
           </a:p>
         </p:txBody>
@@ -7042,7 +8319,7 @@
           <a:lstStyle/>
           <a:p>
             <a:pPr>
-              <a:defRPr sz="3400" b="1">
+              <a:defRPr sz="3000" b="1">
                 <a:solidFill>
                   <a:srgbClr val="D4AF37"/>
                 </a:solidFill>
@@ -7050,164 +8327,21 @@
               </a:defRPr>
             </a:pPr>
             <a:r>
-              <a:t>KELAJAK REJALARI VA INVESTITSIYA</a:t>
-            </a:r>
-          </a:p>
-        </p:txBody>
-      </p:sp>
-      <p:sp>
-        <p:nvSpPr>
-          <p:cNvPr id="7" name="TextBox 6"/>
-          <p:cNvSpPr txBox="1"/>
+              <a:t>TEXNOLOGIK STACK VA AVTOMATIZATSIYA (N8N)</a:t>
+            </a:r>
+          </a:p>
+        </p:txBody>
+      </p:sp>
+      <p:sp>
+        <p:nvSpPr>
+          <p:cNvPr id="7" name="Rounded Rectangle 6"/>
+          <p:cNvSpPr/>
           <p:nvPr/>
         </p:nvSpPr>
         <p:spPr>
           <a:xfrm>
             <a:off x="731520" y="1645920"/>
-            <a:ext cx="4572000" cy="4114800"/>
-          </a:xfrm>
-          <a:prstGeom prst="rect">
-            <a:avLst/>
-          </a:prstGeom>
-          <a:noFill/>
-        </p:spPr>
-        <p:txBody>
-          <a:bodyPr wrap="square">
-            <a:spAutoFit/>
-          </a:bodyPr>
-          <a:lstStyle/>
-          <a:p>
-            <a:pPr>
-              <a:spcAft>
-                <a:spcPts val="1000"/>
-              </a:spcAft>
-              <a:defRPr sz="1400" b="1">
-                <a:solidFill>
-                  <a:srgbClr val="009B9E"/>
-                </a:solidFill>
-                <a:latin typeface="Segoe UI"/>
-              </a:defRPr>
-            </a:pPr>
-            <a:r>
-              <a:t>INVESTITSIYA MAQSADI</a:t>
-            </a:r>
-          </a:p>
-          <a:p>
-            <a:pPr>
-              <a:spcAft>
-                <a:spcPts val="1500"/>
-              </a:spcAft>
-              <a:defRPr sz="3600" b="1">
-                <a:solidFill>
-                  <a:srgbClr val="D4AF37"/>
-                </a:solidFill>
-                <a:latin typeface="Georgia"/>
-              </a:defRPr>
-            </a:pPr>
-            <a:r>
-              <a:t>$100,000 Seed Round</a:t>
-            </a:r>
-          </a:p>
-          <a:p>
-            <a:pPr>
-              <a:spcAft>
-                <a:spcPts val="1000"/>
-              </a:spcAft>
-              <a:defRPr sz="1300">
-                <a:solidFill>
-                  <a:srgbClr val="FFFFFF"/>
-                </a:solidFill>
-                <a:latin typeface="Segoe UI"/>
-              </a:defRPr>
-            </a:pPr>
-            <a:r>
-              <a:t>Ushbu investitsiya quyidagi strategik yo'nalishlarga sarflanadi:</a:t>
-            </a:r>
-          </a:p>
-          <a:p>
-            <a:pPr>
-              <a:spcAft>
-                <a:spcPts val="500"/>
-              </a:spcAft>
-              <a:defRPr sz="1200" b="1">
-                <a:solidFill>
-                  <a:srgbClr val="D4AF37"/>
-                </a:solidFill>
-                <a:latin typeface="Segoe UI"/>
-              </a:defRPr>
-            </a:pPr>
-            <a:r>
-              <a:t>✔ Ilova ishlab chiqish — </a:t>
-            </a:r>
-            <a:r>
-              <a:rPr b="0">
-                <a:solidFill>
-                  <a:srgbClr val="94A3B8"/>
-                </a:solidFill>
-              </a:rPr>
-              <a:t>iOS va Android uchun to'liq mobil ilovalarni tayyorlash.</a:t>
-            </a:r>
-          </a:p>
-          <a:p>
-            <a:pPr>
-              <a:spcAft>
-                <a:spcPts val="500"/>
-              </a:spcAft>
-              <a:defRPr sz="1200" b="1">
-                <a:solidFill>
-                  <a:srgbClr val="D4AF37"/>
-                </a:solidFill>
-                <a:latin typeface="Segoe UI"/>
-              </a:defRPr>
-            </a:pPr>
-            <a:r>
-              <a:t>✔ O'zbekiston bo'ylab kengayish — </a:t>
-            </a:r>
-            <a:r>
-              <a:rPr b="0">
-                <a:solidFill>
-                  <a:srgbClr val="94A3B8"/>
-                </a:solidFill>
-              </a:rPr>
-              <a:t>Buxoro, Xiva va Toshkent shaharlari gid va transport tarmoqlarini qo'shish.</a:t>
-            </a:r>
-          </a:p>
-          <a:p>
-            <a:pPr>
-              <a:spcAft>
-                <a:spcPts val="500"/>
-              </a:spcAft>
-              <a:defRPr sz="1200" b="1">
-                <a:solidFill>
-                  <a:srgbClr val="D4AF37"/>
-                </a:solidFill>
-                <a:latin typeface="Segoe UI"/>
-              </a:defRPr>
-            </a:pPr>
-            <a:r>
-              <a:t>✔ Marketing va brending — </a:t>
-            </a:r>
-            <a:r>
-              <a:rPr b="0">
-                <a:solidFill>
-                  <a:srgbClr val="94A3B8"/>
-                </a:solidFill>
-              </a:rPr>
-              <a:t>Yevropa, AQSh va Arab davlatlaridan kelayotgan sayyohlarga raqamli marketing orqali yetib borish.</a:t>
-            </a:r>
-          </a:p>
-        </p:txBody>
-      </p:sp>
-      <p:sp>
-        <p:nvSpPr>
-          <p:cNvPr id="8" name="Rounded Rectangle 7"/>
-          <p:cNvSpPr/>
-          <p:nvPr/>
-        </p:nvSpPr>
-        <p:spPr>
-          <a:xfrm>
-            <a:off x="5943600" y="1645920"/>
-            <a:ext cx="5486400" cy="4114800"/>
+            <a:ext cx="5120640" cy="4114800"/>
           </a:xfrm>
           <a:prstGeom prst="roundRect">
             <a:avLst/>
@@ -7245,14 +8379,14 @@
       </p:sp>
       <p:sp>
         <p:nvSpPr>
-          <p:cNvPr id="9" name="TextBox 8"/>
+          <p:cNvPr id="8" name="TextBox 7"/>
           <p:cNvSpPr txBox="1"/>
           <p:nvPr/>
         </p:nvSpPr>
         <p:spPr>
           <a:xfrm>
-            <a:off x="6309360" y="1920240"/>
-            <a:ext cx="4754880" cy="3566160"/>
+            <a:off x="1005840" y="1920240"/>
+            <a:ext cx="4572000" cy="3566160"/>
           </a:xfrm>
           <a:prstGeom prst="rect">
             <a:avLst/>
@@ -7277,7 +8411,723 @@
               </a:defRPr>
             </a:pPr>
             <a:r>
-              <a:t>🚀 Kutilayotgan Natijalar (2026-2027)</a:t>
+              <a:t>💻 Platforma Stacki</a:t>
+            </a:r>
+          </a:p>
+          <a:p>
+            <a:pPr>
+              <a:spcAft>
+                <a:spcPts val="1000"/>
+              </a:spcAft>
+              <a:defRPr sz="1200" b="1">
+                <a:solidFill>
+                  <a:srgbClr val="FFFFFF"/>
+                </a:solidFill>
+                <a:latin typeface="Segoe UI"/>
+              </a:defRPr>
+            </a:pPr>
+            <a:r>
+              <a:t>Next.js 16 (App Router): </a:t>
+            </a:r>
+            <a:r>
+              <a:rPr b="0">
+                <a:solidFill>
+                  <a:srgbClr val="94A3B8"/>
+                </a:solidFill>
+              </a:rPr>
+              <a:t>Tez yuklanish, SEO optimallik va yuqori xavfsizlik.</a:t>
+            </a:r>
+          </a:p>
+          <a:p>
+            <a:pPr>
+              <a:spcAft>
+                <a:spcPts val="1000"/>
+              </a:spcAft>
+              <a:defRPr sz="1200" b="1">
+                <a:solidFill>
+                  <a:srgbClr val="FFFFFF"/>
+                </a:solidFill>
+                <a:latin typeface="Segoe UI"/>
+              </a:defRPr>
+            </a:pPr>
+            <a:r>
+              <a:t>Supabase (PostgreSQL): </a:t>
+            </a:r>
+            <a:r>
+              <a:rPr b="0">
+                <a:solidFill>
+                  <a:srgbClr val="94A3B8"/>
+                </a:solidFill>
+              </a:rPr>
+              <a:t>Ma'lumotlar xavfsizligi va real vaqtdagi gid/transport bazasi.</a:t>
+            </a:r>
+          </a:p>
+          <a:p>
+            <a:pPr>
+              <a:spcAft>
+                <a:spcPts val="1000"/>
+              </a:spcAft>
+              <a:defRPr sz="1200" b="1">
+                <a:solidFill>
+                  <a:srgbClr val="FFFFFF"/>
+                </a:solidFill>
+                <a:latin typeface="Segoe UI"/>
+              </a:defRPr>
+            </a:pPr>
+            <a:r>
+              <a:t>Leaflet.js Maps: </a:t>
+            </a:r>
+            <a:r>
+              <a:rPr b="0">
+                <a:solidFill>
+                  <a:srgbClr val="94A3B8"/>
+                </a:solidFill>
+              </a:rPr>
+              <a:t>Bepul va ochiq kodli xarita tizimi (Google Maps uchun ortiqcha to'lov yo'q).</a:t>
+            </a:r>
+          </a:p>
+          <a:p>
+            <a:pPr>
+              <a:spcAft>
+                <a:spcPts val="1000"/>
+              </a:spcAft>
+              <a:defRPr sz="1200" b="1">
+                <a:solidFill>
+                  <a:srgbClr val="FFFFFF"/>
+                </a:solidFill>
+                <a:latin typeface="Segoe UI"/>
+              </a:defRPr>
+            </a:pPr>
+            <a:r>
+              <a:t>OTP Verification System: </a:t>
+            </a:r>
+            <a:r>
+              <a:rPr b="0">
+                <a:solidFill>
+                  <a:srgbClr val="94A3B8"/>
+                </a:solidFill>
+              </a:rPr>
+              <a:t>Aloqa xavfsizligi va buyurtmani vaucher ko'rinishida yuborish.</a:t>
+            </a:r>
+          </a:p>
+        </p:txBody>
+      </p:sp>
+      <p:sp>
+        <p:nvSpPr>
+          <p:cNvPr id="9" name="Rounded Rectangle 8"/>
+          <p:cNvSpPr/>
+          <p:nvPr/>
+        </p:nvSpPr>
+        <p:spPr>
+          <a:xfrm>
+            <a:off x="6217920" y="1645920"/>
+            <a:ext cx="5120640" cy="4114800"/>
+          </a:xfrm>
+          <a:prstGeom prst="roundRect">
+            <a:avLst/>
+          </a:prstGeom>
+          <a:solidFill>
+            <a:srgbClr val="121A2F"/>
+          </a:solidFill>
+          <a:ln w="19050">
+            <a:solidFill>
+              <a:srgbClr val="D4AF37"/>
+            </a:solidFill>
+          </a:ln>
+        </p:spPr>
+        <p:style>
+          <a:lnRef idx="1">
+            <a:schemeClr val="accent1"/>
+          </a:lnRef>
+          <a:fillRef idx="3">
+            <a:schemeClr val="accent1"/>
+          </a:fillRef>
+          <a:effectRef idx="2">
+            <a:schemeClr val="accent1"/>
+          </a:effectRef>
+          <a:fontRef idx="minor">
+            <a:schemeClr val="lt1"/>
+          </a:fontRef>
+        </p:style>
+        <p:txBody>
+          <a:bodyPr rtlCol="0" anchor="ctr"/>
+          <a:lstStyle/>
+          <a:p>
+            <a:pPr algn="ctr"/>
+          </a:p>
+        </p:txBody>
+      </p:sp>
+      <p:sp>
+        <p:nvSpPr>
+          <p:cNvPr id="10" name="TextBox 9"/>
+          <p:cNvSpPr txBox="1"/>
+          <p:nvPr/>
+        </p:nvSpPr>
+        <p:spPr>
+          <a:xfrm>
+            <a:off x="6492240" y="1920240"/>
+            <a:ext cx="4572000" cy="3566160"/>
+          </a:xfrm>
+          <a:prstGeom prst="rect">
+            <a:avLst/>
+          </a:prstGeom>
+          <a:noFill/>
+        </p:spPr>
+        <p:txBody>
+          <a:bodyPr wrap="square">
+            <a:spAutoFit/>
+          </a:bodyPr>
+          <a:lstStyle/>
+          <a:p>
+            <a:pPr>
+              <a:spcAft>
+                <a:spcPts val="1500"/>
+              </a:spcAft>
+              <a:defRPr sz="2000" b="1">
+                <a:solidFill>
+                  <a:srgbClr val="D4AF37"/>
+                </a:solidFill>
+                <a:latin typeface="Georgia"/>
+              </a:defRPr>
+            </a:pPr>
+            <a:r>
+              <a:t>⚡ n8n va WhatsApp Avtomatizatsiyasi</a:t>
+            </a:r>
+          </a:p>
+          <a:p>
+            <a:pPr>
+              <a:spcAft>
+                <a:spcPts val="1000"/>
+              </a:spcAft>
+              <a:defRPr sz="1200" b="1">
+                <a:solidFill>
+                  <a:srgbClr val="009B9E"/>
+                </a:solidFill>
+                <a:latin typeface="Segoe UI"/>
+              </a:defRPr>
+            </a:pPr>
+            <a:r>
+              <a:t>• n8n workflow integratsiyasi — </a:t>
+            </a:r>
+            <a:r>
+              <a:rPr b="0">
+                <a:solidFill>
+                  <a:srgbClr val="94A3B8"/>
+                </a:solidFill>
+              </a:rPr>
+              <a:t>Buyurtmalar boshqaruvi va monitoringi n8n platformasiga ulangan.</a:t>
+            </a:r>
+          </a:p>
+          <a:p>
+            <a:pPr>
+              <a:spcAft>
+                <a:spcPts val="1000"/>
+              </a:spcAft>
+              <a:defRPr sz="1200" b="1">
+                <a:solidFill>
+                  <a:srgbClr val="009B9E"/>
+                </a:solidFill>
+                <a:latin typeface="Segoe UI"/>
+              </a:defRPr>
+            </a:pPr>
+            <a:r>
+              <a:t>• Avtomatik xabar yetkazish — </a:t>
+            </a:r>
+            <a:r>
+              <a:rPr b="0">
+                <a:solidFill>
+                  <a:srgbClr val="94A3B8"/>
+                </a:solidFill>
+              </a:rPr>
+              <a:t>Sayyoh buyurtmani tasdiqlagach, haydovchi va gidning WhatsApp / Telegramiga darhol xabar ketadi.</a:t>
+            </a:r>
+          </a:p>
+          <a:p>
+            <a:pPr>
+              <a:spcAft>
+                <a:spcPts val="1000"/>
+              </a:spcAft>
+              <a:defRPr sz="1200" b="1">
+                <a:solidFill>
+                  <a:srgbClr val="009B9E"/>
+                </a:solidFill>
+                <a:latin typeface="Segoe UI"/>
+              </a:defRPr>
+            </a:pPr>
+            <a:r>
+              <a:t>• Marshrut va aloqa ma'lumotlari — </a:t>
+            </a:r>
+            <a:r>
+              <a:rPr b="0">
+                <a:solidFill>
+                  <a:srgbClr val="94A3B8"/>
+                </a:solidFill>
+              </a:rPr>
+              <a:t>Xabarda sayyohning to'liq marshruti, poyezd/samolyot kelish vaqti va telefon raqami avtomatik taqdim etiladi.</a:t>
+            </a:r>
+          </a:p>
+          <a:p>
+            <a:pPr>
+              <a:spcAft>
+                <a:spcPts val="1000"/>
+              </a:spcAft>
+              <a:defRPr sz="1200" b="1">
+                <a:solidFill>
+                  <a:srgbClr val="009B9E"/>
+                </a:solidFill>
+                <a:latin typeface="Segoe UI"/>
+              </a:defRPr>
+            </a:pPr>
+            <a:r>
+              <a:t>• Operatsion xarajatlarni 90% kamaytirish — </a:t>
+            </a:r>
+            <a:r>
+              <a:rPr b="0">
+                <a:solidFill>
+                  <a:srgbClr val="94A3B8"/>
+                </a:solidFill>
+              </a:rPr>
+              <a:t>Menejerlarning qo'lda aloqa qilish vaqtini tejaydi, inson omilini kamaytiradi.</a:t>
+            </a:r>
+          </a:p>
+        </p:txBody>
+      </p:sp>
+    </p:spTree>
+  </p:cSld>
+  <p:clrMapOvr>
+    <a:masterClrMapping/>
+  </p:clrMapOvr>
+</p:sld>
+</file>
+
+<file path=ppt/slides/slide9.xml><?xml version="1.0" encoding="utf-8"?>
+<p:sld xmlns:a="http://schemas.openxmlformats.org/drawingml/2006/main" xmlns:p="http://schemas.openxmlformats.org/presentationml/2006/main" xmlns:r="http://schemas.openxmlformats.org/officeDocument/2006/relationships">
+  <p:cSld>
+    <p:bg>
+      <p:bgPr>
+        <a:solidFill>
+          <a:srgbClr val="0A0F1D"/>
+        </a:solidFill>
+        <a:effectLst/>
+      </p:bgPr>
+    </p:bg>
+    <p:spTree>
+      <p:nvGrpSpPr>
+        <p:cNvPr id="1" name=""/>
+        <p:cNvGrpSpPr/>
+        <p:nvPr/>
+      </p:nvGrpSpPr>
+      <p:grpSpPr/>
+      <p:pic>
+        <p:nvPicPr>
+          <p:cNvPr id="2" name="Picture 1" descr="uzbek_mandala.jpg"/>
+          <p:cNvPicPr>
+            <a:picLocks noChangeAspect="1"/>
+          </p:cNvPicPr>
+          <p:nvPr/>
+        </p:nvPicPr>
+        <p:blipFill>
+          <a:blip r:embed="rId2"/>
+          <a:stretch>
+            <a:fillRect/>
+          </a:stretch>
+        </p:blipFill>
+        <p:spPr>
+          <a:xfrm>
+            <a:off x="10058400" y="-914400"/>
+            <a:ext cx="3200400" cy="3200400"/>
+          </a:xfrm>
+          <a:prstGeom prst="rect">
+            <a:avLst/>
+          </a:prstGeom>
+        </p:spPr>
+      </p:pic>
+      <p:sp>
+        <p:nvSpPr>
+          <p:cNvPr id="3" name="Rectangle 2"/>
+          <p:cNvSpPr/>
+          <p:nvPr/>
+        </p:nvSpPr>
+        <p:spPr>
+          <a:xfrm>
+            <a:off x="0" y="0"/>
+            <a:ext cx="12191695" cy="109728"/>
+          </a:xfrm>
+          <a:prstGeom prst="rect">
+            <a:avLst/>
+          </a:prstGeom>
+          <a:solidFill>
+            <a:srgbClr val="D4AF37"/>
+          </a:solidFill>
+          <a:ln>
+            <a:noFill/>
+          </a:ln>
+        </p:spPr>
+        <p:style>
+          <a:lnRef idx="1">
+            <a:schemeClr val="accent1"/>
+          </a:lnRef>
+          <a:fillRef idx="3">
+            <a:schemeClr val="accent1"/>
+          </a:fillRef>
+          <a:effectRef idx="2">
+            <a:schemeClr val="accent1"/>
+          </a:effectRef>
+          <a:fontRef idx="minor">
+            <a:schemeClr val="lt1"/>
+          </a:fontRef>
+        </p:style>
+        <p:txBody>
+          <a:bodyPr rtlCol="0" anchor="ctr"/>
+          <a:lstStyle/>
+          <a:p>
+            <a:pPr algn="ctr"/>
+          </a:p>
+        </p:txBody>
+      </p:sp>
+      <p:sp>
+        <p:nvSpPr>
+          <p:cNvPr id="4" name="TextBox 3"/>
+          <p:cNvSpPr txBox="1"/>
+          <p:nvPr/>
+        </p:nvSpPr>
+        <p:spPr>
+          <a:xfrm>
+            <a:off x="731520" y="6492240"/>
+            <a:ext cx="9601200" cy="274320"/>
+          </a:xfrm>
+          <a:prstGeom prst="rect">
+            <a:avLst/>
+          </a:prstGeom>
+          <a:noFill/>
+        </p:spPr>
+        <p:txBody>
+          <a:bodyPr wrap="none" lIns="0" rIns="0" tIns="0" bIns="0">
+            <a:spAutoFit/>
+          </a:bodyPr>
+          <a:lstStyle/>
+          <a:p>
+            <a:pPr>
+              <a:defRPr sz="900" b="1">
+                <a:solidFill>
+                  <a:srgbClr val="475569"/>
+                </a:solidFill>
+                <a:latin typeface="Segoe UI"/>
+              </a:defRPr>
+            </a:pPr>
+            <a:r>
+              <a:t>UZBEK-TRIP (SAMARQAND CRAFTOUR)  |  HAMKORLIK TAQDIMOTI 2026</a:t>
+            </a:r>
+          </a:p>
+        </p:txBody>
+      </p:sp>
+      <p:pic>
+        <p:nvPicPr>
+          <p:cNvPr id="5" name="Picture 4" descr="logo.jpg"/>
+          <p:cNvPicPr>
+            <a:picLocks noChangeAspect="1"/>
+          </p:cNvPicPr>
+          <p:nvPr/>
+        </p:nvPicPr>
+        <p:blipFill>
+          <a:blip r:embed="rId3"/>
+          <a:stretch>
+            <a:fillRect/>
+          </a:stretch>
+        </p:blipFill>
+        <p:spPr>
+          <a:xfrm>
+            <a:off x="11430000" y="6309360"/>
+            <a:ext cx="457200" cy="457200"/>
+          </a:xfrm>
+          <a:prstGeom prst="rect">
+            <a:avLst/>
+          </a:prstGeom>
+        </p:spPr>
+      </p:pic>
+      <p:sp>
+        <p:nvSpPr>
+          <p:cNvPr id="6" name="TextBox 5"/>
+          <p:cNvSpPr txBox="1"/>
+          <p:nvPr/>
+        </p:nvSpPr>
+        <p:spPr>
+          <a:xfrm>
+            <a:off x="731520" y="457200"/>
+            <a:ext cx="10728655" cy="731520"/>
+          </a:xfrm>
+          <a:prstGeom prst="rect">
+            <a:avLst/>
+          </a:prstGeom>
+          <a:noFill/>
+        </p:spPr>
+        <p:txBody>
+          <a:bodyPr wrap="square" lIns="0" rIns="0" tIns="0" bIns="0">
+            <a:spAutoFit/>
+          </a:bodyPr>
+          <a:lstStyle/>
+          <a:p>
+            <a:pPr>
+              <a:defRPr sz="3000" b="1">
+                <a:solidFill>
+                  <a:srgbClr val="D4AF37"/>
+                </a:solidFill>
+                <a:latin typeface="Georgia"/>
+              </a:defRPr>
+            </a:pPr>
+            <a:r>
+              <a:t>ERISHILGAN MUVAFFAQIYATLAR VA KOD TAYYORLIGI</a:t>
+            </a:r>
+          </a:p>
+        </p:txBody>
+      </p:sp>
+      <p:sp>
+        <p:nvSpPr>
+          <p:cNvPr id="7" name="TextBox 6"/>
+          <p:cNvSpPr txBox="1"/>
+          <p:nvPr/>
+        </p:nvSpPr>
+        <p:spPr>
+          <a:xfrm>
+            <a:off x="731520" y="1645920"/>
+            <a:ext cx="4572000" cy="4114800"/>
+          </a:xfrm>
+          <a:prstGeom prst="rect">
+            <a:avLst/>
+          </a:prstGeom>
+          <a:noFill/>
+        </p:spPr>
+        <p:txBody>
+          <a:bodyPr wrap="square">
+            <a:spAutoFit/>
+          </a:bodyPr>
+          <a:lstStyle/>
+          <a:p>
+            <a:pPr>
+              <a:spcAft>
+                <a:spcPts val="1000"/>
+              </a:spcAft>
+              <a:defRPr sz="1400" b="1">
+                <a:solidFill>
+                  <a:srgbClr val="009B9E"/>
+                </a:solidFill>
+                <a:latin typeface="Segoe UI"/>
+              </a:defRPr>
+            </a:pPr>
+            <a:r>
+              <a:t>LOYIHANING BUGUNGI HOLATI</a:t>
+            </a:r>
+          </a:p>
+          <a:p>
+            <a:pPr>
+              <a:spcAft>
+                <a:spcPts val="1500"/>
+              </a:spcAft>
+              <a:defRPr sz="3600" b="1">
+                <a:solidFill>
+                  <a:srgbClr val="D4AF37"/>
+                </a:solidFill>
+                <a:latin typeface="Georgia"/>
+              </a:defRPr>
+            </a:pPr>
+            <a:r>
+              <a:t>Tayyor va Ishlovchi MVP</a:t>
+            </a:r>
+          </a:p>
+          <a:p>
+            <a:pPr>
+              <a:spcAft>
+                <a:spcPts val="1000"/>
+              </a:spcAft>
+              <a:defRPr sz="1300">
+                <a:solidFill>
+                  <a:srgbClr val="FFFFFF"/>
+                </a:solidFill>
+                <a:latin typeface="Segoe UI"/>
+              </a:defRPr>
+            </a:pPr>
+            <a:r>
+              <a:t>Platformaning veb-versiyasi ishlab chiqildi va barcha asosiy funksiyalar kod darajasida tayyorlandi:</a:t>
+            </a:r>
+          </a:p>
+          <a:p>
+            <a:pPr>
+              <a:spcAft>
+                <a:spcPts val="500"/>
+              </a:spcAft>
+              <a:defRPr sz="1200" b="1">
+                <a:solidFill>
+                  <a:srgbClr val="D4AF37"/>
+                </a:solidFill>
+                <a:latin typeface="Segoe UI"/>
+              </a:defRPr>
+            </a:pPr>
+            <a:r>
+              <a:t>✔ Vercel Live-demo — </a:t>
+            </a:r>
+            <a:r>
+              <a:rPr b="0">
+                <a:solidFill>
+                  <a:srgbClr val="94A3B8"/>
+                </a:solidFill>
+              </a:rPr>
+              <a:t>Loyiha muvaffaqiyatli bulutga yuklandi va testdan o'tdi.</a:t>
+            </a:r>
+          </a:p>
+          <a:p>
+            <a:pPr>
+              <a:spcAft>
+                <a:spcPts val="500"/>
+              </a:spcAft>
+              <a:defRPr sz="1200" b="1">
+                <a:solidFill>
+                  <a:srgbClr val="D4AF37"/>
+                </a:solidFill>
+                <a:latin typeface="Segoe UI"/>
+              </a:defRPr>
+            </a:pPr>
+            <a:r>
+              <a:t>✔ OSRM Routing — </a:t>
+            </a:r>
+            <a:r>
+              <a:rPr b="0">
+                <a:solidFill>
+                  <a:srgbClr val="94A3B8"/>
+                </a:solidFill>
+              </a:rPr>
+              <a:t>Haqiqiy avtomobil yo'llari bo'yicha navigatsiya chizig'i ishlaydi.</a:t>
+            </a:r>
+          </a:p>
+          <a:p>
+            <a:pPr>
+              <a:spcAft>
+                <a:spcPts val="500"/>
+              </a:spcAft>
+              <a:defRPr sz="1200" b="1">
+                <a:solidFill>
+                  <a:srgbClr val="D4AF37"/>
+                </a:solidFill>
+                <a:latin typeface="Segoe UI"/>
+              </a:defRPr>
+            </a:pPr>
+            <a:r>
+              <a:t>✔ Jonli GPS Navigatsiyasi — </a:t>
+            </a:r>
+            <a:r>
+              <a:rPr b="0">
+                <a:solidFill>
+                  <a:srgbClr val="94A3B8"/>
+                </a:solidFill>
+              </a:rPr>
+              <a:t>Foydalanuvchi joylashuvini live ko'rsatish funksiyasi tayyor.</a:t>
+            </a:r>
+          </a:p>
+          <a:p>
+            <a:pPr>
+              <a:spcAft>
+                <a:spcPts val="500"/>
+              </a:spcAft>
+              <a:defRPr sz="1200" b="1">
+                <a:solidFill>
+                  <a:srgbClr val="D4AF37"/>
+                </a:solidFill>
+                <a:latin typeface="Segoe UI"/>
+              </a:defRPr>
+            </a:pPr>
+            <a:r>
+              <a:t>✔ Simulyatsiya rejimi (Demo) — </a:t>
+            </a:r>
+            <a:r>
+              <a:rPr b="0">
+                <a:solidFill>
+                  <a:srgbClr val="94A3B8"/>
+                </a:solidFill>
+              </a:rPr>
+              <a:t>Virtual haydovchining harakatlanishini kuzatish imkoniyati.</a:t>
+            </a:r>
+          </a:p>
+        </p:txBody>
+      </p:sp>
+      <p:sp>
+        <p:nvSpPr>
+          <p:cNvPr id="8" name="Rounded Rectangle 7"/>
+          <p:cNvSpPr/>
+          <p:nvPr/>
+        </p:nvSpPr>
+        <p:spPr>
+          <a:xfrm>
+            <a:off x="5943600" y="1645920"/>
+            <a:ext cx="5486400" cy="4114800"/>
+          </a:xfrm>
+          <a:prstGeom prst="roundRect">
+            <a:avLst/>
+          </a:prstGeom>
+          <a:solidFill>
+            <a:srgbClr val="121A2F"/>
+          </a:solidFill>
+          <a:ln w="19050">
+            <a:solidFill>
+              <a:srgbClr val="D4AF37"/>
+            </a:solidFill>
+          </a:ln>
+        </p:spPr>
+        <p:style>
+          <a:lnRef idx="1">
+            <a:schemeClr val="accent1"/>
+          </a:lnRef>
+          <a:fillRef idx="3">
+            <a:schemeClr val="accent1"/>
+          </a:fillRef>
+          <a:effectRef idx="2">
+            <a:schemeClr val="accent1"/>
+          </a:effectRef>
+          <a:fontRef idx="minor">
+            <a:schemeClr val="lt1"/>
+          </a:fontRef>
+        </p:style>
+        <p:txBody>
+          <a:bodyPr rtlCol="0" anchor="ctr"/>
+          <a:lstStyle/>
+          <a:p>
+            <a:pPr algn="ctr"/>
+          </a:p>
+        </p:txBody>
+      </p:sp>
+      <p:sp>
+        <p:nvSpPr>
+          <p:cNvPr id="9" name="TextBox 8"/>
+          <p:cNvSpPr txBox="1"/>
+          <p:nvPr/>
+        </p:nvSpPr>
+        <p:spPr>
+          <a:xfrm>
+            <a:off x="6309360" y="1920240"/>
+            <a:ext cx="4754880" cy="3566160"/>
+          </a:xfrm>
+          <a:prstGeom prst="rect">
+            <a:avLst/>
+          </a:prstGeom>
+          <a:noFill/>
+        </p:spPr>
+        <p:txBody>
+          <a:bodyPr wrap="square">
+            <a:spAutoFit/>
+          </a:bodyPr>
+          <a:lstStyle/>
+          <a:p>
+            <a:pPr>
+              <a:spcAft>
+                <a:spcPts val="1500"/>
+              </a:spcAft>
+              <a:defRPr sz="2000" b="1">
+                <a:solidFill>
+                  <a:srgbClr val="D4AF37"/>
+                </a:solidFill>
+                <a:latin typeface="Georgia"/>
+              </a:defRPr>
+            </a:pPr>
+            <a:r>
+              <a:t>📈 Keyingi 3 Oylik Reja</a:t>
             </a:r>
           </a:p>
           <a:p>
@@ -7293,7 +9143,7 @@
               </a:defRPr>
             </a:pPr>
             <a:r>
-              <a:t>⚡ 10,000 dan ortiq muvaffaqiyatli buyurtmalarni amalga oshirish.</a:t>
+              <a:t>⚡ Mehmonxonalarga QR-kodlarni taqsimlashni boshlash.</a:t>
             </a:r>
           </a:p>
           <a:p>
@@ -7309,7 +9159,7 @@
               </a:defRPr>
             </a:pPr>
             <a:r>
-              <a:t>⚡ 500+ sertifikatlangan gid va haydovchilar bilan hamkorlik tarmog'i.</a:t>
+              <a:t>⚡ Samarqand shahridagi 50 ta yetakchi gid va 30 ta haydovchini tizimga ro'yxatga olish.</a:t>
             </a:r>
           </a:p>
           <a:p>
@@ -7325,7 +9175,7 @@
               </a:defRPr>
             </a:pPr>
             <a:r>
-              <a:t>⚡ Muzeylar, tezyurar poyezdlar va madaniy tadbirlar chiptalari bilan to'liq integratsiya.</a:t>
+              <a:t>⚡ Restoranlar va eko-turizm nuqtalari bilan keshbek shartnomalarini tuzish.</a:t>
             </a:r>
           </a:p>
           <a:p>
@@ -7341,7 +9191,7 @@
               </a:defRPr>
             </a:pPr>
             <a:r>
-              <a:t>⚡ Sayohatlarni rejalashtirish operatsion vaqtini 5 daqiqadan kamaytirish.</a:t>
+              <a:t>⚡ Ilk 1,000 ta muvaffaqiyatli buyurtmani yakunlash.</a:t>
             </a:r>
           </a:p>
           <a:p>
@@ -7357,7 +9207,7 @@
               </a:defRPr>
             </a:pPr>
             <a:r>
-              <a:t>Biz bilan bog'lanish: info@samarkandcraftour.uz</a:t>
+              <a:t>Veb-sayt: uzbek-trip.vercel.app</a:t>
             </a:r>
           </a:p>
         </p:txBody>

</xml_diff>

<commit_message>
docs: adjust pitch deck to 5-minute investor presentation format
</commit_message>
<xml_diff>
--- a/Samarqand_CrafTour_Investor_Pitch_Deck.pptx
+++ b/Samarqand_CrafTour_Investor_Pitch_Deck.pptx
@@ -12,11 +12,6 @@
     <p:sldId id="260" r:id="rId11"/>
     <p:sldId id="261" r:id="rId12"/>
     <p:sldId id="262" r:id="rId13"/>
-    <p:sldId id="263" r:id="rId14"/>
-    <p:sldId id="264" r:id="rId15"/>
-    <p:sldId id="265" r:id="rId16"/>
-    <p:sldId id="266" r:id="rId17"/>
-    <p:sldId id="267" r:id="rId18"/>
   </p:sldIdLst>
   <p:sldSz cx="12191695" cy="6858000" type="screen4x3"/>
   <p:notesSz cx="6858000" cy="9144000"/>
@@ -3221,7 +3216,7 @@
           <a:lstStyle/>
           <a:p>
             <a:pPr algn="l">
-              <a:defRPr sz="4400" b="1">
+              <a:defRPr sz="5400" b="1">
                 <a:solidFill>
                   <a:srgbClr val="D4AF37"/>
                 </a:solidFill>
@@ -3230,10 +3225,6 @@
             </a:pPr>
             <a:r>
               <a:t>UZBEK-TRIP</a:t>
-            </a:r>
-            <a:br/>
-            <a:r>
-              <a:t>PLATFORMASI</a:t>
             </a:r>
           </a:p>
           <a:p>
@@ -3241,7 +3232,7 @@
               <a:spcBef>
                 <a:spcPts val="1000"/>
               </a:spcBef>
-              <a:defRPr sz="1600" b="1">
+              <a:defRPr sz="1800" b="1">
                 <a:solidFill>
                   <a:srgbClr val="FFFFFF"/>
                 </a:solidFill>
@@ -3249,7 +3240,7 @@
               </a:defRPr>
             </a:pPr>
             <a:r>
-              <a:t>Menejment, Marketing, Audit va Iqtisodiyot</a:t>
+              <a:t>Shaxsiy va Aqlli Marshrut Konstruktori</a:t>
             </a:r>
           </a:p>
           <a:p>
@@ -3265,7 +3256,7 @@
               </a:defRPr>
             </a:pPr>
             <a:r>
-              <a:t>Sayohatlarni real vaqtda rejalashtirish, GPS navigatsiyasi, n8n avtomatizatsiyasi hamda hamkorlar uchun unit-iqtisodiy yechimlar ekotizimi.</a:t>
+              <a:t>5 daqiqalik investitsion pitch deck taqdimoti: muammo, yechim, bozor, jamoa va erishilgan natijalar (traction).</a:t>
             </a:r>
           </a:p>
         </p:txBody>
@@ -3301,1353 +3292,7 @@
               </a:defRPr>
             </a:pPr>
             <a:r>
-              <a:t>BIZNES HAMKORLAR VA INVESTORLAR UCHUN TAQDIMOT  |  2026</a:t>
-            </a:r>
-          </a:p>
-        </p:txBody>
-      </p:sp>
-    </p:spTree>
-  </p:cSld>
-  <p:clrMapOvr>
-    <a:masterClrMapping/>
-  </p:clrMapOvr>
-</p:sld>
-</file>
-
-<file path=ppt/slides/slide10.xml><?xml version="1.0" encoding="utf-8"?>
-<p:sld xmlns:a="http://schemas.openxmlformats.org/drawingml/2006/main" xmlns:p="http://schemas.openxmlformats.org/presentationml/2006/main" xmlns:r="http://schemas.openxmlformats.org/officeDocument/2006/relationships">
-  <p:cSld>
-    <p:bg>
-      <p:bgPr>
-        <a:solidFill>
-          <a:srgbClr val="0A0F1D"/>
-        </a:solidFill>
-        <a:effectLst/>
-      </p:bgPr>
-    </p:bg>
-    <p:spTree>
-      <p:nvGrpSpPr>
-        <p:cNvPr id="1" name=""/>
-        <p:cNvGrpSpPr/>
-        <p:nvPr/>
-      </p:nvGrpSpPr>
-      <p:grpSpPr/>
-      <p:pic>
-        <p:nvPicPr>
-          <p:cNvPr id="2" name="Picture 1" descr="uzbek_mandala.jpg"/>
-          <p:cNvPicPr>
-            <a:picLocks noChangeAspect="1"/>
-          </p:cNvPicPr>
-          <p:nvPr/>
-        </p:nvPicPr>
-        <p:blipFill>
-          <a:blip r:embed="rId2"/>
-          <a:stretch>
-            <a:fillRect/>
-          </a:stretch>
-        </p:blipFill>
-        <p:spPr>
-          <a:xfrm>
-            <a:off x="10058400" y="-914400"/>
-            <a:ext cx="3200400" cy="3200400"/>
-          </a:xfrm>
-          <a:prstGeom prst="rect">
-            <a:avLst/>
-          </a:prstGeom>
-        </p:spPr>
-      </p:pic>
-      <p:sp>
-        <p:nvSpPr>
-          <p:cNvPr id="3" name="Rectangle 2"/>
-          <p:cNvSpPr/>
-          <p:nvPr/>
-        </p:nvSpPr>
-        <p:spPr>
-          <a:xfrm>
-            <a:off x="0" y="0"/>
-            <a:ext cx="12191695" cy="109728"/>
-          </a:xfrm>
-          <a:prstGeom prst="rect">
-            <a:avLst/>
-          </a:prstGeom>
-          <a:solidFill>
-            <a:srgbClr val="D4AF37"/>
-          </a:solidFill>
-          <a:ln>
-            <a:noFill/>
-          </a:ln>
-        </p:spPr>
-        <p:style>
-          <a:lnRef idx="1">
-            <a:schemeClr val="accent1"/>
-          </a:lnRef>
-          <a:fillRef idx="3">
-            <a:schemeClr val="accent1"/>
-          </a:fillRef>
-          <a:effectRef idx="2">
-            <a:schemeClr val="accent1"/>
-          </a:effectRef>
-          <a:fontRef idx="minor">
-            <a:schemeClr val="lt1"/>
-          </a:fontRef>
-        </p:style>
-        <p:txBody>
-          <a:bodyPr rtlCol="0" anchor="ctr"/>
-          <a:lstStyle/>
-          <a:p>
-            <a:pPr algn="ctr"/>
-          </a:p>
-        </p:txBody>
-      </p:sp>
-      <p:sp>
-        <p:nvSpPr>
-          <p:cNvPr id="4" name="TextBox 3"/>
-          <p:cNvSpPr txBox="1"/>
-          <p:nvPr/>
-        </p:nvSpPr>
-        <p:spPr>
-          <a:xfrm>
-            <a:off x="731520" y="6492240"/>
-            <a:ext cx="9601200" cy="274320"/>
-          </a:xfrm>
-          <a:prstGeom prst="rect">
-            <a:avLst/>
-          </a:prstGeom>
-          <a:noFill/>
-        </p:spPr>
-        <p:txBody>
-          <a:bodyPr wrap="none" lIns="0" rIns="0" tIns="0" bIns="0">
-            <a:spAutoFit/>
-          </a:bodyPr>
-          <a:lstStyle/>
-          <a:p>
-            <a:pPr>
-              <a:defRPr sz="900" b="1">
-                <a:solidFill>
-                  <a:srgbClr val="475569"/>
-                </a:solidFill>
-                <a:latin typeface="Segoe UI"/>
-              </a:defRPr>
-            </a:pPr>
-            <a:r>
-              <a:t>UZBEK-TRIP (SAMARQAND CRAFTOUR)  |  HAMKORLIK TAQDIMOTI 2026</a:t>
-            </a:r>
-          </a:p>
-        </p:txBody>
-      </p:sp>
-      <p:pic>
-        <p:nvPicPr>
-          <p:cNvPr id="5" name="Picture 4" descr="logo.jpg"/>
-          <p:cNvPicPr>
-            <a:picLocks noChangeAspect="1"/>
-          </p:cNvPicPr>
-          <p:nvPr/>
-        </p:nvPicPr>
-        <p:blipFill>
-          <a:blip r:embed="rId3"/>
-          <a:stretch>
-            <a:fillRect/>
-          </a:stretch>
-        </p:blipFill>
-        <p:spPr>
-          <a:xfrm>
-            <a:off x="11430000" y="6309360"/>
-            <a:ext cx="457200" cy="457200"/>
-          </a:xfrm>
-          <a:prstGeom prst="rect">
-            <a:avLst/>
-          </a:prstGeom>
-        </p:spPr>
-      </p:pic>
-      <p:sp>
-        <p:nvSpPr>
-          <p:cNvPr id="6" name="TextBox 5"/>
-          <p:cNvSpPr txBox="1"/>
-          <p:nvPr/>
-        </p:nvSpPr>
-        <p:spPr>
-          <a:xfrm>
-            <a:off x="731520" y="457200"/>
-            <a:ext cx="10728655" cy="731520"/>
-          </a:xfrm>
-          <a:prstGeom prst="rect">
-            <a:avLst/>
-          </a:prstGeom>
-          <a:noFill/>
-        </p:spPr>
-        <p:txBody>
-          <a:bodyPr wrap="square" lIns="0" rIns="0" tIns="0" bIns="0">
-            <a:spAutoFit/>
-          </a:bodyPr>
-          <a:lstStyle/>
-          <a:p>
-            <a:pPr>
-              <a:defRPr sz="3000" b="1">
-                <a:solidFill>
-                  <a:srgbClr val="D4AF37"/>
-                </a:solidFill>
-                <a:latin typeface="Georgia"/>
-              </a:defRPr>
-            </a:pPr>
-            <a:r>
-              <a:t>KELAJAKDAGI STRATEGIK REJALAR</a:t>
-            </a:r>
-          </a:p>
-        </p:txBody>
-      </p:sp>
-      <p:sp>
-        <p:nvSpPr>
-          <p:cNvPr id="7" name="Rounded Rectangle 6"/>
-          <p:cNvSpPr/>
-          <p:nvPr/>
-        </p:nvSpPr>
-        <p:spPr>
-          <a:xfrm>
-            <a:off x="731520" y="1645920"/>
-            <a:ext cx="3291840" cy="4114800"/>
-          </a:xfrm>
-          <a:prstGeom prst="roundRect">
-            <a:avLst/>
-          </a:prstGeom>
-          <a:solidFill>
-            <a:srgbClr val="121A2F"/>
-          </a:solidFill>
-          <a:ln w="19050">
-            <a:solidFill>
-              <a:srgbClr val="D4AF37"/>
-            </a:solidFill>
-          </a:ln>
-        </p:spPr>
-        <p:style>
-          <a:lnRef idx="1">
-            <a:schemeClr val="accent1"/>
-          </a:lnRef>
-          <a:fillRef idx="3">
-            <a:schemeClr val="accent1"/>
-          </a:fillRef>
-          <a:effectRef idx="2">
-            <a:schemeClr val="accent1"/>
-          </a:effectRef>
-          <a:fontRef idx="minor">
-            <a:schemeClr val="lt1"/>
-          </a:fontRef>
-        </p:style>
-        <p:txBody>
-          <a:bodyPr rtlCol="0" anchor="ctr"/>
-          <a:lstStyle/>
-          <a:p>
-            <a:pPr algn="ctr"/>
-          </a:p>
-        </p:txBody>
-      </p:sp>
-      <p:sp>
-        <p:nvSpPr>
-          <p:cNvPr id="8" name="TextBox 7"/>
-          <p:cNvSpPr txBox="1"/>
-          <p:nvPr/>
-        </p:nvSpPr>
-        <p:spPr>
-          <a:xfrm>
-            <a:off x="914400" y="1828800"/>
-            <a:ext cx="2926080" cy="3749040"/>
-          </a:xfrm>
-          <a:prstGeom prst="rect">
-            <a:avLst/>
-          </a:prstGeom>
-          <a:noFill/>
-        </p:spPr>
-        <p:txBody>
-          <a:bodyPr wrap="square">
-            <a:spAutoFit/>
-          </a:bodyPr>
-          <a:lstStyle/>
-          <a:p>
-            <a:pPr>
-              <a:defRPr sz="2800" b="1">
-                <a:solidFill>
-                  <a:srgbClr val="009B9E"/>
-                </a:solidFill>
-                <a:latin typeface="Georgia"/>
-              </a:defRPr>
-            </a:pPr>
-            <a:r>
-              <a:t>01</a:t>
-            </a:r>
-          </a:p>
-          <a:p>
-            <a:pPr>
-              <a:spcBef>
-                <a:spcPts val="1000"/>
-              </a:spcBef>
-              <a:spcAft>
-                <a:spcPts val="1000"/>
-              </a:spcAft>
-              <a:defRPr sz="1700" b="1">
-                <a:solidFill>
-                  <a:srgbClr val="D4AF37"/>
-                </a:solidFill>
-                <a:latin typeface="Georgia"/>
-              </a:defRPr>
-            </a:pPr>
-            <a:r>
-              <a:t>UzRailways Integratsiyasi</a:t>
-            </a:r>
-          </a:p>
-          <a:p>
-            <a:pPr>
-              <a:spcAft>
-                <a:spcPts val="1500"/>
-              </a:spcAft>
-              <a:defRPr sz="1200">
-                <a:solidFill>
-                  <a:srgbClr val="94A3B8"/>
-                </a:solidFill>
-                <a:latin typeface="Segoe UI"/>
-              </a:defRPr>
-            </a:pPr>
-            <a:r>
-              <a:t>Platforma ichida Afrosiyob tezyurar poyezdi chiptalarini avtomatik sotish tizimini yo'lga qo'yish (UzRailways API orqali).</a:t>
-            </a:r>
-          </a:p>
-          <a:p>
-            <a:pPr>
-              <a:defRPr sz="1200" b="1">
-                <a:solidFill>
-                  <a:srgbClr val="FFFFFF"/>
-                </a:solidFill>
-                <a:latin typeface="Segoe UI"/>
-              </a:defRPr>
-            </a:pPr>
-            <a:r>
-              <a:t>Maqsad: Poyezd Chiptalari</a:t>
-            </a:r>
-          </a:p>
-        </p:txBody>
-      </p:sp>
-      <p:sp>
-        <p:nvSpPr>
-          <p:cNvPr id="9" name="Rounded Rectangle 8"/>
-          <p:cNvSpPr/>
-          <p:nvPr/>
-        </p:nvSpPr>
-        <p:spPr>
-          <a:xfrm>
-            <a:off x="4389120" y="1645920"/>
-            <a:ext cx="3291840" cy="4114800"/>
-          </a:xfrm>
-          <a:prstGeom prst="roundRect">
-            <a:avLst/>
-          </a:prstGeom>
-          <a:solidFill>
-            <a:srgbClr val="121A2F"/>
-          </a:solidFill>
-          <a:ln w="19050">
-            <a:solidFill>
-              <a:srgbClr val="D4AF37"/>
-            </a:solidFill>
-          </a:ln>
-        </p:spPr>
-        <p:style>
-          <a:lnRef idx="1">
-            <a:schemeClr val="accent1"/>
-          </a:lnRef>
-          <a:fillRef idx="3">
-            <a:schemeClr val="accent1"/>
-          </a:fillRef>
-          <a:effectRef idx="2">
-            <a:schemeClr val="accent1"/>
-          </a:effectRef>
-          <a:fontRef idx="minor">
-            <a:schemeClr val="lt1"/>
-          </a:fontRef>
-        </p:style>
-        <p:txBody>
-          <a:bodyPr rtlCol="0" anchor="ctr"/>
-          <a:lstStyle/>
-          <a:p>
-            <a:pPr algn="ctr"/>
-          </a:p>
-        </p:txBody>
-      </p:sp>
-      <p:sp>
-        <p:nvSpPr>
-          <p:cNvPr id="10" name="TextBox 9"/>
-          <p:cNvSpPr txBox="1"/>
-          <p:nvPr/>
-        </p:nvSpPr>
-        <p:spPr>
-          <a:xfrm>
-            <a:off x="4572000" y="1828800"/>
-            <a:ext cx="2926080" cy="3749040"/>
-          </a:xfrm>
-          <a:prstGeom prst="rect">
-            <a:avLst/>
-          </a:prstGeom>
-          <a:noFill/>
-        </p:spPr>
-        <p:txBody>
-          <a:bodyPr wrap="square">
-            <a:spAutoFit/>
-          </a:bodyPr>
-          <a:lstStyle/>
-          <a:p>
-            <a:pPr>
-              <a:defRPr sz="2800" b="1">
-                <a:solidFill>
-                  <a:srgbClr val="009B9E"/>
-                </a:solidFill>
-                <a:latin typeface="Georgia"/>
-              </a:defRPr>
-            </a:pPr>
-            <a:r>
-              <a:t>02</a:t>
-            </a:r>
-          </a:p>
-          <a:p>
-            <a:pPr>
-              <a:spcBef>
-                <a:spcPts val="1000"/>
-              </a:spcBef>
-              <a:spcAft>
-                <a:spcPts val="1000"/>
-              </a:spcAft>
-              <a:defRPr sz="1700" b="1">
-                <a:solidFill>
-                  <a:srgbClr val="D4AF37"/>
-                </a:solidFill>
-                <a:latin typeface="Georgia"/>
-              </a:defRPr>
-            </a:pPr>
-            <a:r>
-              <a:t>Milliy Avia-chiptalar</a:t>
-            </a:r>
-          </a:p>
-          <a:p>
-            <a:pPr>
-              <a:spcAft>
-                <a:spcPts val="1500"/>
-              </a:spcAft>
-              <a:defRPr sz="1200">
-                <a:solidFill>
-                  <a:srgbClr val="94A3B8"/>
-                </a:solidFill>
-                <a:latin typeface="Segoe UI"/>
-              </a:defRPr>
-            </a:pPr>
-            <a:r>
-              <a:t>Xalqaro va ichki reys chiptalarini dynamic ravishda platformaga ulash. Sayohat konstruktorida poyezd + samolyot integratsiyasi.</a:t>
-            </a:r>
-          </a:p>
-          <a:p>
-            <a:pPr>
-              <a:defRPr sz="1200" b="1">
-                <a:solidFill>
-                  <a:srgbClr val="FFFFFF"/>
-                </a:solidFill>
-                <a:latin typeface="Segoe UI"/>
-              </a:defRPr>
-            </a:pPr>
-            <a:r>
-              <a:t>Maqsad: Aviakompaniyalar</a:t>
-            </a:r>
-          </a:p>
-        </p:txBody>
-      </p:sp>
-      <p:sp>
-        <p:nvSpPr>
-          <p:cNvPr id="11" name="Rounded Rectangle 10"/>
-          <p:cNvSpPr/>
-          <p:nvPr/>
-        </p:nvSpPr>
-        <p:spPr>
-          <a:xfrm>
-            <a:off x="8046720" y="1645920"/>
-            <a:ext cx="3291840" cy="4114800"/>
-          </a:xfrm>
-          <a:prstGeom prst="roundRect">
-            <a:avLst/>
-          </a:prstGeom>
-          <a:solidFill>
-            <a:srgbClr val="121A2F"/>
-          </a:solidFill>
-          <a:ln w="19050">
-            <a:solidFill>
-              <a:srgbClr val="D4AF37"/>
-            </a:solidFill>
-          </a:ln>
-        </p:spPr>
-        <p:style>
-          <a:lnRef idx="1">
-            <a:schemeClr val="accent1"/>
-          </a:lnRef>
-          <a:fillRef idx="3">
-            <a:schemeClr val="accent1"/>
-          </a:fillRef>
-          <a:effectRef idx="2">
-            <a:schemeClr val="accent1"/>
-          </a:effectRef>
-          <a:fontRef idx="minor">
-            <a:schemeClr val="lt1"/>
-          </a:fontRef>
-        </p:style>
-        <p:txBody>
-          <a:bodyPr rtlCol="0" anchor="ctr"/>
-          <a:lstStyle/>
-          <a:p>
-            <a:pPr algn="ctr"/>
-          </a:p>
-        </p:txBody>
-      </p:sp>
-      <p:sp>
-        <p:nvSpPr>
-          <p:cNvPr id="12" name="TextBox 11"/>
-          <p:cNvSpPr txBox="1"/>
-          <p:nvPr/>
-        </p:nvSpPr>
-        <p:spPr>
-          <a:xfrm>
-            <a:off x="8229600" y="1828800"/>
-            <a:ext cx="2926080" cy="3749040"/>
-          </a:xfrm>
-          <a:prstGeom prst="rect">
-            <a:avLst/>
-          </a:prstGeom>
-          <a:noFill/>
-        </p:spPr>
-        <p:txBody>
-          <a:bodyPr wrap="square">
-            <a:spAutoFit/>
-          </a:bodyPr>
-          <a:lstStyle/>
-          <a:p>
-            <a:pPr>
-              <a:defRPr sz="2800" b="1">
-                <a:solidFill>
-                  <a:srgbClr val="009B9E"/>
-                </a:solidFill>
-                <a:latin typeface="Georgia"/>
-              </a:defRPr>
-            </a:pPr>
-            <a:r>
-              <a:t>03</a:t>
-            </a:r>
-          </a:p>
-          <a:p>
-            <a:pPr>
-              <a:spcBef>
-                <a:spcPts val="1000"/>
-              </a:spcBef>
-              <a:spcAft>
-                <a:spcPts val="1000"/>
-              </a:spcAft>
-              <a:defRPr sz="1700" b="1">
-                <a:solidFill>
-                  <a:srgbClr val="D4AF37"/>
-                </a:solidFill>
-                <a:latin typeface="Georgia"/>
-              </a:defRPr>
-            </a:pPr>
-            <a:r>
-              <a:t>Ovozli Navigatsiya</a:t>
-            </a:r>
-          </a:p>
-          <a:p>
-            <a:pPr>
-              <a:spcAft>
-                <a:spcPts val="1500"/>
-              </a:spcAft>
-              <a:defRPr sz="1200">
-                <a:solidFill>
-                  <a:srgbClr val="94A3B8"/>
-                </a:solidFill>
-                <a:latin typeface="Segoe UI"/>
-              </a:defRPr>
-            </a:pPr>
-            <a:r>
-              <a:t>Sayyohlar tarixiy obidalarda yurganda avtomatik ishga tushadigan localized ovozli audioprezentatsiya (multilingual voice guidance).</a:t>
-            </a:r>
-          </a:p>
-          <a:p>
-            <a:pPr>
-              <a:defRPr sz="1200" b="1">
-                <a:solidFill>
-                  <a:srgbClr val="FFFFFF"/>
-                </a:solidFill>
-                <a:latin typeface="Segoe UI"/>
-              </a:defRPr>
-            </a:pPr>
-            <a:r>
-              <a:t>Maqsad: Smart Audio Guide</a:t>
-            </a:r>
-          </a:p>
-        </p:txBody>
-      </p:sp>
-    </p:spTree>
-  </p:cSld>
-  <p:clrMapOvr>
-    <a:masterClrMapping/>
-  </p:clrMapOvr>
-</p:sld>
-</file>
-
-<file path=ppt/slides/slide11.xml><?xml version="1.0" encoding="utf-8"?>
-<p:sld xmlns:a="http://schemas.openxmlformats.org/drawingml/2006/main" xmlns:p="http://schemas.openxmlformats.org/presentationml/2006/main" xmlns:r="http://schemas.openxmlformats.org/officeDocument/2006/relationships">
-  <p:cSld>
-    <p:bg>
-      <p:bgPr>
-        <a:solidFill>
-          <a:srgbClr val="0A0F1D"/>
-        </a:solidFill>
-        <a:effectLst/>
-      </p:bgPr>
-    </p:bg>
-    <p:spTree>
-      <p:nvGrpSpPr>
-        <p:cNvPr id="1" name=""/>
-        <p:cNvGrpSpPr/>
-        <p:nvPr/>
-      </p:nvGrpSpPr>
-      <p:grpSpPr/>
-      <p:pic>
-        <p:nvPicPr>
-          <p:cNvPr id="2" name="Picture 1" descr="uzbek_mandala.jpg"/>
-          <p:cNvPicPr>
-            <a:picLocks noChangeAspect="1"/>
-          </p:cNvPicPr>
-          <p:nvPr/>
-        </p:nvPicPr>
-        <p:blipFill>
-          <a:blip r:embed="rId2"/>
-          <a:stretch>
-            <a:fillRect/>
-          </a:stretch>
-        </p:blipFill>
-        <p:spPr>
-          <a:xfrm>
-            <a:off x="10058400" y="-914400"/>
-            <a:ext cx="3200400" cy="3200400"/>
-          </a:xfrm>
-          <a:prstGeom prst="rect">
-            <a:avLst/>
-          </a:prstGeom>
-        </p:spPr>
-      </p:pic>
-      <p:sp>
-        <p:nvSpPr>
-          <p:cNvPr id="3" name="Rectangle 2"/>
-          <p:cNvSpPr/>
-          <p:nvPr/>
-        </p:nvSpPr>
-        <p:spPr>
-          <a:xfrm>
-            <a:off x="0" y="0"/>
-            <a:ext cx="12191695" cy="109728"/>
-          </a:xfrm>
-          <a:prstGeom prst="rect">
-            <a:avLst/>
-          </a:prstGeom>
-          <a:solidFill>
-            <a:srgbClr val="D4AF37"/>
-          </a:solidFill>
-          <a:ln>
-            <a:noFill/>
-          </a:ln>
-        </p:spPr>
-        <p:style>
-          <a:lnRef idx="1">
-            <a:schemeClr val="accent1"/>
-          </a:lnRef>
-          <a:fillRef idx="3">
-            <a:schemeClr val="accent1"/>
-          </a:fillRef>
-          <a:effectRef idx="2">
-            <a:schemeClr val="accent1"/>
-          </a:effectRef>
-          <a:fontRef idx="minor">
-            <a:schemeClr val="lt1"/>
-          </a:fontRef>
-        </p:style>
-        <p:txBody>
-          <a:bodyPr rtlCol="0" anchor="ctr"/>
-          <a:lstStyle/>
-          <a:p>
-            <a:pPr algn="ctr"/>
-          </a:p>
-        </p:txBody>
-      </p:sp>
-      <p:sp>
-        <p:nvSpPr>
-          <p:cNvPr id="4" name="TextBox 3"/>
-          <p:cNvSpPr txBox="1"/>
-          <p:nvPr/>
-        </p:nvSpPr>
-        <p:spPr>
-          <a:xfrm>
-            <a:off x="731520" y="6492240"/>
-            <a:ext cx="9601200" cy="274320"/>
-          </a:xfrm>
-          <a:prstGeom prst="rect">
-            <a:avLst/>
-          </a:prstGeom>
-          <a:noFill/>
-        </p:spPr>
-        <p:txBody>
-          <a:bodyPr wrap="none" lIns="0" rIns="0" tIns="0" bIns="0">
-            <a:spAutoFit/>
-          </a:bodyPr>
-          <a:lstStyle/>
-          <a:p>
-            <a:pPr>
-              <a:defRPr sz="900" b="1">
-                <a:solidFill>
-                  <a:srgbClr val="475569"/>
-                </a:solidFill>
-                <a:latin typeface="Segoe UI"/>
-              </a:defRPr>
-            </a:pPr>
-            <a:r>
-              <a:t>UZBEK-TRIP (SAMARQAND CRAFTOUR)  |  HAMKORLIK TAQDIMOTI 2026</a:t>
-            </a:r>
-          </a:p>
-        </p:txBody>
-      </p:sp>
-      <p:pic>
-        <p:nvPicPr>
-          <p:cNvPr id="5" name="Picture 4" descr="logo.jpg"/>
-          <p:cNvPicPr>
-            <a:picLocks noChangeAspect="1"/>
-          </p:cNvPicPr>
-          <p:nvPr/>
-        </p:nvPicPr>
-        <p:blipFill>
-          <a:blip r:embed="rId3"/>
-          <a:stretch>
-            <a:fillRect/>
-          </a:stretch>
-        </p:blipFill>
-        <p:spPr>
-          <a:xfrm>
-            <a:off x="11430000" y="6309360"/>
-            <a:ext cx="457200" cy="457200"/>
-          </a:xfrm>
-          <a:prstGeom prst="rect">
-            <a:avLst/>
-          </a:prstGeom>
-        </p:spPr>
-      </p:pic>
-      <p:sp>
-        <p:nvSpPr>
-          <p:cNvPr id="6" name="TextBox 5"/>
-          <p:cNvSpPr txBox="1"/>
-          <p:nvPr/>
-        </p:nvSpPr>
-        <p:spPr>
-          <a:xfrm>
-            <a:off x="731520" y="457200"/>
-            <a:ext cx="10728655" cy="731520"/>
-          </a:xfrm>
-          <a:prstGeom prst="rect">
-            <a:avLst/>
-          </a:prstGeom>
-          <a:noFill/>
-        </p:spPr>
-        <p:txBody>
-          <a:bodyPr wrap="square" lIns="0" rIns="0" tIns="0" bIns="0">
-            <a:spAutoFit/>
-          </a:bodyPr>
-          <a:lstStyle/>
-          <a:p>
-            <a:pPr>
-              <a:defRPr sz="3000" b="1">
-                <a:solidFill>
-                  <a:srgbClr val="D4AF37"/>
-                </a:solidFill>
-                <a:latin typeface="Georgia"/>
-              </a:defRPr>
-            </a:pPr>
-            <a:r>
-              <a:t>INVESTITSIYA TAKLIFI VA BUDJET TAQSIMOTI</a:t>
-            </a:r>
-          </a:p>
-        </p:txBody>
-      </p:sp>
-      <p:sp>
-        <p:nvSpPr>
-          <p:cNvPr id="7" name="TextBox 6"/>
-          <p:cNvSpPr txBox="1"/>
-          <p:nvPr/>
-        </p:nvSpPr>
-        <p:spPr>
-          <a:xfrm>
-            <a:off x="731520" y="1645920"/>
-            <a:ext cx="4572000" cy="4114800"/>
-          </a:xfrm>
-          <a:prstGeom prst="rect">
-            <a:avLst/>
-          </a:prstGeom>
-          <a:noFill/>
-        </p:spPr>
-        <p:txBody>
-          <a:bodyPr wrap="square">
-            <a:spAutoFit/>
-          </a:bodyPr>
-          <a:lstStyle/>
-          <a:p>
-            <a:pPr>
-              <a:spcAft>
-                <a:spcPts val="1000"/>
-              </a:spcAft>
-              <a:defRPr sz="1400" b="1">
-                <a:solidFill>
-                  <a:srgbClr val="009B9E"/>
-                </a:solidFill>
-                <a:latin typeface="Segoe UI"/>
-              </a:defRPr>
-            </a:pPr>
-            <a:r>
-              <a:t>MOLIYAVIY EHTIYOJ</a:t>
-            </a:r>
-          </a:p>
-          <a:p>
-            <a:pPr>
-              <a:spcAft>
-                <a:spcPts val="1500"/>
-              </a:spcAft>
-              <a:defRPr sz="3600" b="1">
-                <a:solidFill>
-                  <a:srgbClr val="D4AF37"/>
-                </a:solidFill>
-                <a:latin typeface="Georgia"/>
-              </a:defRPr>
-            </a:pPr>
-            <a:r>
-              <a:t>$100,000 Seed Round</a:t>
-            </a:r>
-          </a:p>
-          <a:p>
-            <a:pPr>
-              <a:spcAft>
-                <a:spcPts val="1000"/>
-              </a:spcAft>
-              <a:defRPr sz="1300">
-                <a:solidFill>
-                  <a:srgbClr val="FFFFFF"/>
-                </a:solidFill>
-                <a:latin typeface="Segoe UI"/>
-              </a:defRPr>
-            </a:pPr>
-            <a:r>
-              <a:t>Ushbu sarmoya loyihaning operatsion faoliyatini kengaytirish va 1 yillik rivojlanish bosqichlari uchun sarflanadi.</a:t>
-            </a:r>
-          </a:p>
-          <a:p>
-            <a:pPr>
-              <a:spcAft>
-                <a:spcPts val="500"/>
-              </a:spcAft>
-              <a:defRPr sz="1200" b="1">
-                <a:solidFill>
-                  <a:srgbClr val="D4AF37"/>
-                </a:solidFill>
-                <a:latin typeface="Segoe UI"/>
-              </a:defRPr>
-            </a:pPr>
-            <a:r>
-              <a:t>✔ Dasturiy Rivojlanish (40%): </a:t>
-            </a:r>
-            <a:r>
-              <a:rPr b="0">
-                <a:solidFill>
-                  <a:srgbClr val="94A3B8"/>
-                </a:solidFill>
-              </a:rPr>
-              <a:t>iOS / Android mobil ilovalarini tayyorlash.</a:t>
-            </a:r>
-          </a:p>
-          <a:p>
-            <a:pPr>
-              <a:spcAft>
-                <a:spcPts val="500"/>
-              </a:spcAft>
-              <a:defRPr sz="1200" b="1">
-                <a:solidFill>
-                  <a:srgbClr val="D4AF37"/>
-                </a:solidFill>
-                <a:latin typeface="Segoe UI"/>
-              </a:defRPr>
-            </a:pPr>
-            <a:r>
-              <a:t>✔ Marketing va Jalb Etish (35%): </a:t>
-            </a:r>
-            <a:r>
-              <a:rPr b="0">
-                <a:solidFill>
-                  <a:srgbClr val="94A3B8"/>
-                </a:solidFill>
-              </a:rPr>
-              <a:t>B2C va B2B mehmonxona kampaniyalari.</a:t>
-            </a:r>
-          </a:p>
-          <a:p>
-            <a:pPr>
-              <a:spcAft>
-                <a:spcPts val="500"/>
-              </a:spcAft>
-              <a:defRPr sz="1200" b="1">
-                <a:solidFill>
-                  <a:srgbClr val="D4AF37"/>
-                </a:solidFill>
-                <a:latin typeface="Segoe UI"/>
-              </a:defRPr>
-            </a:pPr>
-            <a:r>
-              <a:t>✔ Operatsion Xarajatlar (25%): </a:t>
-            </a:r>
-            <a:r>
-              <a:rPr b="0">
-                <a:solidFill>
-                  <a:srgbClr val="94A3B8"/>
-                </a:solidFill>
-              </a:rPr>
-              <a:t>Haydovchilar auditini o'tkazish va ofis faoliyati.</a:t>
-            </a:r>
-          </a:p>
-        </p:txBody>
-      </p:sp>
-      <p:sp>
-        <p:nvSpPr>
-          <p:cNvPr id="8" name="Rounded Rectangle 7"/>
-          <p:cNvSpPr/>
-          <p:nvPr/>
-        </p:nvSpPr>
-        <p:spPr>
-          <a:xfrm>
-            <a:off x="5943600" y="1645920"/>
-            <a:ext cx="5486400" cy="4114800"/>
-          </a:xfrm>
-          <a:prstGeom prst="roundRect">
-            <a:avLst/>
-          </a:prstGeom>
-          <a:solidFill>
-            <a:srgbClr val="121A2F"/>
-          </a:solidFill>
-          <a:ln w="19050">
-            <a:solidFill>
-              <a:srgbClr val="D4AF37"/>
-            </a:solidFill>
-          </a:ln>
-        </p:spPr>
-        <p:style>
-          <a:lnRef idx="1">
-            <a:schemeClr val="accent1"/>
-          </a:lnRef>
-          <a:fillRef idx="3">
-            <a:schemeClr val="accent1"/>
-          </a:fillRef>
-          <a:effectRef idx="2">
-            <a:schemeClr val="accent1"/>
-          </a:effectRef>
-          <a:fontRef idx="minor">
-            <a:schemeClr val="lt1"/>
-          </a:fontRef>
-        </p:style>
-        <p:txBody>
-          <a:bodyPr rtlCol="0" anchor="ctr"/>
-          <a:lstStyle/>
-          <a:p>
-            <a:pPr algn="ctr"/>
-          </a:p>
-        </p:txBody>
-      </p:sp>
-      <p:sp>
-        <p:nvSpPr>
-          <p:cNvPr id="9" name="TextBox 8"/>
-          <p:cNvSpPr txBox="1"/>
-          <p:nvPr/>
-        </p:nvSpPr>
-        <p:spPr>
-          <a:xfrm>
-            <a:off x="6309360" y="1920240"/>
-            <a:ext cx="4754880" cy="3566160"/>
-          </a:xfrm>
-          <a:prstGeom prst="rect">
-            <a:avLst/>
-          </a:prstGeom>
-          <a:noFill/>
-        </p:spPr>
-        <p:txBody>
-          <a:bodyPr wrap="square">
-            <a:spAutoFit/>
-          </a:bodyPr>
-          <a:lstStyle/>
-          <a:p>
-            <a:pPr>
-              <a:spcAft>
-                <a:spcPts val="1500"/>
-              </a:spcAft>
-              <a:defRPr sz="2000" b="1">
-                <a:solidFill>
-                  <a:srgbClr val="D4AF37"/>
-                </a:solidFill>
-                <a:latin typeface="Georgia"/>
-              </a:defRPr>
-            </a:pPr>
-            <a:r>
-              <a:t>🤝 Hamkorlik Shartlari</a:t>
-            </a:r>
-          </a:p>
-          <a:p>
-            <a:pPr>
-              <a:spcAft>
-                <a:spcPts val="800"/>
-              </a:spcAft>
-              <a:defRPr sz="1200">
-                <a:solidFill>
-                  <a:srgbClr val="94A3B8"/>
-                </a:solidFill>
-                <a:latin typeface="Segoe UI"/>
-              </a:defRPr>
-            </a:pPr>
-            <a:r>
-              <a:t>⚡ 10-15% gacha ulush (Equity) investitsiya evaziga.</a:t>
-            </a:r>
-          </a:p>
-          <a:p>
-            <a:pPr>
-              <a:spcAft>
-                <a:spcPts val="800"/>
-              </a:spcAft>
-              <a:defRPr sz="1200">
-                <a:solidFill>
-                  <a:srgbClr val="94A3B8"/>
-                </a:solidFill>
-                <a:latin typeface="Segoe UI"/>
-              </a:defRPr>
-            </a:pPr>
-            <a:r>
-              <a:t>⚡ Mehmonxonalar va restorantlar uchun B2B hamkorlikda alohida referral / keshbek tizimi.</a:t>
-            </a:r>
-          </a:p>
-          <a:p>
-            <a:pPr>
-              <a:spcAft>
-                <a:spcPts val="800"/>
-              </a:spcAft>
-              <a:defRPr sz="1200">
-                <a:solidFill>
-                  <a:srgbClr val="94A3B8"/>
-                </a:solidFill>
-                <a:latin typeface="Segoe UI"/>
-              </a:defRPr>
-            </a:pPr>
-            <a:r>
-              <a:t>⚡ Tezyurar poyezd va aviabiletlar integratsiyasida qo'shma aksiyalar va hamkorlik imkoniyatlari.</a:t>
-            </a:r>
-          </a:p>
-          <a:p>
-            <a:pPr>
-              <a:spcAft>
-                <a:spcPts val="800"/>
-              </a:spcAft>
-              <a:defRPr sz="1200">
-                <a:solidFill>
-                  <a:srgbClr val="94A3B8"/>
-                </a:solidFill>
-                <a:latin typeface="Segoe UI"/>
-              </a:defRPr>
-            </a:pPr>
-            <a:r>
-              <a:t>⚡ Strategik boshqaruv kengashida ishtirok etish huquqi.</a:t>
-            </a:r>
-          </a:p>
-        </p:txBody>
-      </p:sp>
-    </p:spTree>
-  </p:cSld>
-  <p:clrMapOvr>
-    <a:masterClrMapping/>
-  </p:clrMapOvr>
-</p:sld>
-</file>
-
-<file path=ppt/slides/slide12.xml><?xml version="1.0" encoding="utf-8"?>
-<p:sld xmlns:a="http://schemas.openxmlformats.org/drawingml/2006/main" xmlns:p="http://schemas.openxmlformats.org/presentationml/2006/main" xmlns:r="http://schemas.openxmlformats.org/officeDocument/2006/relationships">
-  <p:cSld>
-    <p:bg>
-      <p:bgPr>
-        <a:solidFill>
-          <a:srgbClr val="0A0F1D"/>
-        </a:solidFill>
-        <a:effectLst/>
-      </p:bgPr>
-    </p:bg>
-    <p:spTree>
-      <p:nvGrpSpPr>
-        <p:cNvPr id="1" name=""/>
-        <p:cNvGrpSpPr/>
-        <p:nvPr/>
-      </p:nvGrpSpPr>
-      <p:grpSpPr/>
-      <p:pic>
-        <p:nvPicPr>
-          <p:cNvPr id="2" name="Picture 1" descr="uzbek_mandala.jpg"/>
-          <p:cNvPicPr>
-            <a:picLocks noChangeAspect="1"/>
-          </p:cNvPicPr>
-          <p:nvPr/>
-        </p:nvPicPr>
-        <p:blipFill>
-          <a:blip r:embed="rId2"/>
-          <a:stretch>
-            <a:fillRect/>
-          </a:stretch>
-        </p:blipFill>
-        <p:spPr>
-          <a:xfrm>
-            <a:off x="10058400" y="-914400"/>
-            <a:ext cx="3200400" cy="3200400"/>
-          </a:xfrm>
-          <a:prstGeom prst="rect">
-            <a:avLst/>
-          </a:prstGeom>
-        </p:spPr>
-      </p:pic>
-      <p:sp>
-        <p:nvSpPr>
-          <p:cNvPr id="3" name="Rectangle 2"/>
-          <p:cNvSpPr/>
-          <p:nvPr/>
-        </p:nvSpPr>
-        <p:spPr>
-          <a:xfrm>
-            <a:off x="0" y="0"/>
-            <a:ext cx="12191695" cy="109728"/>
-          </a:xfrm>
-          <a:prstGeom prst="rect">
-            <a:avLst/>
-          </a:prstGeom>
-          <a:solidFill>
-            <a:srgbClr val="D4AF37"/>
-          </a:solidFill>
-          <a:ln>
-            <a:noFill/>
-          </a:ln>
-        </p:spPr>
-        <p:style>
-          <a:lnRef idx="1">
-            <a:schemeClr val="accent1"/>
-          </a:lnRef>
-          <a:fillRef idx="3">
-            <a:schemeClr val="accent1"/>
-          </a:fillRef>
-          <a:effectRef idx="2">
-            <a:schemeClr val="accent1"/>
-          </a:effectRef>
-          <a:fontRef idx="minor">
-            <a:schemeClr val="lt1"/>
-          </a:fontRef>
-        </p:style>
-        <p:txBody>
-          <a:bodyPr rtlCol="0" anchor="ctr"/>
-          <a:lstStyle/>
-          <a:p>
-            <a:pPr algn="ctr"/>
-          </a:p>
-        </p:txBody>
-      </p:sp>
-      <p:sp>
-        <p:nvSpPr>
-          <p:cNvPr id="4" name="TextBox 3"/>
-          <p:cNvSpPr txBox="1"/>
-          <p:nvPr/>
-        </p:nvSpPr>
-        <p:spPr>
-          <a:xfrm>
-            <a:off x="731520" y="6492240"/>
-            <a:ext cx="9601200" cy="274320"/>
-          </a:xfrm>
-          <a:prstGeom prst="rect">
-            <a:avLst/>
-          </a:prstGeom>
-          <a:noFill/>
-        </p:spPr>
-        <p:txBody>
-          <a:bodyPr wrap="none" lIns="0" rIns="0" tIns="0" bIns="0">
-            <a:spAutoFit/>
-          </a:bodyPr>
-          <a:lstStyle/>
-          <a:p>
-            <a:pPr>
-              <a:defRPr sz="900" b="1">
-                <a:solidFill>
-                  <a:srgbClr val="475569"/>
-                </a:solidFill>
-                <a:latin typeface="Segoe UI"/>
-              </a:defRPr>
-            </a:pPr>
-            <a:r>
-              <a:t>UZBEK-TRIP (SAMARQAND CRAFTOUR)  |  HAMKORLIK TAQDIMOTI 2026</a:t>
-            </a:r>
-          </a:p>
-        </p:txBody>
-      </p:sp>
-      <p:pic>
-        <p:nvPicPr>
-          <p:cNvPr id="5" name="Picture 4" descr="logo.jpg"/>
-          <p:cNvPicPr>
-            <a:picLocks noChangeAspect="1"/>
-          </p:cNvPicPr>
-          <p:nvPr/>
-        </p:nvPicPr>
-        <p:blipFill>
-          <a:blip r:embed="rId3"/>
-          <a:stretch>
-            <a:fillRect/>
-          </a:stretch>
-        </p:blipFill>
-        <p:spPr>
-          <a:xfrm>
-            <a:off x="11430000" y="6309360"/>
-            <a:ext cx="457200" cy="457200"/>
-          </a:xfrm>
-          <a:prstGeom prst="rect">
-            <a:avLst/>
-          </a:prstGeom>
-        </p:spPr>
-      </p:pic>
-      <p:sp>
-        <p:nvSpPr>
-          <p:cNvPr id="6" name="Rectangle 5"/>
-          <p:cNvSpPr/>
-          <p:nvPr/>
-        </p:nvSpPr>
-        <p:spPr>
-          <a:xfrm>
-            <a:off x="1828800" y="1371600"/>
-            <a:ext cx="8534095" cy="4114800"/>
-          </a:xfrm>
-          <a:prstGeom prst="rect">
-            <a:avLst/>
-          </a:prstGeom>
-          <a:solidFill>
-            <a:srgbClr val="121A2F"/>
-          </a:solidFill>
-          <a:ln w="25400">
-            <a:solidFill>
-              <a:srgbClr val="D4AF37"/>
-            </a:solidFill>
-          </a:ln>
-        </p:spPr>
-        <p:style>
-          <a:lnRef idx="1">
-            <a:schemeClr val="accent1"/>
-          </a:lnRef>
-          <a:fillRef idx="3">
-            <a:schemeClr val="accent1"/>
-          </a:fillRef>
-          <a:effectRef idx="2">
-            <a:schemeClr val="accent1"/>
-          </a:effectRef>
-          <a:fontRef idx="minor">
-            <a:schemeClr val="lt1"/>
-          </a:fontRef>
-        </p:style>
-        <p:txBody>
-          <a:bodyPr rtlCol="0" anchor="ctr"/>
-          <a:lstStyle/>
-          <a:p>
-            <a:pPr algn="ctr"/>
-          </a:p>
-        </p:txBody>
-      </p:sp>
-      <p:sp>
-        <p:nvSpPr>
-          <p:cNvPr id="7" name="TextBox 6"/>
-          <p:cNvSpPr txBox="1"/>
-          <p:nvPr/>
-        </p:nvSpPr>
-        <p:spPr>
-          <a:xfrm>
-            <a:off x="2286000" y="1828800"/>
-            <a:ext cx="7619695" cy="3200400"/>
-          </a:xfrm>
-          <a:prstGeom prst="rect">
-            <a:avLst/>
-          </a:prstGeom>
-          <a:noFill/>
-        </p:spPr>
-        <p:txBody>
-          <a:bodyPr wrap="square">
-            <a:spAutoFit/>
-          </a:bodyPr>
-          <a:lstStyle/>
-          <a:p>
-            <a:pPr algn="ctr">
-              <a:spcAft>
-                <a:spcPts val="1000"/>
-              </a:spcAft>
-              <a:defRPr sz="3600" b="1">
-                <a:solidFill>
-                  <a:srgbClr val="D4AF37"/>
-                </a:solidFill>
-                <a:latin typeface="Georgia"/>
-              </a:defRPr>
-            </a:pPr>
-            <a:r>
-              <a:t>KATTA RAHMAT!</a:t>
-            </a:r>
-          </a:p>
-          <a:p>
-            <a:pPr algn="ctr">
-              <a:spcAft>
-                <a:spcPts val="2500"/>
-              </a:spcAft>
-              <a:defRPr sz="1600">
-                <a:solidFill>
-                  <a:srgbClr val="FFFFFF"/>
-                </a:solidFill>
-                <a:latin typeface="Segoe UI"/>
-              </a:defRPr>
-            </a:pPr>
-            <a:r>
-              <a:t>O'zbekistonda Zamonaviy va Shaxsiy Turizm Ekotizimini Birgalikda Yarataylik.</a:t>
-            </a:r>
-          </a:p>
-          <a:p>
-            <a:pPr algn="ctr">
-              <a:spcAft>
-                <a:spcPts val="1500"/>
-              </a:spcAft>
-              <a:defRPr sz="1400">
-                <a:solidFill>
-                  <a:srgbClr val="94A3B8"/>
-                </a:solidFill>
-                <a:latin typeface="Segoe UI"/>
-              </a:defRPr>
-            </a:pPr>
-            <a:r>
-              <a:t>📞 Aloqa: +998 (94) 019-64-20</a:t>
-            </a:r>
-            <a:br/>
-            <a:r>
-              <a:t>📧 Email: mikemukhriddin@gmail.com</a:t>
-            </a:r>
-            <a:br/>
-            <a:r>
-              <a:t>🌐 Veb-sayt: uzbek-trip.vercel.app</a:t>
-            </a:r>
-          </a:p>
-          <a:p>
-            <a:pPr algn="ctr">
-              <a:defRPr sz="1300" b="1" i="1">
-                <a:solidFill>
-                  <a:srgbClr val="009B9E"/>
-                </a:solidFill>
-                <a:latin typeface="Segoe UI"/>
-              </a:defRPr>
-            </a:pPr>
-            <a:r>
-              <a:t>Savollar bormi? Biz har qanday hamkorlikka tayyormiz!</a:t>
+              <a:t>INVESTOR PITCH DECK  |  2026</a:t>
             </a:r>
           </a:p>
         </p:txBody>
@@ -4776,7 +3421,7 @@
               </a:defRPr>
             </a:pPr>
             <a:r>
-              <a:t>UZBEK-TRIP (SAMARQAND CRAFTOUR)  |  HAMKORLIK TAQDIMOTI 2026</a:t>
+              <a:t>UZBEK-TRIP (SAMARQAND CRAFTOUR)  |  5-DAQIQALIK INVESTOR PITCH DECK</a:t>
             </a:r>
           </a:p>
         </p:txBody>
@@ -4836,7 +3481,7 @@
               </a:defRPr>
             </a:pPr>
             <a:r>
-              <a:t>BOZOR MUAMMOLARI VA IMKONIYAT</a:t>
+              <a:t>TURIZMDAGI ANIQ MUAMMOLAR</a:t>
             </a:r>
           </a:p>
         </p:txBody>
@@ -4936,7 +3581,7 @@
               </a:defRPr>
             </a:pPr>
             <a:r>
-              <a:t>Tashkiliy Qiyinchiliklar</a:t>
+              <a:t>Qotib qolgan turlar</a:t>
             </a:r>
           </a:p>
           <a:p>
@@ -4952,7 +3597,7 @@
               </a:defRPr>
             </a:pPr>
             <a:r>
-              <a:t>Sayyohlar gidlar, haydovchilar va marshrutlarni turli joylardan qidirishga majbur. Yagona, tezkor va ishonchli buyurtma berish vositasi mavjud emas.</a:t>
+              <a:t>Mavjud turpaketlar juda qattiq rejalashtirilgan. Zamonaviy erkin sayyohlar tayyor shablonlardan charchagan va o'z marshrutlarini shaxsiy qiziqishlariga moslashni xohlashadi.</a:t>
             </a:r>
           </a:p>
           <a:p>
@@ -4965,7 +3610,7 @@
               </a:defRPr>
             </a:pPr>
             <a:r>
-              <a:t>Operatsion menejmentning parchalanganligi.</a:t>
+              <a:t>Individual yondashuv yo'qligi</a:t>
             </a:r>
           </a:p>
         </p:txBody>
@@ -5065,7 +3710,7 @@
               </a:defRPr>
             </a:pPr>
             <a:r>
-              <a:t>Shaffof Emas Narxlar</a:t>
+              <a:t>Noaniq va yashirin narxlar</a:t>
             </a:r>
           </a:p>
           <a:p>
@@ -5081,7 +3726,7 @@
               </a:defRPr>
             </a:pPr>
             <a:r>
-              <a:t>Turizm bozorida narxlar sun'iy oshirilgan. Sayyoh oldindan aniq xizmatlar uchun qancha pul to'lashini va narx qanday shakllanishini ko'ra olmaydi.</a:t>
+              <a:t>Gidlar va haydovchilar bozori tartibga solinmagan. Narxlar oldindan ma'lum emas va yashirin komissiyalar sababli sayyohlar ko'p pul yo'qotishadi.</a:t>
             </a:r>
           </a:p>
           <a:p>
@@ -5094,7 +3739,7 @@
               </a:defRPr>
             </a:pPr>
             <a:r>
-              <a:t>Yashirin komissiyalar va noaniqlik.</a:t>
+              <a:t>Moliyaviy shaffoflik yo'qligi</a:t>
             </a:r>
           </a:p>
         </p:txBody>
@@ -5194,7 +3839,7 @@
               </a:defRPr>
             </a:pPr>
             <a:r>
-              <a:t>Sifat va Audit Kamchiligi</a:t>
+              <a:t>Sertifikatsiyalanmagan xizmatlar</a:t>
             </a:r>
           </a:p>
           <a:p>
@@ -5210,7 +3855,7 @@
               </a:defRPr>
             </a:pPr>
             <a:r>
-              <a:t>Haydovchi va gidlarning sifati oldindan tekshirilmaydi. Xavfsizlik va xizmat darajasi kafolatlanmaganligi sayyohlar ishonchini yo'qotadi.</a:t>
+              <a:t>Professional tillarni biladigan gidlar va ishonchli haydovchilarni bitta platformada kafolatlangan holda band qilish va tekshirish imkoniyati cheklangan.</a:t>
             </a:r>
           </a:p>
           <a:p>
@@ -5223,7 +3868,7 @@
               </a:defRPr>
             </a:pPr>
             <a:r>
-              <a:t>Audit va reyting tizimining yo'qligi.</a:t>
+              <a:t>Xavfsizlik va sifat nazorati sustligi</a:t>
             </a:r>
           </a:p>
         </p:txBody>
@@ -5352,7 +3997,7 @@
               </a:defRPr>
             </a:pPr>
             <a:r>
-              <a:t>UZBEK-TRIP (SAMARQAND CRAFTOUR)  |  HAMKORLIK TAQDIMOTI 2026</a:t>
+              <a:t>UZBEK-TRIP (SAMARQAND CRAFTOUR)  |  5-DAQIQALIK INVESTOR PITCH DECK</a:t>
             </a:r>
           </a:p>
         </p:txBody>
@@ -5412,7 +4057,7 @@
               </a:defRPr>
             </a:pPr>
             <a:r>
-              <a:t>OPERATSION MENEJMENT VA STRUKTURA</a:t>
+              <a:t>YECHIM VA MAHSULOT QANDAY ISHLAYDI</a:t>
             </a:r>
           </a:p>
         </p:txBody>
@@ -5443,7 +4088,7 @@
               <a:spcAft>
                 <a:spcPts val="1500"/>
               </a:spcAft>
-              <a:defRPr sz="2600" b="1">
+              <a:defRPr sz="2400" b="1">
                 <a:solidFill>
                   <a:srgbClr val="FFFFFF"/>
                 </a:solidFill>
@@ -5451,7 +4096,7 @@
               </a:defRPr>
             </a:pPr>
             <a:r>
-              <a:t>Samarali Boshqaruv Model</a:t>
+              <a:t>Biz sayyohlarga to'liq shaffoflik va boshqaruv erkinligini beramiz.</a:t>
             </a:r>
           </a:p>
           <a:p>
@@ -5459,7 +4104,7 @@
               <a:spcAft>
                 <a:spcPts val="1500"/>
               </a:spcAft>
-              <a:defRPr sz="1400">
+              <a:defRPr sz="1300">
                 <a:solidFill>
                   <a:srgbClr val="94A3B8"/>
                 </a:solidFill>
@@ -5467,7 +4112,7 @@
               </a:defRPr>
             </a:pPr>
             <a:r>
-              <a:t>Inson omilini kamaytirgan holda, platforma barcha buyurtmalar, haydovchilar va gidlar faoliyatini markazlashgan boshqaruv paneli orqali nazorat qiladi.</a:t>
+              <a:t>Sayyoh bir necha soniyalar ichida o'ziga mos transport turini, gid tili va boradigan maskanlarini tanlab, o'z yo'nalishini 'Lego' kabi teradi.</a:t>
             </a:r>
           </a:p>
           <a:p>
@@ -5480,7 +4125,7 @@
               </a:defRPr>
             </a:pPr>
             <a:r>
-              <a:t>Barcha jarayonlar avtomatlashtirilgan bo'lib, dispetcherlar va operatsion xodimlarga bo'lgan ehtiyojni 90% gacha kamaytiradi.</a:t>
+              <a:t>Real vaqt rejimida GPS navigatsiya yo'llari chiziladi va jami narx hisoblanib chiqadi.</a:t>
             </a:r>
           </a:p>
         </p:txBody>
@@ -5561,7 +4206,7 @@
               </a:defRPr>
             </a:pPr>
             <a:r>
-              <a:t>🚗 Haydovchilar Menejmenti</a:t>
+              <a:t>🗺 Interaktiv Marshrut Quruvchi</a:t>
             </a:r>
           </a:p>
           <a:p>
@@ -5577,7 +4222,7 @@
               </a:defRPr>
             </a:pPr>
             <a:r>
-              <a:t>Avtomobillar sig'imi, turi (sedan, minivan, avtobus) va yo'nalish tariflari bo'yicha real vaqtda avtomatik boshqaruv va band qilish.</a:t>
+              <a:t>Tarixiy diqqatga sazovor joylar va muqobil eko-turlarni birlashtirib, OSRM orqali yo'llar bo'yicha marshrut chizish.</a:t>
             </a:r>
           </a:p>
         </p:txBody>
@@ -5658,7 +4303,7 @@
               </a:defRPr>
             </a:pPr>
             <a:r>
-              <a:t>🗣 Gidlar Boshqaruvi</a:t>
+              <a:t>🚗 Haqiqiy GPS Kuzatuv &amp; Simulyatsiya</a:t>
             </a:r>
           </a:p>
           <a:p>
@@ -5674,7 +4319,7 @@
               </a:defRPr>
             </a:pPr>
             <a:r>
-              <a:t>Gidlar o'z tillari (EN, RU, ES, FR, UZ) va bandlik kalendarlari asosida tizimga integratsiya qilingan.</a:t>
+              <a:t>Sayyohning harakatlanishini online ko'rsatish, HUD panelda masofa, tezlik va yetib borish vaqtini (ETA) jonli yangilash.</a:t>
             </a:r>
           </a:p>
         </p:txBody>
@@ -5755,7 +4400,7 @@
               </a:defRPr>
             </a:pPr>
             <a:r>
-              <a:t>📊 Admin Dashboard</a:t>
+              <a:t>⚡ Avtomatlashtirilgan n8n Workflow</a:t>
             </a:r>
           </a:p>
           <a:p>
@@ -5771,7 +4416,7 @@
               </a:defRPr>
             </a:pPr>
             <a:r>
-              <a:t>Platforma ma'murlari uchun barcha faol turlarni kuzatish, kelib tushgan to'lovlarni nazorat qilish va hisobotlarni shakllantirish paneli.</a:t>
+              <a:t>Mijoz OTP kod orqali band qilganda haydovchi va gidning WhatsApp raqamiga to'liq ma'lumotlarni 1 soniyada yuborish.</a:t>
             </a:r>
           </a:p>
         </p:txBody>
@@ -5900,7 +4545,7 @@
               </a:defRPr>
             </a:pPr>
             <a:r>
-              <a:t>UZBEK-TRIP (SAMARQAND CRAFTOUR)  |  HAMKORLIK TAQDIMOTI 2026</a:t>
+              <a:t>UZBEK-TRIP (SAMARQAND CRAFTOUR)  |  5-DAQIQALIK INVESTOR PITCH DECK</a:t>
             </a:r>
           </a:p>
         </p:txBody>
@@ -5960,7 +4605,7 @@
               </a:defRPr>
             </a:pPr>
             <a:r>
-              <a:t>MARKETING VA MIJOZLARNI JALB QILISH</a:t>
+              <a:t>BOZOR HAJMI VA ASOSIY RAQOBATCHILAR</a:t>
             </a:r>
           </a:p>
         </p:txBody>
@@ -5974,7 +4619,7 @@
         <p:spPr>
           <a:xfrm>
             <a:off x="731520" y="1645920"/>
-            <a:ext cx="3291840" cy="4114800"/>
+            <a:ext cx="3291840" cy="2011680"/>
           </a:xfrm>
           <a:prstGeom prst="roundRect">
             <a:avLst/>
@@ -5984,7 +4629,7 @@
           </a:solidFill>
           <a:ln w="19050">
             <a:solidFill>
-              <a:srgbClr val="D4AF37"/>
+              <a:srgbClr val="009B9E"/>
             </a:solidFill>
           </a:ln>
         </p:spPr>
@@ -6018,8 +4663,8 @@
         </p:nvSpPr>
         <p:spPr>
           <a:xfrm>
-            <a:off x="868680" y="1828800"/>
-            <a:ext cx="3017520" cy="3749040"/>
+            <a:off x="914400" y="1783080"/>
+            <a:ext cx="2926080" cy="1737360"/>
           </a:xfrm>
           <a:prstGeom prst="rect">
             <a:avLst/>
@@ -6033,50 +4678,39 @@
           <a:lstStyle/>
           <a:p>
             <a:pPr algn="ctr">
-              <a:defRPr sz="1100" b="1">
-                <a:solidFill>
-                  <a:srgbClr val="009B9E"/>
-                </a:solidFill>
-                <a:latin typeface="Segoe UI"/>
-              </a:defRPr>
-            </a:pPr>
-            <a:r>
-              <a:t>B2C RAQAMLI MARKETING</a:t>
+              <a:defRPr sz="4000" b="1">
+                <a:solidFill>
+                  <a:srgbClr val="D4AF37"/>
+                </a:solidFill>
+                <a:latin typeface="Georgia"/>
+              </a:defRPr>
+            </a:pPr>
+            <a:r>
+              <a:t>$1.2B+</a:t>
             </a:r>
           </a:p>
           <a:p>
             <a:pPr algn="ctr">
               <a:spcBef>
-                <a:spcPts val="1000"/>
+                <a:spcPts val="500"/>
               </a:spcBef>
-              <a:spcAft>
-                <a:spcPts val="1000"/>
-              </a:spcAft>
-              <a:defRPr sz="3200"/>
-            </a:pPr>
-            <a:r>
-              <a:t>📱</a:t>
+              <a:defRPr sz="1200" b="1">
+                <a:solidFill>
+                  <a:srgbClr val="FFFFFF"/>
+                </a:solidFill>
+                <a:latin typeface="Segoe UI"/>
+              </a:defRPr>
+            </a:pPr>
+            <a:r>
+              <a:t>TAM (Total Addressable Market)</a:t>
             </a:r>
           </a:p>
           <a:p>
             <a:pPr algn="ctr">
-              <a:spcAft>
-                <a:spcPts val="1000"/>
-              </a:spcAft>
-              <a:defRPr sz="1600" b="1">
-                <a:solidFill>
-                  <a:srgbClr val="D4AF37"/>
-                </a:solidFill>
-                <a:latin typeface="Georgia"/>
-              </a:defRPr>
-            </a:pPr>
-            <a:r>
-              <a:t>Target Reklama &amp; SEO</a:t>
-            </a:r>
-          </a:p>
-          <a:p>
-            <a:pPr algn="ctr">
-              <a:defRPr sz="1100">
+              <a:spcBef>
+                <a:spcPts val="500"/>
+              </a:spcBef>
+              <a:defRPr sz="950">
                 <a:solidFill>
                   <a:srgbClr val="94A3B8"/>
                 </a:solidFill>
@@ -6084,7 +4718,7 @@
               </a:defRPr>
             </a:pPr>
             <a:r>
-              <a:t>Google Ads, Instagram va Facebook orqali O'zbekistonga sayohat rejalashtirayotgan xorijiy sayyohlarni maqsadli jalb qilish. Saytning xalqaro SEO optimallashtirilishi organik trafikni oshiradi.</a:t>
+              <a:t>O'zbekistondagi umumiy turizm bozori va sayyohlar xarajatlari yillik hajmi.</a:t>
             </a:r>
           </a:p>
         </p:txBody>
@@ -6098,7 +4732,7 @@
         <p:spPr>
           <a:xfrm>
             <a:off x="4389120" y="1645920"/>
-            <a:ext cx="3291840" cy="4114800"/>
+            <a:ext cx="3291840" cy="2011680"/>
           </a:xfrm>
           <a:prstGeom prst="roundRect">
             <a:avLst/>
@@ -6108,7 +4742,7 @@
           </a:solidFill>
           <a:ln w="19050">
             <a:solidFill>
-              <a:srgbClr val="D4AF37"/>
+              <a:srgbClr val="009B9E"/>
             </a:solidFill>
           </a:ln>
         </p:spPr>
@@ -6142,8 +4776,8 @@
         </p:nvSpPr>
         <p:spPr>
           <a:xfrm>
-            <a:off x="4526280" y="1828800"/>
-            <a:ext cx="3017520" cy="3749040"/>
+            <a:off x="4572000" y="1783080"/>
+            <a:ext cx="2926080" cy="1737360"/>
           </a:xfrm>
           <a:prstGeom prst="rect">
             <a:avLst/>
@@ -6157,50 +4791,39 @@
           <a:lstStyle/>
           <a:p>
             <a:pPr algn="ctr">
-              <a:defRPr sz="1100" b="1">
-                <a:solidFill>
-                  <a:srgbClr val="009B9E"/>
-                </a:solidFill>
-                <a:latin typeface="Segoe UI"/>
-              </a:defRPr>
-            </a:pPr>
-            <a:r>
-              <a:t>B2B HAMKORLIK</a:t>
+              <a:defRPr sz="4000" b="1">
+                <a:solidFill>
+                  <a:srgbClr val="D4AF37"/>
+                </a:solidFill>
+                <a:latin typeface="Georgia"/>
+              </a:defRPr>
+            </a:pPr>
+            <a:r>
+              <a:t>$250M</a:t>
             </a:r>
           </a:p>
           <a:p>
             <a:pPr algn="ctr">
               <a:spcBef>
-                <a:spcPts val="1000"/>
+                <a:spcPts val="500"/>
               </a:spcBef>
-              <a:spcAft>
-                <a:spcPts val="1000"/>
-              </a:spcAft>
-              <a:defRPr sz="3200"/>
-            </a:pPr>
-            <a:r>
-              <a:t>🏨</a:t>
+              <a:defRPr sz="1200" b="1">
+                <a:solidFill>
+                  <a:srgbClr val="FFFFFF"/>
+                </a:solidFill>
+                <a:latin typeface="Segoe UI"/>
+              </a:defRPr>
+            </a:pPr>
+            <a:r>
+              <a:t>SAM (Serviceable Addressable Market)</a:t>
             </a:r>
           </a:p>
           <a:p>
             <a:pPr algn="ctr">
-              <a:spcAft>
-                <a:spcPts val="1000"/>
-              </a:spcAft>
-              <a:defRPr sz="1600" b="1">
-                <a:solidFill>
-                  <a:srgbClr val="D4AF37"/>
-                </a:solidFill>
-                <a:latin typeface="Georgia"/>
-              </a:defRPr>
-            </a:pPr>
-            <a:r>
-              <a:t>Mehmonxonalar va Hostellar</a:t>
-            </a:r>
-          </a:p>
-          <a:p>
-            <a:pPr algn="ctr">
-              <a:defRPr sz="1100">
+              <a:spcBef>
+                <a:spcPts val="500"/>
+              </a:spcBef>
+              <a:defRPr sz="950">
                 <a:solidFill>
                   <a:srgbClr val="94A3B8"/>
                 </a:solidFill>
@@ -6208,7 +4831,7 @@
               </a:defRPr>
             </a:pPr>
             <a:r>
-              <a:t>Samarqand va Toshkentdagi 50+ yirik mehmonxonalar bilan hamkorlik shartnomalari. Har bir xonada platformaga yo'naltiruvchi maxsus QR-kod stikerlari o'rnatiladi.</a:t>
+              <a:t>Mustaqil va individual ravishda sayohat qiluvchi xalqaro turistlar ulushi.</a:t>
             </a:r>
           </a:p>
         </p:txBody>
@@ -6222,7 +4845,7 @@
         <p:spPr>
           <a:xfrm>
             <a:off x="8046720" y="1645920"/>
-            <a:ext cx="3291840" cy="4114800"/>
+            <a:ext cx="3291840" cy="2011680"/>
           </a:xfrm>
           <a:prstGeom prst="roundRect">
             <a:avLst/>
@@ -6232,7 +4855,7 @@
           </a:solidFill>
           <a:ln w="19050">
             <a:solidFill>
-              <a:srgbClr val="D4AF37"/>
+              <a:srgbClr val="009B9E"/>
             </a:solidFill>
           </a:ln>
         </p:spPr>
@@ -6266,8 +4889,8 @@
         </p:nvSpPr>
         <p:spPr>
           <a:xfrm>
-            <a:off x="8183880" y="1828800"/>
-            <a:ext cx="3017520" cy="3749040"/>
+            <a:off x="8229600" y="1783080"/>
+            <a:ext cx="2926080" cy="1737360"/>
           </a:xfrm>
           <a:prstGeom prst="rect">
             <a:avLst/>
@@ -6281,37 +4904,123 @@
           <a:lstStyle/>
           <a:p>
             <a:pPr algn="ctr">
-              <a:defRPr sz="1100" b="1">
-                <a:solidFill>
-                  <a:srgbClr val="009B9E"/>
-                </a:solidFill>
-                <a:latin typeface="Segoe UI"/>
-              </a:defRPr>
-            </a:pPr>
-            <a:r>
-              <a:t>INFLUENCER MARKETING</a:t>
+              <a:defRPr sz="4000" b="1">
+                <a:solidFill>
+                  <a:srgbClr val="D4AF37"/>
+                </a:solidFill>
+                <a:latin typeface="Georgia"/>
+              </a:defRPr>
+            </a:pPr>
+            <a:r>
+              <a:t>$15M</a:t>
             </a:r>
           </a:p>
           <a:p>
             <a:pPr algn="ctr">
               <a:spcBef>
-                <a:spcPts val="1000"/>
+                <a:spcPts val="500"/>
               </a:spcBef>
+              <a:defRPr sz="1200" b="1">
+                <a:solidFill>
+                  <a:srgbClr val="FFFFFF"/>
+                </a:solidFill>
+                <a:latin typeface="Segoe UI"/>
+              </a:defRPr>
+            </a:pPr>
+            <a:r>
+              <a:t>SOM (Serviceable Obtainable Market)</a:t>
+            </a:r>
+          </a:p>
+          <a:p>
+            <a:pPr algn="ctr">
+              <a:spcBef>
+                <a:spcPts val="500"/>
+              </a:spcBef>
+              <a:defRPr sz="950">
+                <a:solidFill>
+                  <a:srgbClr val="94A3B8"/>
+                </a:solidFill>
+                <a:latin typeface="Segoe UI"/>
+              </a:defRPr>
+            </a:pPr>
+            <a:r>
+              <a:t>Dastlabki yillarda platforma orqali qamrab olinadigan tranzaksiyalar hajmi.</a:t>
+            </a:r>
+          </a:p>
+        </p:txBody>
+      </p:sp>
+      <p:sp>
+        <p:nvSpPr>
+          <p:cNvPr id="13" name="Rounded Rectangle 12"/>
+          <p:cNvSpPr/>
+          <p:nvPr/>
+        </p:nvSpPr>
+        <p:spPr>
+          <a:xfrm>
+            <a:off x="731520" y="3931920"/>
+            <a:ext cx="10728655" cy="1828800"/>
+          </a:xfrm>
+          <a:prstGeom prst="roundRect">
+            <a:avLst/>
+          </a:prstGeom>
+          <a:solidFill>
+            <a:srgbClr val="121A2F"/>
+          </a:solidFill>
+          <a:ln w="19050">
+            <a:solidFill>
+              <a:srgbClr val="D4AF37"/>
+            </a:solidFill>
+          </a:ln>
+        </p:spPr>
+        <p:style>
+          <a:lnRef idx="1">
+            <a:schemeClr val="accent1"/>
+          </a:lnRef>
+          <a:fillRef idx="3">
+            <a:schemeClr val="accent1"/>
+          </a:fillRef>
+          <a:effectRef idx="2">
+            <a:schemeClr val="accent1"/>
+          </a:effectRef>
+          <a:fontRef idx="minor">
+            <a:schemeClr val="lt1"/>
+          </a:fontRef>
+        </p:style>
+        <p:txBody>
+          <a:bodyPr rtlCol="0" anchor="ctr"/>
+          <a:lstStyle/>
+          <a:p>
+            <a:pPr algn="ctr"/>
+          </a:p>
+        </p:txBody>
+      </p:sp>
+      <p:sp>
+        <p:nvSpPr>
+          <p:cNvPr id="14" name="TextBox 13"/>
+          <p:cNvSpPr txBox="1"/>
+          <p:nvPr/>
+        </p:nvSpPr>
+        <p:spPr>
+          <a:xfrm>
+            <a:off x="1005840" y="4114800"/>
+            <a:ext cx="10180015" cy="1463040"/>
+          </a:xfrm>
+          <a:prstGeom prst="rect">
+            <a:avLst/>
+          </a:prstGeom>
+          <a:noFill/>
+        </p:spPr>
+        <p:txBody>
+          <a:bodyPr wrap="square">
+            <a:spAutoFit/>
+          </a:bodyPr>
+          <a:lstStyle/>
+          <a:p>
+            <a:pPr>
               <a:spcAft>
-                <a:spcPts val="1000"/>
+                <a:spcPts val="600"/>
               </a:spcAft>
-              <a:defRPr sz="3200"/>
-            </a:pPr>
-            <a:r>
-              <a:t>🗣</a:t>
-            </a:r>
-          </a:p>
-          <a:p>
-            <a:pPr algn="ctr">
-              <a:spcAft>
-                <a:spcPts val="1000"/>
-              </a:spcAft>
-              <a:defRPr sz="1600" b="1">
+              <a:defRPr sz="1700" b="1">
                 <a:solidFill>
                   <a:srgbClr val="D4AF37"/>
                 </a:solidFill>
@@ -6319,12 +5028,12 @@
               </a:defRPr>
             </a:pPr>
             <a:r>
-              <a:t>Sayohat Blogerlari</a:t>
-            </a:r>
-          </a:p>
-          <a:p>
-            <a:pPr algn="ctr">
-              <a:defRPr sz="1100">
+              <a:t>⚔ Raqobat Muhiti va Bizning Ustunligimiz (USP)</a:t>
+            </a:r>
+          </a:p>
+          <a:p>
+            <a:pPr>
+              <a:defRPr sz="1150">
                 <a:solidFill>
                   <a:srgbClr val="94A3B8"/>
                 </a:solidFill>
@@ -6332,7 +5041,7 @@
               </a:defRPr>
             </a:pPr>
             <a:r>
-              <a:t>Chet ellik taniqli travel-blogerlarni taklif qilish va ularning real sayohatlarini xaritada jonli kuzatish (live tracking) orqali virusli marketing kampaniyalarini amalga oshirish.</a:t>
+              <a:t>Raqobatchilarimiz (an'anaviy turoperatorlar va ko'cha taksi xizmatlari) qimmat va rejalari qat'iy belgilangan turlarni taklif qiladilar. Bizning UZBEK-TRIP platformamiz esa sayyohlarga o'z turlarini 100% mustaqil tuzish, shaffof hisoblangan narxni ko'rish, onlayn GPS navigatsiya va n8n yordamida tezkor WhatsApp/SMS tasdiqnomaga ega bo'lish ustunligini beradi.</a:t>
             </a:r>
           </a:p>
         </p:txBody>
@@ -6461,7 +5170,7 @@
               </a:defRPr>
             </a:pPr>
             <a:r>
-              <a:t>UZBEK-TRIP (SAMARQAND CRAFTOUR)  |  HAMKORLIK TAQDIMOTI 2026</a:t>
+              <a:t>UZBEK-TRIP (SAMARQAND CRAFTOUR)  |  5-DAQIQALIK INVESTOR PITCH DECK</a:t>
             </a:r>
           </a:p>
         </p:txBody>
@@ -6521,89 +5230,21 @@
               </a:defRPr>
             </a:pPr>
             <a:r>
-              <a:t>AUDIT VA SIFAT NAZORATI TIZIMI</a:t>
-            </a:r>
-          </a:p>
-        </p:txBody>
-      </p:sp>
-      <p:sp>
-        <p:nvSpPr>
-          <p:cNvPr id="7" name="TextBox 6"/>
-          <p:cNvSpPr txBox="1"/>
-          <p:nvPr/>
-        </p:nvSpPr>
-        <p:spPr>
-          <a:xfrm>
-            <a:off x="731520" y="1645920"/>
-            <a:ext cx="4114800" cy="4114800"/>
-          </a:xfrm>
-          <a:prstGeom prst="rect">
-            <a:avLst/>
-          </a:prstGeom>
-          <a:noFill/>
-        </p:spPr>
-        <p:txBody>
-          <a:bodyPr wrap="square">
-            <a:spAutoFit/>
-          </a:bodyPr>
-          <a:lstStyle/>
-          <a:p>
-            <a:pPr>
-              <a:spcAft>
-                <a:spcPts val="1500"/>
-              </a:spcAft>
-              <a:defRPr sz="2600" b="1">
-                <a:solidFill>
-                  <a:srgbClr val="FFFFFF"/>
-                </a:solidFill>
-                <a:latin typeface="Georgia"/>
-              </a:defRPr>
-            </a:pPr>
-            <a:r>
-              <a:t>Kafolatlangan Sifat</a:t>
-            </a:r>
-          </a:p>
-          <a:p>
-            <a:pPr>
-              <a:spcAft>
-                <a:spcPts val="1500"/>
-              </a:spcAft>
-              <a:defRPr sz="1400">
-                <a:solidFill>
-                  <a:srgbClr val="94A3B8"/>
-                </a:solidFill>
-                <a:latin typeface="Segoe UI"/>
-              </a:defRPr>
-            </a:pPr>
-            <a:r>
-              <a:t>Sayohat davomida eng yuqori darajada xavfsizlik va xizmat sifatini ta'minlash maqsadida platformamizda ko'p bosqichli audit tizimi joriy qilingan.</a:t>
-            </a:r>
-          </a:p>
-          <a:p>
-            <a:pPr>
-              <a:defRPr sz="1200">
-                <a:solidFill>
-                  <a:srgbClr val="009B9E"/>
-                </a:solidFill>
-                <a:latin typeface="Segoe UI"/>
-              </a:defRPr>
-            </a:pPr>
-            <a:r>
-              <a:t>Har bir haydovchi va gid muntazam tekshiruvdan o'tkaziladi.</a:t>
-            </a:r>
-          </a:p>
-        </p:txBody>
-      </p:sp>
-      <p:sp>
-        <p:nvSpPr>
-          <p:cNvPr id="8" name="Rounded Rectangle 7"/>
+              <a:t>JAMOA VA ERISHILGAN NATIJALAR (TRACTION)</a:t>
+            </a:r>
+          </a:p>
+        </p:txBody>
+      </p:sp>
+      <p:sp>
+        <p:nvSpPr>
+          <p:cNvPr id="7" name="Rounded Rectangle 6"/>
           <p:cNvSpPr/>
           <p:nvPr/>
         </p:nvSpPr>
         <p:spPr>
           <a:xfrm>
-            <a:off x="5303520" y="1645920"/>
-            <a:ext cx="6126480" cy="1188720"/>
+            <a:off x="731520" y="1645920"/>
+            <a:ext cx="5120640" cy="4114800"/>
           </a:xfrm>
           <a:prstGeom prst="roundRect">
             <a:avLst/>
@@ -6641,14 +5282,14 @@
       </p:sp>
       <p:sp>
         <p:nvSpPr>
-          <p:cNvPr id="9" name="TextBox 8"/>
+          <p:cNvPr id="8" name="TextBox 7"/>
           <p:cNvSpPr txBox="1"/>
           <p:nvPr/>
         </p:nvSpPr>
         <p:spPr>
           <a:xfrm>
-            <a:off x="5486400" y="1737360"/>
-            <a:ext cx="5760720" cy="1005840"/>
+            <a:off x="1005840" y="1920240"/>
+            <a:ext cx="4572000" cy="3566160"/>
           </a:xfrm>
           <a:prstGeom prst="rect">
             <a:avLst/>
@@ -6662,7 +5303,10 @@
           <a:lstStyle/>
           <a:p>
             <a:pPr>
-              <a:defRPr sz="1600" b="1">
+              <a:spcAft>
+                <a:spcPts val="1500"/>
+              </a:spcAft>
+              <a:defRPr sz="2000" b="1">
                 <a:solidFill>
                   <a:srgbClr val="D4AF37"/>
                 </a:solidFill>
@@ -6670,37 +5314,93 @@
               </a:defRPr>
             </a:pPr>
             <a:r>
-              <a:t>🔒 OTP Tasdiqlash &amp; Anti-Fraud</a:t>
+              <a:t>👥 Professional Jamoa</a:t>
             </a:r>
           </a:p>
           <a:p>
             <a:pPr>
-              <a:spcBef>
-                <a:spcPts val="400"/>
-              </a:spcBef>
-              <a:defRPr sz="1150">
+              <a:spcAft>
+                <a:spcPts val="1200"/>
+              </a:spcAft>
+              <a:defRPr sz="1200" b="1">
+                <a:solidFill>
+                  <a:srgbClr val="FFFFFF"/>
+                </a:solidFill>
+                <a:latin typeface="Segoe UI"/>
+              </a:defRPr>
+            </a:pPr>
+            <a:r>
+              <a:t>• Muhriddin Bo'riboyev - </a:t>
+            </a:r>
+            <a:r>
+              <a:rPr b="0">
                 <a:solidFill>
                   <a:srgbClr val="94A3B8"/>
                 </a:solidFill>
+              </a:rPr>
+              <a:t>Founder &amp; Lead Developer. Next.js, Supabase, OSRM routing va n8n avtomatlashtirish muhandisi.</a:t>
+            </a:r>
+          </a:p>
+          <a:p>
+            <a:pPr>
+              <a:spcAft>
+                <a:spcPts val="1200"/>
+              </a:spcAft>
+              <a:defRPr sz="1200" b="1">
+                <a:solidFill>
+                  <a:srgbClr val="FFFFFF"/>
+                </a:solidFill>
                 <a:latin typeface="Segoe UI"/>
               </a:defRPr>
             </a:pPr>
             <a:r>
-              <a:t>Buyurtmani rasmiylashtirishda email/WhatsApp orqali majburiy OTP kod kiritiladi. Bu soxta buyurtmalarni 100% oldini oladi.</a:t>
-            </a:r>
-          </a:p>
-        </p:txBody>
-      </p:sp>
-      <p:sp>
-        <p:nvSpPr>
-          <p:cNvPr id="10" name="Rounded Rectangle 9"/>
+              <a:t>• Operatsion Guruh - </a:t>
+            </a:r>
+            <a:r>
+              <a:rPr b="0">
+                <a:solidFill>
+                  <a:srgbClr val="94A3B8"/>
+                </a:solidFill>
+              </a:rPr>
+              <a:t>Mehmonxonalar integratsiyasi, gidlar va haydovchilar bilan hamkorlik tarmoqlarini muvofiqlashtiruvchi operatsion menejerlar.</a:t>
+            </a:r>
+          </a:p>
+          <a:p>
+            <a:pPr>
+              <a:spcAft>
+                <a:spcPts val="1200"/>
+              </a:spcAft>
+              <a:defRPr sz="1200" b="1">
+                <a:solidFill>
+                  <a:srgbClr val="FFFFFF"/>
+                </a:solidFill>
+                <a:latin typeface="Segoe UI"/>
+              </a:defRPr>
+            </a:pPr>
+            <a:r>
+              <a:t>• Lokal Hamkorlar - </a:t>
+            </a:r>
+            <a:r>
+              <a:rPr b="0">
+                <a:solidFill>
+                  <a:srgbClr val="94A3B8"/>
+                </a:solidFill>
+              </a:rPr>
+              <a:t>Samarqand, Buxoro va Toshkent shaharlaridagi litsenziyalangan gidlar va sertifikatlangan transport uyushmalari.</a:t>
+            </a:r>
+          </a:p>
+        </p:txBody>
+      </p:sp>
+      <p:sp>
+        <p:nvSpPr>
+          <p:cNvPr id="9" name="Rounded Rectangle 8"/>
           <p:cNvSpPr/>
           <p:nvPr/>
         </p:nvSpPr>
         <p:spPr>
           <a:xfrm>
-            <a:off x="5303520" y="3017520"/>
-            <a:ext cx="6126480" cy="1188720"/>
+            <a:off x="6309360" y="1645920"/>
+            <a:ext cx="5120640" cy="4114800"/>
           </a:xfrm>
           <a:prstGeom prst="roundRect">
             <a:avLst/>
@@ -6738,14 +5438,14 @@
       </p:sp>
       <p:sp>
         <p:nvSpPr>
-          <p:cNvPr id="11" name="TextBox 10"/>
+          <p:cNvPr id="10" name="TextBox 9"/>
           <p:cNvSpPr txBox="1"/>
           <p:nvPr/>
         </p:nvSpPr>
         <p:spPr>
           <a:xfrm>
-            <a:off x="5486400" y="3108960"/>
-            <a:ext cx="5760720" cy="1005840"/>
+            <a:off x="6583680" y="1920240"/>
+            <a:ext cx="4572000" cy="3566160"/>
           </a:xfrm>
           <a:prstGeom prst="rect">
             <a:avLst/>
@@ -6759,7 +5459,10 @@
           <a:lstStyle/>
           <a:p>
             <a:pPr>
-              <a:defRPr sz="1600" b="1">
+              <a:spcAft>
+                <a:spcPts val="1500"/>
+              </a:spcAft>
+              <a:defRPr sz="2000" b="1">
                 <a:solidFill>
                   <a:srgbClr val="D4AF37"/>
                 </a:solidFill>
@@ -6767,120 +5470,103 @@
               </a:defRPr>
             </a:pPr>
             <a:r>
-              <a:t>🚗 Avtotransport Texnik Auditi</a:t>
+              <a:t>📈 Erishilgan Natijalar (Traction)</a:t>
             </a:r>
           </a:p>
           <a:p>
             <a:pPr>
-              <a:spcBef>
-                <a:spcPts val="400"/>
-              </a:spcBef>
-              <a:defRPr sz="1150">
+              <a:spcAft>
+                <a:spcPts val="800"/>
+              </a:spcAft>
+              <a:defRPr sz="1200" b="1">
+                <a:solidFill>
+                  <a:srgbClr val="009B9E"/>
+                </a:solidFill>
+                <a:latin typeface="Segoe UI"/>
+              </a:defRPr>
+            </a:pPr>
+            <a:r>
+              <a:t>✔ Ishlovchi MVP: </a:t>
+            </a:r>
+            <a:r>
+              <a:rPr b="0">
                 <a:solidFill>
                   <a:srgbClr val="94A3B8"/>
                 </a:solidFill>
+              </a:rPr>
+              <a:t>Veb platformamiz Vercel-ga joylashtirildi va to'liq foydalanishga tayyor: uzbek-trip.vercel.app</a:t>
+            </a:r>
+          </a:p>
+          <a:p>
+            <a:pPr>
+              <a:spcAft>
+                <a:spcPts val="800"/>
+              </a:spcAft>
+              <a:defRPr sz="1200" b="1">
+                <a:solidFill>
+                  <a:srgbClr val="009B9E"/>
+                </a:solidFill>
                 <a:latin typeface="Segoe UI"/>
               </a:defRPr>
             </a:pPr>
             <a:r>
-              <a:t>Hamkorlikdagi barcha transport vositalari konditsioner, tozalik va xavfsizlik kamarlari bo'yicha yillik texnik auditdan o'tadi.</a:t>
-            </a:r>
-          </a:p>
-        </p:txBody>
-      </p:sp>
-      <p:sp>
-        <p:nvSpPr>
-          <p:cNvPr id="12" name="Rounded Rectangle 11"/>
-          <p:cNvSpPr/>
-          <p:nvPr/>
-        </p:nvSpPr>
-        <p:spPr>
-          <a:xfrm>
-            <a:off x="5303520" y="4389120"/>
-            <a:ext cx="6126480" cy="1188720"/>
-          </a:xfrm>
-          <a:prstGeom prst="roundRect">
-            <a:avLst/>
-          </a:prstGeom>
-          <a:solidFill>
-            <a:srgbClr val="121A2F"/>
-          </a:solidFill>
-          <a:ln w="19050">
-            <a:solidFill>
-              <a:srgbClr val="D4AF37"/>
-            </a:solidFill>
-          </a:ln>
-        </p:spPr>
-        <p:style>
-          <a:lnRef idx="1">
-            <a:schemeClr val="accent1"/>
-          </a:lnRef>
-          <a:fillRef idx="3">
-            <a:schemeClr val="accent1"/>
-          </a:fillRef>
-          <a:effectRef idx="2">
-            <a:schemeClr val="accent1"/>
-          </a:effectRef>
-          <a:fontRef idx="minor">
-            <a:schemeClr val="lt1"/>
-          </a:fontRef>
-        </p:style>
-        <p:txBody>
-          <a:bodyPr rtlCol="0" anchor="ctr"/>
-          <a:lstStyle/>
-          <a:p>
-            <a:pPr algn="ctr"/>
-          </a:p>
-        </p:txBody>
-      </p:sp>
-      <p:sp>
-        <p:nvSpPr>
-          <p:cNvPr id="13" name="TextBox 12"/>
-          <p:cNvSpPr txBox="1"/>
-          <p:nvPr/>
-        </p:nvSpPr>
-        <p:spPr>
-          <a:xfrm>
-            <a:off x="5486400" y="4480560"/>
-            <a:ext cx="5760720" cy="1005840"/>
-          </a:xfrm>
-          <a:prstGeom prst="rect">
-            <a:avLst/>
-          </a:prstGeom>
-          <a:noFill/>
-        </p:spPr>
-        <p:txBody>
-          <a:bodyPr wrap="square">
-            <a:spAutoFit/>
-          </a:bodyPr>
-          <a:lstStyle/>
+              <a:t>✔ OSRM va GPS Navigatsiyasi: </a:t>
+            </a:r>
+            <a:r>
+              <a:rPr b="0">
+                <a:solidFill>
+                  <a:srgbClr val="94A3B8"/>
+                </a:solidFill>
+              </a:rPr>
+              <a:t>Xaritada yo'l tarmog'i bo'yicha marshrut hisoblash, live navigatsiya va virtual sayohat simulyatori joriy qilindi.</a:t>
+            </a:r>
+          </a:p>
           <a:p>
             <a:pPr>
-              <a:defRPr sz="1600" b="1">
-                <a:solidFill>
-                  <a:srgbClr val="D4AF37"/>
-                </a:solidFill>
-                <a:latin typeface="Georgia"/>
-              </a:defRPr>
-            </a:pPr>
-            <a:r>
-              <a:t>🗣 Gidlar Litsenziya Nazorati</a:t>
+              <a:spcAft>
+                <a:spcPts val="800"/>
+              </a:spcAft>
+              <a:defRPr sz="1200" b="1">
+                <a:solidFill>
+                  <a:srgbClr val="009B9E"/>
+                </a:solidFill>
+                <a:latin typeface="Segoe UI"/>
+              </a:defRPr>
+            </a:pPr>
+            <a:r>
+              <a:t>✔ n8n Avtomatizatsiyasi: </a:t>
+            </a:r>
+            <a:r>
+              <a:rPr b="0">
+                <a:solidFill>
+                  <a:srgbClr val="94A3B8"/>
+                </a:solidFill>
+              </a:rPr>
+              <a:t>Sayohat buyurtmalarini operatsion tasdiqlash va haydovchi/gidlarga WhatsApp orqali yetkazish moduli sinovdan o'tdi.</a:t>
             </a:r>
           </a:p>
           <a:p>
             <a:pPr>
-              <a:spcBef>
-                <a:spcPts val="400"/>
-              </a:spcBef>
-              <a:defRPr sz="1150">
+              <a:spcAft>
+                <a:spcPts val="800"/>
+              </a:spcAft>
+              <a:defRPr sz="1200" b="1">
+                <a:solidFill>
+                  <a:srgbClr val="009B9E"/>
+                </a:solidFill>
+                <a:latin typeface="Segoe UI"/>
+              </a:defRPr>
+            </a:pPr>
+            <a:r>
+              <a:t>✔ B2B Hamkorlik Kelishuvlari: </a:t>
+            </a:r>
+            <a:r>
+              <a:rPr b="0">
                 <a:solidFill>
                   <a:srgbClr val="94A3B8"/>
                 </a:solidFill>
-                <a:latin typeface="Segoe UI"/>
-              </a:defRPr>
-            </a:pPr>
-            <a:r>
-              <a:t>Tizimga faqat davlat tomonidan litsenziyalangan, chet tillarini bilish darajasi tasdiqlangan professional gidlar jalb etiladi.</a:t>
+              </a:rPr>
+              <a:t>Toshkent va Samarqand shahridagi dastlabki mehmonxonalar va gidlar bilan integratsiya bo'yicha kelishuvlar.</a:t>
             </a:r>
           </a:p>
         </p:txBody>
@@ -7009,7 +5695,7 @@
               </a:defRPr>
             </a:pPr>
             <a:r>
-              <a:t>UZBEK-TRIP (SAMARQAND CRAFTOUR)  |  HAMKORLIK TAQDIMOTI 2026</a:t>
+              <a:t>UZBEK-TRIP (SAMARQAND CRAFTOUR)  |  5-DAQIQALIK INVESTOR PITCH DECK</a:t>
             </a:r>
           </a:p>
         </p:txBody>
@@ -7069,7 +5755,7 @@
               </a:defRPr>
             </a:pPr>
             <a:r>
-              <a:t>IQTISODIY YONDASHUV VA UNIT-IQTISODIYOT</a:t>
+              <a:t>BIZNES MODEL VA STRATEGIK KELAJAK</a:t>
             </a:r>
           </a:p>
         </p:txBody>
@@ -7083,7 +5769,7 @@
         <p:spPr>
           <a:xfrm>
             <a:off x="731520" y="1645920"/>
-            <a:ext cx="3291840" cy="2011680"/>
+            <a:ext cx="3291840" cy="4114800"/>
           </a:xfrm>
           <a:prstGeom prst="roundRect">
             <a:avLst/>
@@ -7093,7 +5779,7 @@
           </a:solidFill>
           <a:ln w="19050">
             <a:solidFill>
-              <a:srgbClr val="009B9E"/>
+              <a:srgbClr val="D4AF37"/>
             </a:solidFill>
           </a:ln>
         </p:spPr>
@@ -7127,8 +5813,8 @@
         </p:nvSpPr>
         <p:spPr>
           <a:xfrm>
-            <a:off x="914400" y="1783080"/>
-            <a:ext cx="2926080" cy="1737360"/>
+            <a:off x="914400" y="1828800"/>
+            <a:ext cx="2926080" cy="3749040"/>
           </a:xfrm>
           <a:prstGeom prst="rect">
             <a:avLst/>
@@ -7141,8 +5827,11 @@
           </a:bodyPr>
           <a:lstStyle/>
           <a:p>
-            <a:pPr algn="ctr">
-              <a:defRPr sz="4800" b="1">
+            <a:pPr>
+              <a:spcAft>
+                <a:spcPts val="1000"/>
+              </a:spcAft>
+              <a:defRPr sz="1800" b="1">
                 <a:solidFill>
                   <a:srgbClr val="D4AF37"/>
                 </a:solidFill>
@@ -7150,31 +5839,63 @@
               </a:defRPr>
             </a:pPr>
             <a:r>
-              <a:t>15%</a:t>
-            </a:r>
-          </a:p>
-          <a:p>
-            <a:pPr algn="ctr">
-              <a:spcBef>
+              <a:t>Komissiya &amp; Daromad</a:t>
+            </a:r>
+          </a:p>
+          <a:p>
+            <a:pPr>
+              <a:spcAft>
+                <a:spcPts val="1000"/>
+              </a:spcAft>
+              <a:defRPr sz="2000" b="1">
+                <a:solidFill>
+                  <a:srgbClr val="009B9E"/>
+                </a:solidFill>
+                <a:latin typeface="Georgia"/>
+              </a:defRPr>
+            </a:pPr>
+            <a:r>
+              <a:t>15% platforma ulushi</a:t>
+            </a:r>
+          </a:p>
+          <a:p>
+            <a:pPr>
+              <a:spcAft>
+                <a:spcPts val="1500"/>
+              </a:spcAft>
+              <a:defRPr sz="1150">
+                <a:solidFill>
+                  <a:srgbClr val="FFFFFF"/>
+                </a:solidFill>
+                <a:latin typeface="Segoe UI"/>
+              </a:defRPr>
+            </a:pPr>
+            <a:r>
+              <a:t>Platforma orqali band qilingan har bir transport va gid xizmatlaridan 15% tranzaksion komissiya to'lovi olinadi. O'rtacha buyurtma qiymati $120.</a:t>
+            </a:r>
+          </a:p>
+          <a:p>
+            <a:pPr>
+              <a:spcAft>
                 <a:spcPts val="500"/>
-              </a:spcBef>
-              <a:defRPr sz="1300" b="1">
-                <a:solidFill>
-                  <a:srgbClr val="FFFFFF"/>
+              </a:spcAft>
+              <a:defRPr sz="1100">
+                <a:solidFill>
+                  <a:srgbClr val="94A3B8"/>
                 </a:solidFill>
                 <a:latin typeface="Segoe UI"/>
               </a:defRPr>
             </a:pPr>
             <a:r>
-              <a:t>Platforma Komissiyasi</a:t>
-            </a:r>
-          </a:p>
-          <a:p>
-            <a:pPr algn="ctr">
-              <a:spcBef>
+              <a:t>• 15% gid va transport komissiyasi</a:t>
+            </a:r>
+          </a:p>
+          <a:p>
+            <a:pPr>
+              <a:spcAft>
                 <a:spcPts val="500"/>
-              </a:spcBef>
-              <a:defRPr sz="1000">
+              </a:spcAft>
+              <a:defRPr sz="1100">
                 <a:solidFill>
                   <a:srgbClr val="94A3B8"/>
                 </a:solidFill>
@@ -7182,7 +5903,7 @@
               </a:defRPr>
             </a:pPr>
             <a:r>
-              <a:t>Gidlar, haydovchilar va restoranlar to'lovlaridan platforma foydasi.</a:t>
+              <a:t>• Mehmonxona va restoran keshbeklari</a:t>
             </a:r>
           </a:p>
         </p:txBody>
@@ -7196,7 +5917,7 @@
         <p:spPr>
           <a:xfrm>
             <a:off x="4389120" y="1645920"/>
-            <a:ext cx="3291840" cy="2011680"/>
+            <a:ext cx="3291840" cy="4114800"/>
           </a:xfrm>
           <a:prstGeom prst="roundRect">
             <a:avLst/>
@@ -7206,7 +5927,7 @@
           </a:solidFill>
           <a:ln w="19050">
             <a:solidFill>
-              <a:srgbClr val="009B9E"/>
+              <a:srgbClr val="D4AF37"/>
             </a:solidFill>
           </a:ln>
         </p:spPr>
@@ -7240,8 +5961,8 @@
         </p:nvSpPr>
         <p:spPr>
           <a:xfrm>
-            <a:off x="4572000" y="1783080"/>
-            <a:ext cx="2926080" cy="1737360"/>
+            <a:off x="4572000" y="1828800"/>
+            <a:ext cx="2926080" cy="3749040"/>
           </a:xfrm>
           <a:prstGeom prst="rect">
             <a:avLst/>
@@ -7254,8 +5975,11 @@
           </a:bodyPr>
           <a:lstStyle/>
           <a:p>
-            <a:pPr algn="ctr">
-              <a:defRPr sz="4800" b="1">
+            <a:pPr>
+              <a:spcAft>
+                <a:spcPts val="1000"/>
+              </a:spcAft>
+              <a:defRPr sz="1800" b="1">
                 <a:solidFill>
                   <a:srgbClr val="D4AF37"/>
                 </a:solidFill>
@@ -7263,31 +5987,63 @@
               </a:defRPr>
             </a:pPr>
             <a:r>
-              <a:t>$120</a:t>
-            </a:r>
-          </a:p>
-          <a:p>
-            <a:pPr algn="ctr">
-              <a:spcBef>
+              <a:t>UzRailways API Integratsiya</a:t>
+            </a:r>
+          </a:p>
+          <a:p>
+            <a:pPr>
+              <a:spcAft>
+                <a:spcPts val="1000"/>
+              </a:spcAft>
+              <a:defRPr sz="2000" b="1">
+                <a:solidFill>
+                  <a:srgbClr val="009B9E"/>
+                </a:solidFill>
+                <a:latin typeface="Georgia"/>
+              </a:defRPr>
+            </a:pPr>
+            <a:r>
+              <a:t>Kelasi reja: chiptalar</a:t>
+            </a:r>
+          </a:p>
+          <a:p>
+            <a:pPr>
+              <a:spcAft>
+                <a:spcPts val="1500"/>
+              </a:spcAft>
+              <a:defRPr sz="1150">
+                <a:solidFill>
+                  <a:srgbClr val="FFFFFF"/>
+                </a:solidFill>
+                <a:latin typeface="Segoe UI"/>
+              </a:defRPr>
+            </a:pPr>
+            <a:r>
+              <a:t>Kelgusi oylarda sayyohlar uchun platformaning o'zida Afrosiyob tezyurar poyezdi va avia-chiptalarni birdan xarid qilish tizimi qo'shiladi.</a:t>
+            </a:r>
+          </a:p>
+          <a:p>
+            <a:pPr>
+              <a:spcAft>
                 <a:spcPts val="500"/>
-              </a:spcBef>
-              <a:defRPr sz="1300" b="1">
-                <a:solidFill>
-                  <a:srgbClr val="FFFFFF"/>
+              </a:spcAft>
+              <a:defRPr sz="1100">
+                <a:solidFill>
+                  <a:srgbClr val="94A3B8"/>
                 </a:solidFill>
                 <a:latin typeface="Segoe UI"/>
               </a:defRPr>
             </a:pPr>
             <a:r>
-              <a:t>O'rtacha Buyurtma Narxi</a:t>
-            </a:r>
-          </a:p>
-          <a:p>
-            <a:pPr algn="ctr">
-              <a:spcBef>
+              <a:t>• Afrosiyob poyezd chiptalari</a:t>
+            </a:r>
+          </a:p>
+          <a:p>
+            <a:pPr>
+              <a:spcAft>
                 <a:spcPts val="500"/>
-              </a:spcBef>
-              <a:defRPr sz="1000">
+              </a:spcAft>
+              <a:defRPr sz="1100">
                 <a:solidFill>
                   <a:srgbClr val="94A3B8"/>
                 </a:solidFill>
@@ -7295,7 +6051,7 @@
               </a:defRPr>
             </a:pPr>
             <a:r>
-              <a:t>1 sayohat davomida bitta sayyoh tomonidan transport va gidlar uchun qilinadigan xarajat.</a:t>
+              <a:t>• Lokal aviareys integratsiyasi</a:t>
             </a:r>
           </a:p>
         </p:txBody>
@@ -7309,7 +6065,7 @@
         <p:spPr>
           <a:xfrm>
             <a:off x="8046720" y="1645920"/>
-            <a:ext cx="3291840" cy="2011680"/>
+            <a:ext cx="3291840" cy="4114800"/>
           </a:xfrm>
           <a:prstGeom prst="roundRect">
             <a:avLst/>
@@ -7319,7 +6075,7 @@
           </a:solidFill>
           <a:ln w="19050">
             <a:solidFill>
-              <a:srgbClr val="009B9E"/>
+              <a:srgbClr val="D4AF37"/>
             </a:solidFill>
           </a:ln>
         </p:spPr>
@@ -7353,8 +6109,8 @@
         </p:nvSpPr>
         <p:spPr>
           <a:xfrm>
-            <a:off x="8229600" y="1783080"/>
-            <a:ext cx="2926080" cy="1737360"/>
+            <a:off x="8229600" y="1828800"/>
+            <a:ext cx="2926080" cy="3749040"/>
           </a:xfrm>
           <a:prstGeom prst="rect">
             <a:avLst/>
@@ -7367,122 +6123,9 @@
           </a:bodyPr>
           <a:lstStyle/>
           <a:p>
-            <a:pPr algn="ctr">
-              <a:defRPr sz="4800" b="1">
-                <a:solidFill>
-                  <a:srgbClr val="D4AF37"/>
-                </a:solidFill>
-                <a:latin typeface="Georgia"/>
-              </a:defRPr>
-            </a:pPr>
-            <a:r>
-              <a:t>$18</a:t>
-            </a:r>
-          </a:p>
-          <a:p>
-            <a:pPr algn="ctr">
-              <a:spcBef>
-                <a:spcPts val="500"/>
-              </a:spcBef>
-              <a:defRPr sz="1300" b="1">
-                <a:solidFill>
-                  <a:srgbClr val="FFFFFF"/>
-                </a:solidFill>
-                <a:latin typeface="Segoe UI"/>
-              </a:defRPr>
-            </a:pPr>
-            <a:r>
-              <a:t>Mijozdan Olinadigan Sof Foyda</a:t>
-            </a:r>
-          </a:p>
-          <a:p>
-            <a:pPr algn="ctr">
-              <a:spcBef>
-                <a:spcPts val="500"/>
-              </a:spcBef>
-              <a:defRPr sz="1000">
-                <a:solidFill>
-                  <a:srgbClr val="94A3B8"/>
-                </a:solidFill>
-                <a:latin typeface="Segoe UI"/>
-              </a:defRPr>
-            </a:pPr>
-            <a:r>
-              <a:t>Har bir jalb etilgan sayyohdan komissiya hisobiga platformaga tushadigan o'rtacha foyda.</a:t>
-            </a:r>
-          </a:p>
-        </p:txBody>
-      </p:sp>
-      <p:sp>
-        <p:nvSpPr>
-          <p:cNvPr id="13" name="Rounded Rectangle 12"/>
-          <p:cNvSpPr/>
-          <p:nvPr/>
-        </p:nvSpPr>
-        <p:spPr>
-          <a:xfrm>
-            <a:off x="731520" y="3931920"/>
-            <a:ext cx="10728655" cy="1828800"/>
-          </a:xfrm>
-          <a:prstGeom prst="roundRect">
-            <a:avLst/>
-          </a:prstGeom>
-          <a:solidFill>
-            <a:srgbClr val="121A2F"/>
-          </a:solidFill>
-          <a:ln w="19050">
-            <a:solidFill>
-              <a:srgbClr val="D4AF37"/>
-            </a:solidFill>
-          </a:ln>
-        </p:spPr>
-        <p:style>
-          <a:lnRef idx="1">
-            <a:schemeClr val="accent1"/>
-          </a:lnRef>
-          <a:fillRef idx="3">
-            <a:schemeClr val="accent1"/>
-          </a:fillRef>
-          <a:effectRef idx="2">
-            <a:schemeClr val="accent1"/>
-          </a:effectRef>
-          <a:fontRef idx="minor">
-            <a:schemeClr val="lt1"/>
-          </a:fontRef>
-        </p:style>
-        <p:txBody>
-          <a:bodyPr rtlCol="0" anchor="ctr"/>
-          <a:lstStyle/>
-          <a:p>
-            <a:pPr algn="ctr"/>
-          </a:p>
-        </p:txBody>
-      </p:sp>
-      <p:sp>
-        <p:nvSpPr>
-          <p:cNvPr id="14" name="TextBox 13"/>
-          <p:cNvSpPr txBox="1"/>
-          <p:nvPr/>
-        </p:nvSpPr>
-        <p:spPr>
-          <a:xfrm>
-            <a:off x="1005840" y="4114800"/>
-            <a:ext cx="10180015" cy="1463040"/>
-          </a:xfrm>
-          <a:prstGeom prst="rect">
-            <a:avLst/>
-          </a:prstGeom>
-          <a:noFill/>
-        </p:spPr>
-        <p:txBody>
-          <a:bodyPr wrap="square">
-            <a:spAutoFit/>
-          </a:bodyPr>
-          <a:lstStyle/>
-          <a:p>
             <a:pPr>
               <a:spcAft>
-                <a:spcPts val="600"/>
+                <a:spcPts val="1000"/>
               </a:spcAft>
               <a:defRPr sz="1800" b="1">
                 <a:solidFill>
@@ -7492,12 +6135,47 @@
               </a:defRPr>
             </a:pPr>
             <a:r>
-              <a:t>🎯 Past CAC (Mijozni jalb qilish narxi) va Yuqori ROI</a:t>
+              <a:t>Hududiy Kengayish</a:t>
             </a:r>
           </a:p>
           <a:p>
             <a:pPr>
-              <a:defRPr sz="1200">
+              <a:spcAft>
+                <a:spcPts val="1000"/>
+              </a:spcAft>
+              <a:defRPr sz="2000" b="1">
+                <a:solidFill>
+                  <a:srgbClr val="009B9E"/>
+                </a:solidFill>
+                <a:latin typeface="Georgia"/>
+              </a:defRPr>
+            </a:pPr>
+            <a:r>
+              <a:t>Kelasi reja: kengayish</a:t>
+            </a:r>
+          </a:p>
+          <a:p>
+            <a:pPr>
+              <a:spcAft>
+                <a:spcPts val="1500"/>
+              </a:spcAft>
+              <a:defRPr sz="1150">
+                <a:solidFill>
+                  <a:srgbClr val="FFFFFF"/>
+                </a:solidFill>
+                <a:latin typeface="Segoe UI"/>
+              </a:defRPr>
+            </a:pPr>
+            <a:r>
+              <a:t>Platformani Samarqanddan so'ng Toshkent, Buxoro, Xiva va Qoraqalpog'iston viloyatlariga to'liq moslashtirish va sayohatlarni viloyatlararo ulash.</a:t>
+            </a:r>
+          </a:p>
+          <a:p>
+            <a:pPr>
+              <a:spcAft>
+                <a:spcPts val="500"/>
+              </a:spcAft>
+              <a:defRPr sz="1100">
                 <a:solidFill>
                   <a:srgbClr val="94A3B8"/>
                 </a:solidFill>
@@ -7505,7 +6183,23 @@
               </a:defRPr>
             </a:pPr>
             <a:r>
-              <a:t>Bizning marketing modelimiz bevosita mehmonxonalar, QR-kod integratsiyalari va organik qidiruvga asoslangan. Shu sababli mijozni jalb qilish tannarxi (CAC) o'rtacha $2-$3 ni tashkil etadi. Bu esa har bir buyurtmadan kamida 6 barobar sof daromad (ROI) olishni ta'minlaydi.</a:t>
+              <a:t>• Buxoro, Xiva va Toshkent</a:t>
+            </a:r>
+          </a:p>
+          <a:p>
+            <a:pPr>
+              <a:spcAft>
+                <a:spcPts val="500"/>
+              </a:spcAft>
+              <a:defRPr sz="1100">
+                <a:solidFill>
+                  <a:srgbClr val="94A3B8"/>
+                </a:solidFill>
+                <a:latin typeface="Segoe UI"/>
+              </a:defRPr>
+            </a:pPr>
+            <a:r>
+              <a:t>• Viloyatlararo turlar</a:t>
             </a:r>
           </a:p>
         </p:txBody>
@@ -7634,7 +6328,7 @@
               </a:defRPr>
             </a:pPr>
             <a:r>
-              <a:t>UZBEK-TRIP (SAMARQAND CRAFTOUR)  |  HAMKORLIK TAQDIMOTI 2026</a:t>
+              <a:t>UZBEK-TRIP (SAMARQAND CRAFTOUR)  |  5-DAQIQALIK INVESTOR PITCH DECK</a:t>
             </a:r>
           </a:p>
         </p:txBody>
@@ -7665,58 +6359,22 @@
       </p:pic>
       <p:sp>
         <p:nvSpPr>
-          <p:cNvPr id="6" name="TextBox 5"/>
-          <p:cNvSpPr txBox="1"/>
-          <p:nvPr/>
-        </p:nvSpPr>
-        <p:spPr>
-          <a:xfrm>
-            <a:off x="731520" y="457200"/>
-            <a:ext cx="10728655" cy="731520"/>
-          </a:xfrm>
-          <a:prstGeom prst="rect">
-            <a:avLst/>
-          </a:prstGeom>
-          <a:noFill/>
-        </p:spPr>
-        <p:txBody>
-          <a:bodyPr wrap="square" lIns="0" rIns="0" tIns="0" bIns="0">
-            <a:spAutoFit/>
-          </a:bodyPr>
-          <a:lstStyle/>
-          <a:p>
-            <a:pPr>
-              <a:defRPr sz="3000" b="1">
-                <a:solidFill>
-                  <a:srgbClr val="D4AF37"/>
-                </a:solidFill>
-                <a:latin typeface="Georgia"/>
-              </a:defRPr>
-            </a:pPr>
-            <a:r>
-              <a:t>MOLIYAVIY PROYEKSIYALAR VA KO'RSATKICHLAR</a:t>
-            </a:r>
-          </a:p>
-        </p:txBody>
-      </p:sp>
-      <p:sp>
-        <p:nvSpPr>
-          <p:cNvPr id="7" name="Rounded Rectangle 6"/>
+          <p:cNvPr id="6" name="Rectangle 5"/>
           <p:cNvSpPr/>
           <p:nvPr/>
         </p:nvSpPr>
         <p:spPr>
           <a:xfrm>
-            <a:off x="731520" y="1645920"/>
-            <a:ext cx="3291840" cy="4114800"/>
-          </a:xfrm>
-          <a:prstGeom prst="roundRect">
+            <a:off x="1828800" y="1371600"/>
+            <a:ext cx="8534095" cy="4114800"/>
+          </a:xfrm>
+          <a:prstGeom prst="rect">
             <a:avLst/>
           </a:prstGeom>
           <a:solidFill>
             <a:srgbClr val="121A2F"/>
           </a:solidFill>
-          <a:ln w="19050">
+          <a:ln w="25400">
             <a:solidFill>
               <a:srgbClr val="D4AF37"/>
             </a:solidFill>
@@ -7746,14 +6404,14 @@
       </p:sp>
       <p:sp>
         <p:nvSpPr>
-          <p:cNvPr id="8" name="TextBox 7"/>
+          <p:cNvPr id="7" name="TextBox 6"/>
           <p:cNvSpPr txBox="1"/>
           <p:nvPr/>
         </p:nvSpPr>
         <p:spPr>
           <a:xfrm>
-            <a:off x="914400" y="1828800"/>
-            <a:ext cx="2926080" cy="3749040"/>
+            <a:off x="2286000" y="1828800"/>
+            <a:ext cx="7619695" cy="3200400"/>
           </a:xfrm>
           <a:prstGeom prst="rect">
             <a:avLst/>
@@ -7766,1160 +6424,7 @@
           </a:bodyPr>
           <a:lstStyle/>
           <a:p>
-            <a:pPr>
-              <a:spcAft>
-                <a:spcPts val="1000"/>
-              </a:spcAft>
-              <a:defRPr sz="1800" b="1">
-                <a:solidFill>
-                  <a:srgbClr val="D4AF37"/>
-                </a:solidFill>
-                <a:latin typeface="Georgia"/>
-              </a:defRPr>
-            </a:pPr>
-            <a:r>
-              <a:t>2026-yil (Samarqand)</a:t>
-            </a:r>
-          </a:p>
-          <a:p>
-            <a:pPr>
-              <a:spcAft>
-                <a:spcPts val="1000"/>
-              </a:spcAft>
-              <a:defRPr sz="2200" b="1">
-                <a:solidFill>
-                  <a:srgbClr val="009B9E"/>
-                </a:solidFill>
-                <a:latin typeface="Georgia"/>
-              </a:defRPr>
-            </a:pPr>
-            <a:r>
-              <a:t>$150,000</a:t>
-            </a:r>
-          </a:p>
-          <a:p>
-            <a:pPr>
-              <a:spcAft>
-                <a:spcPts val="1500"/>
-              </a:spcAft>
-              <a:defRPr sz="1200">
-                <a:solidFill>
-                  <a:srgbClr val="FFFFFF"/>
-                </a:solidFill>
-                <a:latin typeface="Segoe UI"/>
-              </a:defRPr>
-            </a:pPr>
-            <a:r>
-              <a:t>Samarqand shahrida loyihani to'liq yo'lga qo'yish va 10,000 dan ortiq turlarni muvaffaqiyatli band qilish.</a:t>
-            </a:r>
-          </a:p>
-          <a:p>
-            <a:pPr>
-              <a:spcAft>
-                <a:spcPts val="500"/>
-              </a:spcAft>
-              <a:defRPr sz="1100">
-                <a:solidFill>
-                  <a:srgbClr val="94A3B8"/>
-                </a:solidFill>
-                <a:latin typeface="Segoe UI"/>
-              </a:defRPr>
-            </a:pPr>
-            <a:r>
-              <a:t>• 150+ gid va haydovchilar tarmog'i.</a:t>
-            </a:r>
-          </a:p>
-          <a:p>
-            <a:pPr>
-              <a:spcAft>
-                <a:spcPts val="500"/>
-              </a:spcAft>
-              <a:defRPr sz="1100">
-                <a:solidFill>
-                  <a:srgbClr val="94A3B8"/>
-                </a:solidFill>
-                <a:latin typeface="Segoe UI"/>
-              </a:defRPr>
-            </a:pPr>
-            <a:r>
-              <a:t>• O'rtacha aylanma: $1.2 Million.</a:t>
-            </a:r>
-          </a:p>
-        </p:txBody>
-      </p:sp>
-      <p:sp>
-        <p:nvSpPr>
-          <p:cNvPr id="9" name="Rounded Rectangle 8"/>
-          <p:cNvSpPr/>
-          <p:nvPr/>
-        </p:nvSpPr>
-        <p:spPr>
-          <a:xfrm>
-            <a:off x="4389120" y="1645920"/>
-            <a:ext cx="3291840" cy="4114800"/>
-          </a:xfrm>
-          <a:prstGeom prst="roundRect">
-            <a:avLst/>
-          </a:prstGeom>
-          <a:solidFill>
-            <a:srgbClr val="121A2F"/>
-          </a:solidFill>
-          <a:ln w="19050">
-            <a:solidFill>
-              <a:srgbClr val="D4AF37"/>
-            </a:solidFill>
-          </a:ln>
-        </p:spPr>
-        <p:style>
-          <a:lnRef idx="1">
-            <a:schemeClr val="accent1"/>
-          </a:lnRef>
-          <a:fillRef idx="3">
-            <a:schemeClr val="accent1"/>
-          </a:fillRef>
-          <a:effectRef idx="2">
-            <a:schemeClr val="accent1"/>
-          </a:effectRef>
-          <a:fontRef idx="minor">
-            <a:schemeClr val="lt1"/>
-          </a:fontRef>
-        </p:style>
-        <p:txBody>
-          <a:bodyPr rtlCol="0" anchor="ctr"/>
-          <a:lstStyle/>
-          <a:p>
-            <a:pPr algn="ctr"/>
-          </a:p>
-        </p:txBody>
-      </p:sp>
-      <p:sp>
-        <p:nvSpPr>
-          <p:cNvPr id="10" name="TextBox 9"/>
-          <p:cNvSpPr txBox="1"/>
-          <p:nvPr/>
-        </p:nvSpPr>
-        <p:spPr>
-          <a:xfrm>
-            <a:off x="4572000" y="1828800"/>
-            <a:ext cx="2926080" cy="3749040"/>
-          </a:xfrm>
-          <a:prstGeom prst="rect">
-            <a:avLst/>
-          </a:prstGeom>
-          <a:noFill/>
-        </p:spPr>
-        <p:txBody>
-          <a:bodyPr wrap="square">
-            <a:spAutoFit/>
-          </a:bodyPr>
-          <a:lstStyle/>
-          <a:p>
-            <a:pPr>
-              <a:spcAft>
-                <a:spcPts val="1000"/>
-              </a:spcAft>
-              <a:defRPr sz="1800" b="1">
-                <a:solidFill>
-                  <a:srgbClr val="D4AF37"/>
-                </a:solidFill>
-                <a:latin typeface="Georgia"/>
-              </a:defRPr>
-            </a:pPr>
-            <a:r>
-              <a:t>2027-yil (Kengayish)</a:t>
-            </a:r>
-          </a:p>
-          <a:p>
-            <a:pPr>
-              <a:spcAft>
-                <a:spcPts val="1000"/>
-              </a:spcAft>
-              <a:defRPr sz="2200" b="1">
-                <a:solidFill>
-                  <a:srgbClr val="009B9E"/>
-                </a:solidFill>
-                <a:latin typeface="Georgia"/>
-              </a:defRPr>
-            </a:pPr>
-            <a:r>
-              <a:t>$600,000</a:t>
-            </a:r>
-          </a:p>
-          <a:p>
-            <a:pPr>
-              <a:spcAft>
-                <a:spcPts val="1500"/>
-              </a:spcAft>
-              <a:defRPr sz="1200">
-                <a:solidFill>
-                  <a:srgbClr val="FFFFFF"/>
-                </a:solidFill>
-                <a:latin typeface="Segoe UI"/>
-              </a:defRPr>
-            </a:pPr>
-            <a:r>
-              <a:t>Toshkent, Buxoro, Xiva va Qoraqalpog'iston shaharlarini integratsiya qilish hamda turlarni ko'paytirish.</a:t>
-            </a:r>
-          </a:p>
-          <a:p>
-            <a:pPr>
-              <a:spcAft>
-                <a:spcPts val="500"/>
-              </a:spcAft>
-              <a:defRPr sz="1100">
-                <a:solidFill>
-                  <a:srgbClr val="94A3B8"/>
-                </a:solidFill>
-                <a:latin typeface="Segoe UI"/>
-              </a:defRPr>
-            </a:pPr>
-            <a:r>
-              <a:t>• 600+ gid va haydovchilar tarmog'i.</a:t>
-            </a:r>
-          </a:p>
-          <a:p>
-            <a:pPr>
-              <a:spcAft>
-                <a:spcPts val="500"/>
-              </a:spcAft>
-              <a:defRPr sz="1100">
-                <a:solidFill>
-                  <a:srgbClr val="94A3B8"/>
-                </a:solidFill>
-                <a:latin typeface="Segoe UI"/>
-              </a:defRPr>
-            </a:pPr>
-            <a:r>
-              <a:t>• B2B va mehmonxonalar bilan hamkorlik.</a:t>
-            </a:r>
-          </a:p>
-        </p:txBody>
-      </p:sp>
-      <p:sp>
-        <p:nvSpPr>
-          <p:cNvPr id="11" name="Rounded Rectangle 10"/>
-          <p:cNvSpPr/>
-          <p:nvPr/>
-        </p:nvSpPr>
-        <p:spPr>
-          <a:xfrm>
-            <a:off x="8046720" y="1645920"/>
-            <a:ext cx="3291840" cy="4114800"/>
-          </a:xfrm>
-          <a:prstGeom prst="roundRect">
-            <a:avLst/>
-          </a:prstGeom>
-          <a:solidFill>
-            <a:srgbClr val="121A2F"/>
-          </a:solidFill>
-          <a:ln w="19050">
-            <a:solidFill>
-              <a:srgbClr val="D4AF37"/>
-            </a:solidFill>
-          </a:ln>
-        </p:spPr>
-        <p:style>
-          <a:lnRef idx="1">
-            <a:schemeClr val="accent1"/>
-          </a:lnRef>
-          <a:fillRef idx="3">
-            <a:schemeClr val="accent1"/>
-          </a:fillRef>
-          <a:effectRef idx="2">
-            <a:schemeClr val="accent1"/>
-          </a:effectRef>
-          <a:fontRef idx="minor">
-            <a:schemeClr val="lt1"/>
-          </a:fontRef>
-        </p:style>
-        <p:txBody>
-          <a:bodyPr rtlCol="0" anchor="ctr"/>
-          <a:lstStyle/>
-          <a:p>
-            <a:pPr algn="ctr"/>
-          </a:p>
-        </p:txBody>
-      </p:sp>
-      <p:sp>
-        <p:nvSpPr>
-          <p:cNvPr id="12" name="TextBox 11"/>
-          <p:cNvSpPr txBox="1"/>
-          <p:nvPr/>
-        </p:nvSpPr>
-        <p:spPr>
-          <a:xfrm>
-            <a:off x="8229600" y="1828800"/>
-            <a:ext cx="2926080" cy="3749040"/>
-          </a:xfrm>
-          <a:prstGeom prst="rect">
-            <a:avLst/>
-          </a:prstGeom>
-          <a:noFill/>
-        </p:spPr>
-        <p:txBody>
-          <a:bodyPr wrap="square">
-            <a:spAutoFit/>
-          </a:bodyPr>
-          <a:lstStyle/>
-          <a:p>
-            <a:pPr>
-              <a:spcAft>
-                <a:spcPts val="1000"/>
-              </a:spcAft>
-              <a:defRPr sz="1800" b="1">
-                <a:solidFill>
-                  <a:srgbClr val="D4AF37"/>
-                </a:solidFill>
-                <a:latin typeface="Georgia"/>
-              </a:defRPr>
-            </a:pPr>
-            <a:r>
-              <a:t>2028-yil (Milliy Lider)</a:t>
-            </a:r>
-          </a:p>
-          <a:p>
-            <a:pPr>
-              <a:spcAft>
-                <a:spcPts val="1000"/>
-              </a:spcAft>
-              <a:defRPr sz="2200" b="1">
-                <a:solidFill>
-                  <a:srgbClr val="009B9E"/>
-                </a:solidFill>
-                <a:latin typeface="Georgia"/>
-              </a:defRPr>
-            </a:pPr>
-            <a:r>
-              <a:t>$1,800,000</a:t>
-            </a:r>
-          </a:p>
-          <a:p>
-            <a:pPr>
-              <a:spcAft>
-                <a:spcPts val="1500"/>
-              </a:spcAft>
-              <a:defRPr sz="1200">
-                <a:solidFill>
-                  <a:srgbClr val="FFFFFF"/>
-                </a:solidFill>
-                <a:latin typeface="Segoe UI"/>
-              </a:defRPr>
-            </a:pPr>
-            <a:r>
-              <a:t>O'zbekistondagi eng yirik mustaqil shaxsiy sayohat konstruktoriga aylanish va super-app integratsiyasi.</a:t>
-            </a:r>
-          </a:p>
-          <a:p>
-            <a:pPr>
-              <a:spcAft>
-                <a:spcPts val="500"/>
-              </a:spcAft>
-              <a:defRPr sz="1100">
-                <a:solidFill>
-                  <a:srgbClr val="94A3B8"/>
-                </a:solidFill>
-                <a:latin typeface="Segoe UI"/>
-              </a:defRPr>
-            </a:pPr>
-            <a:r>
-              <a:t>• 2,000+ hamkorlar tarmog'i.</a:t>
-            </a:r>
-          </a:p>
-          <a:p>
-            <a:pPr>
-              <a:spcAft>
-                <a:spcPts val="500"/>
-              </a:spcAft>
-              <a:defRPr sz="1100">
-                <a:solidFill>
-                  <a:srgbClr val="94A3B8"/>
-                </a:solidFill>
-                <a:latin typeface="Segoe UI"/>
-              </a:defRPr>
-            </a:pPr>
-            <a:r>
-              <a:t>• Afrosiyob chiptalari va mehmonxona bron.</a:t>
-            </a:r>
-          </a:p>
-        </p:txBody>
-      </p:sp>
-    </p:spTree>
-  </p:cSld>
-  <p:clrMapOvr>
-    <a:masterClrMapping/>
-  </p:clrMapOvr>
-</p:sld>
-</file>
-
-<file path=ppt/slides/slide8.xml><?xml version="1.0" encoding="utf-8"?>
-<p:sld xmlns:a="http://schemas.openxmlformats.org/drawingml/2006/main" xmlns:p="http://schemas.openxmlformats.org/presentationml/2006/main" xmlns:r="http://schemas.openxmlformats.org/officeDocument/2006/relationships">
-  <p:cSld>
-    <p:bg>
-      <p:bgPr>
-        <a:solidFill>
-          <a:srgbClr val="0A0F1D"/>
-        </a:solidFill>
-        <a:effectLst/>
-      </p:bgPr>
-    </p:bg>
-    <p:spTree>
-      <p:nvGrpSpPr>
-        <p:cNvPr id="1" name=""/>
-        <p:cNvGrpSpPr/>
-        <p:nvPr/>
-      </p:nvGrpSpPr>
-      <p:grpSpPr/>
-      <p:pic>
-        <p:nvPicPr>
-          <p:cNvPr id="2" name="Picture 1" descr="uzbek_mandala.jpg"/>
-          <p:cNvPicPr>
-            <a:picLocks noChangeAspect="1"/>
-          </p:cNvPicPr>
-          <p:nvPr/>
-        </p:nvPicPr>
-        <p:blipFill>
-          <a:blip r:embed="rId2"/>
-          <a:stretch>
-            <a:fillRect/>
-          </a:stretch>
-        </p:blipFill>
-        <p:spPr>
-          <a:xfrm>
-            <a:off x="10058400" y="-914400"/>
-            <a:ext cx="3200400" cy="3200400"/>
-          </a:xfrm>
-          <a:prstGeom prst="rect">
-            <a:avLst/>
-          </a:prstGeom>
-        </p:spPr>
-      </p:pic>
-      <p:sp>
-        <p:nvSpPr>
-          <p:cNvPr id="3" name="Rectangle 2"/>
-          <p:cNvSpPr/>
-          <p:nvPr/>
-        </p:nvSpPr>
-        <p:spPr>
-          <a:xfrm>
-            <a:off x="0" y="0"/>
-            <a:ext cx="12191695" cy="109728"/>
-          </a:xfrm>
-          <a:prstGeom prst="rect">
-            <a:avLst/>
-          </a:prstGeom>
-          <a:solidFill>
-            <a:srgbClr val="D4AF37"/>
-          </a:solidFill>
-          <a:ln>
-            <a:noFill/>
-          </a:ln>
-        </p:spPr>
-        <p:style>
-          <a:lnRef idx="1">
-            <a:schemeClr val="accent1"/>
-          </a:lnRef>
-          <a:fillRef idx="3">
-            <a:schemeClr val="accent1"/>
-          </a:fillRef>
-          <a:effectRef idx="2">
-            <a:schemeClr val="accent1"/>
-          </a:effectRef>
-          <a:fontRef idx="minor">
-            <a:schemeClr val="lt1"/>
-          </a:fontRef>
-        </p:style>
-        <p:txBody>
-          <a:bodyPr rtlCol="0" anchor="ctr"/>
-          <a:lstStyle/>
-          <a:p>
-            <a:pPr algn="ctr"/>
-          </a:p>
-        </p:txBody>
-      </p:sp>
-      <p:sp>
-        <p:nvSpPr>
-          <p:cNvPr id="4" name="TextBox 3"/>
-          <p:cNvSpPr txBox="1"/>
-          <p:nvPr/>
-        </p:nvSpPr>
-        <p:spPr>
-          <a:xfrm>
-            <a:off x="731520" y="6492240"/>
-            <a:ext cx="9601200" cy="274320"/>
-          </a:xfrm>
-          <a:prstGeom prst="rect">
-            <a:avLst/>
-          </a:prstGeom>
-          <a:noFill/>
-        </p:spPr>
-        <p:txBody>
-          <a:bodyPr wrap="none" lIns="0" rIns="0" tIns="0" bIns="0">
-            <a:spAutoFit/>
-          </a:bodyPr>
-          <a:lstStyle/>
-          <a:p>
-            <a:pPr>
-              <a:defRPr sz="900" b="1">
-                <a:solidFill>
-                  <a:srgbClr val="475569"/>
-                </a:solidFill>
-                <a:latin typeface="Segoe UI"/>
-              </a:defRPr>
-            </a:pPr>
-            <a:r>
-              <a:t>UZBEK-TRIP (SAMARQAND CRAFTOUR)  |  HAMKORLIK TAQDIMOTI 2026</a:t>
-            </a:r>
-          </a:p>
-        </p:txBody>
-      </p:sp>
-      <p:pic>
-        <p:nvPicPr>
-          <p:cNvPr id="5" name="Picture 4" descr="logo.jpg"/>
-          <p:cNvPicPr>
-            <a:picLocks noChangeAspect="1"/>
-          </p:cNvPicPr>
-          <p:nvPr/>
-        </p:nvPicPr>
-        <p:blipFill>
-          <a:blip r:embed="rId3"/>
-          <a:stretch>
-            <a:fillRect/>
-          </a:stretch>
-        </p:blipFill>
-        <p:spPr>
-          <a:xfrm>
-            <a:off x="11430000" y="6309360"/>
-            <a:ext cx="457200" cy="457200"/>
-          </a:xfrm>
-          <a:prstGeom prst="rect">
-            <a:avLst/>
-          </a:prstGeom>
-        </p:spPr>
-      </p:pic>
-      <p:sp>
-        <p:nvSpPr>
-          <p:cNvPr id="6" name="TextBox 5"/>
-          <p:cNvSpPr txBox="1"/>
-          <p:nvPr/>
-        </p:nvSpPr>
-        <p:spPr>
-          <a:xfrm>
-            <a:off x="731520" y="457200"/>
-            <a:ext cx="10728655" cy="731520"/>
-          </a:xfrm>
-          <a:prstGeom prst="rect">
-            <a:avLst/>
-          </a:prstGeom>
-          <a:noFill/>
-        </p:spPr>
-        <p:txBody>
-          <a:bodyPr wrap="square" lIns="0" rIns="0" tIns="0" bIns="0">
-            <a:spAutoFit/>
-          </a:bodyPr>
-          <a:lstStyle/>
-          <a:p>
-            <a:pPr>
-              <a:defRPr sz="3000" b="1">
-                <a:solidFill>
-                  <a:srgbClr val="D4AF37"/>
-                </a:solidFill>
-                <a:latin typeface="Georgia"/>
-              </a:defRPr>
-            </a:pPr>
-            <a:r>
-              <a:t>TEXNOLOGIK STACK VA AVTOMATIZATSIYA (N8N)</a:t>
-            </a:r>
-          </a:p>
-        </p:txBody>
-      </p:sp>
-      <p:sp>
-        <p:nvSpPr>
-          <p:cNvPr id="7" name="Rounded Rectangle 6"/>
-          <p:cNvSpPr/>
-          <p:nvPr/>
-        </p:nvSpPr>
-        <p:spPr>
-          <a:xfrm>
-            <a:off x="731520" y="1645920"/>
-            <a:ext cx="5120640" cy="4114800"/>
-          </a:xfrm>
-          <a:prstGeom prst="roundRect">
-            <a:avLst/>
-          </a:prstGeom>
-          <a:solidFill>
-            <a:srgbClr val="121A2F"/>
-          </a:solidFill>
-          <a:ln w="19050">
-            <a:solidFill>
-              <a:srgbClr val="D4AF37"/>
-            </a:solidFill>
-          </a:ln>
-        </p:spPr>
-        <p:style>
-          <a:lnRef idx="1">
-            <a:schemeClr val="accent1"/>
-          </a:lnRef>
-          <a:fillRef idx="3">
-            <a:schemeClr val="accent1"/>
-          </a:fillRef>
-          <a:effectRef idx="2">
-            <a:schemeClr val="accent1"/>
-          </a:effectRef>
-          <a:fontRef idx="minor">
-            <a:schemeClr val="lt1"/>
-          </a:fontRef>
-        </p:style>
-        <p:txBody>
-          <a:bodyPr rtlCol="0" anchor="ctr"/>
-          <a:lstStyle/>
-          <a:p>
-            <a:pPr algn="ctr"/>
-          </a:p>
-        </p:txBody>
-      </p:sp>
-      <p:sp>
-        <p:nvSpPr>
-          <p:cNvPr id="8" name="TextBox 7"/>
-          <p:cNvSpPr txBox="1"/>
-          <p:nvPr/>
-        </p:nvSpPr>
-        <p:spPr>
-          <a:xfrm>
-            <a:off x="1005840" y="1920240"/>
-            <a:ext cx="4572000" cy="3566160"/>
-          </a:xfrm>
-          <a:prstGeom prst="rect">
-            <a:avLst/>
-          </a:prstGeom>
-          <a:noFill/>
-        </p:spPr>
-        <p:txBody>
-          <a:bodyPr wrap="square">
-            <a:spAutoFit/>
-          </a:bodyPr>
-          <a:lstStyle/>
-          <a:p>
-            <a:pPr>
-              <a:spcAft>
-                <a:spcPts val="1500"/>
-              </a:spcAft>
-              <a:defRPr sz="2000" b="1">
-                <a:solidFill>
-                  <a:srgbClr val="D4AF37"/>
-                </a:solidFill>
-                <a:latin typeface="Georgia"/>
-              </a:defRPr>
-            </a:pPr>
-            <a:r>
-              <a:t>💻 Platforma Stacki</a:t>
-            </a:r>
-          </a:p>
-          <a:p>
-            <a:pPr>
-              <a:spcAft>
-                <a:spcPts val="1000"/>
-              </a:spcAft>
-              <a:defRPr sz="1200" b="1">
-                <a:solidFill>
-                  <a:srgbClr val="FFFFFF"/>
-                </a:solidFill>
-                <a:latin typeface="Segoe UI"/>
-              </a:defRPr>
-            </a:pPr>
-            <a:r>
-              <a:t>Next.js 16 (App Router): </a:t>
-            </a:r>
-            <a:r>
-              <a:rPr b="0">
-                <a:solidFill>
-                  <a:srgbClr val="94A3B8"/>
-                </a:solidFill>
-              </a:rPr>
-              <a:t>Tez yuklanish, SEO optimallik va yuqori xavfsizlik.</a:t>
-            </a:r>
-          </a:p>
-          <a:p>
-            <a:pPr>
-              <a:spcAft>
-                <a:spcPts val="1000"/>
-              </a:spcAft>
-              <a:defRPr sz="1200" b="1">
-                <a:solidFill>
-                  <a:srgbClr val="FFFFFF"/>
-                </a:solidFill>
-                <a:latin typeface="Segoe UI"/>
-              </a:defRPr>
-            </a:pPr>
-            <a:r>
-              <a:t>Supabase (PostgreSQL): </a:t>
-            </a:r>
-            <a:r>
-              <a:rPr b="0">
-                <a:solidFill>
-                  <a:srgbClr val="94A3B8"/>
-                </a:solidFill>
-              </a:rPr>
-              <a:t>Ma'lumotlar xavfsizligi va real vaqtdagi gid/transport bazasi.</a:t>
-            </a:r>
-          </a:p>
-          <a:p>
-            <a:pPr>
-              <a:spcAft>
-                <a:spcPts val="1000"/>
-              </a:spcAft>
-              <a:defRPr sz="1200" b="1">
-                <a:solidFill>
-                  <a:srgbClr val="FFFFFF"/>
-                </a:solidFill>
-                <a:latin typeface="Segoe UI"/>
-              </a:defRPr>
-            </a:pPr>
-            <a:r>
-              <a:t>Leaflet.js Maps: </a:t>
-            </a:r>
-            <a:r>
-              <a:rPr b="0">
-                <a:solidFill>
-                  <a:srgbClr val="94A3B8"/>
-                </a:solidFill>
-              </a:rPr>
-              <a:t>Bepul va ochiq kodli xarita tizimi (Google Maps uchun ortiqcha to'lov yo'q).</a:t>
-            </a:r>
-          </a:p>
-          <a:p>
-            <a:pPr>
-              <a:spcAft>
-                <a:spcPts val="1000"/>
-              </a:spcAft>
-              <a:defRPr sz="1200" b="1">
-                <a:solidFill>
-                  <a:srgbClr val="FFFFFF"/>
-                </a:solidFill>
-                <a:latin typeface="Segoe UI"/>
-              </a:defRPr>
-            </a:pPr>
-            <a:r>
-              <a:t>OTP Verification System: </a:t>
-            </a:r>
-            <a:r>
-              <a:rPr b="0">
-                <a:solidFill>
-                  <a:srgbClr val="94A3B8"/>
-                </a:solidFill>
-              </a:rPr>
-              <a:t>Aloqa xavfsizligi va buyurtmani vaucher ko'rinishida yuborish.</a:t>
-            </a:r>
-          </a:p>
-        </p:txBody>
-      </p:sp>
-      <p:sp>
-        <p:nvSpPr>
-          <p:cNvPr id="9" name="Rounded Rectangle 8"/>
-          <p:cNvSpPr/>
-          <p:nvPr/>
-        </p:nvSpPr>
-        <p:spPr>
-          <a:xfrm>
-            <a:off x="6217920" y="1645920"/>
-            <a:ext cx="5120640" cy="4114800"/>
-          </a:xfrm>
-          <a:prstGeom prst="roundRect">
-            <a:avLst/>
-          </a:prstGeom>
-          <a:solidFill>
-            <a:srgbClr val="121A2F"/>
-          </a:solidFill>
-          <a:ln w="19050">
-            <a:solidFill>
-              <a:srgbClr val="D4AF37"/>
-            </a:solidFill>
-          </a:ln>
-        </p:spPr>
-        <p:style>
-          <a:lnRef idx="1">
-            <a:schemeClr val="accent1"/>
-          </a:lnRef>
-          <a:fillRef idx="3">
-            <a:schemeClr val="accent1"/>
-          </a:fillRef>
-          <a:effectRef idx="2">
-            <a:schemeClr val="accent1"/>
-          </a:effectRef>
-          <a:fontRef idx="minor">
-            <a:schemeClr val="lt1"/>
-          </a:fontRef>
-        </p:style>
-        <p:txBody>
-          <a:bodyPr rtlCol="0" anchor="ctr"/>
-          <a:lstStyle/>
-          <a:p>
-            <a:pPr algn="ctr"/>
-          </a:p>
-        </p:txBody>
-      </p:sp>
-      <p:sp>
-        <p:nvSpPr>
-          <p:cNvPr id="10" name="TextBox 9"/>
-          <p:cNvSpPr txBox="1"/>
-          <p:nvPr/>
-        </p:nvSpPr>
-        <p:spPr>
-          <a:xfrm>
-            <a:off x="6492240" y="1920240"/>
-            <a:ext cx="4572000" cy="3566160"/>
-          </a:xfrm>
-          <a:prstGeom prst="rect">
-            <a:avLst/>
-          </a:prstGeom>
-          <a:noFill/>
-        </p:spPr>
-        <p:txBody>
-          <a:bodyPr wrap="square">
-            <a:spAutoFit/>
-          </a:bodyPr>
-          <a:lstStyle/>
-          <a:p>
-            <a:pPr>
-              <a:spcAft>
-                <a:spcPts val="1500"/>
-              </a:spcAft>
-              <a:defRPr sz="2000" b="1">
-                <a:solidFill>
-                  <a:srgbClr val="D4AF37"/>
-                </a:solidFill>
-                <a:latin typeface="Georgia"/>
-              </a:defRPr>
-            </a:pPr>
-            <a:r>
-              <a:t>⚡ n8n va WhatsApp Avtomatizatsiyasi</a:t>
-            </a:r>
-          </a:p>
-          <a:p>
-            <a:pPr>
-              <a:spcAft>
-                <a:spcPts val="1000"/>
-              </a:spcAft>
-              <a:defRPr sz="1200" b="1">
-                <a:solidFill>
-                  <a:srgbClr val="009B9E"/>
-                </a:solidFill>
-                <a:latin typeface="Segoe UI"/>
-              </a:defRPr>
-            </a:pPr>
-            <a:r>
-              <a:t>• n8n workflow integratsiyasi — </a:t>
-            </a:r>
-            <a:r>
-              <a:rPr b="0">
-                <a:solidFill>
-                  <a:srgbClr val="94A3B8"/>
-                </a:solidFill>
-              </a:rPr>
-              <a:t>Buyurtmalar boshqaruvi va monitoringi n8n platformasiga ulangan.</a:t>
-            </a:r>
-          </a:p>
-          <a:p>
-            <a:pPr>
-              <a:spcAft>
-                <a:spcPts val="1000"/>
-              </a:spcAft>
-              <a:defRPr sz="1200" b="1">
-                <a:solidFill>
-                  <a:srgbClr val="009B9E"/>
-                </a:solidFill>
-                <a:latin typeface="Segoe UI"/>
-              </a:defRPr>
-            </a:pPr>
-            <a:r>
-              <a:t>• Avtomatik xabar yetkazish — </a:t>
-            </a:r>
-            <a:r>
-              <a:rPr b="0">
-                <a:solidFill>
-                  <a:srgbClr val="94A3B8"/>
-                </a:solidFill>
-              </a:rPr>
-              <a:t>Sayyoh buyurtmani tasdiqlagach, haydovchi va gidning WhatsApp / Telegramiga darhol xabar ketadi.</a:t>
-            </a:r>
-          </a:p>
-          <a:p>
-            <a:pPr>
-              <a:spcAft>
-                <a:spcPts val="1000"/>
-              </a:spcAft>
-              <a:defRPr sz="1200" b="1">
-                <a:solidFill>
-                  <a:srgbClr val="009B9E"/>
-                </a:solidFill>
-                <a:latin typeface="Segoe UI"/>
-              </a:defRPr>
-            </a:pPr>
-            <a:r>
-              <a:t>• Marshrut va aloqa ma'lumotlari — </a:t>
-            </a:r>
-            <a:r>
-              <a:rPr b="0">
-                <a:solidFill>
-                  <a:srgbClr val="94A3B8"/>
-                </a:solidFill>
-              </a:rPr>
-              <a:t>Xabarda sayyohning to'liq marshruti, poyezd/samolyot kelish vaqti va telefon raqami avtomatik taqdim etiladi.</a:t>
-            </a:r>
-          </a:p>
-          <a:p>
-            <a:pPr>
-              <a:spcAft>
-                <a:spcPts val="1000"/>
-              </a:spcAft>
-              <a:defRPr sz="1200" b="1">
-                <a:solidFill>
-                  <a:srgbClr val="009B9E"/>
-                </a:solidFill>
-                <a:latin typeface="Segoe UI"/>
-              </a:defRPr>
-            </a:pPr>
-            <a:r>
-              <a:t>• Operatsion xarajatlarni 90% kamaytirish — </a:t>
-            </a:r>
-            <a:r>
-              <a:rPr b="0">
-                <a:solidFill>
-                  <a:srgbClr val="94A3B8"/>
-                </a:solidFill>
-              </a:rPr>
-              <a:t>Menejerlarning qo'lda aloqa qilish vaqtini tejaydi, inson omilini kamaytiradi.</a:t>
-            </a:r>
-          </a:p>
-        </p:txBody>
-      </p:sp>
-    </p:spTree>
-  </p:cSld>
-  <p:clrMapOvr>
-    <a:masterClrMapping/>
-  </p:clrMapOvr>
-</p:sld>
-</file>
-
-<file path=ppt/slides/slide9.xml><?xml version="1.0" encoding="utf-8"?>
-<p:sld xmlns:a="http://schemas.openxmlformats.org/drawingml/2006/main" xmlns:p="http://schemas.openxmlformats.org/presentationml/2006/main" xmlns:r="http://schemas.openxmlformats.org/officeDocument/2006/relationships">
-  <p:cSld>
-    <p:bg>
-      <p:bgPr>
-        <a:solidFill>
-          <a:srgbClr val="0A0F1D"/>
-        </a:solidFill>
-        <a:effectLst/>
-      </p:bgPr>
-    </p:bg>
-    <p:spTree>
-      <p:nvGrpSpPr>
-        <p:cNvPr id="1" name=""/>
-        <p:cNvGrpSpPr/>
-        <p:nvPr/>
-      </p:nvGrpSpPr>
-      <p:grpSpPr/>
-      <p:pic>
-        <p:nvPicPr>
-          <p:cNvPr id="2" name="Picture 1" descr="uzbek_mandala.jpg"/>
-          <p:cNvPicPr>
-            <a:picLocks noChangeAspect="1"/>
-          </p:cNvPicPr>
-          <p:nvPr/>
-        </p:nvPicPr>
-        <p:blipFill>
-          <a:blip r:embed="rId2"/>
-          <a:stretch>
-            <a:fillRect/>
-          </a:stretch>
-        </p:blipFill>
-        <p:spPr>
-          <a:xfrm>
-            <a:off x="10058400" y="-914400"/>
-            <a:ext cx="3200400" cy="3200400"/>
-          </a:xfrm>
-          <a:prstGeom prst="rect">
-            <a:avLst/>
-          </a:prstGeom>
-        </p:spPr>
-      </p:pic>
-      <p:sp>
-        <p:nvSpPr>
-          <p:cNvPr id="3" name="Rectangle 2"/>
-          <p:cNvSpPr/>
-          <p:nvPr/>
-        </p:nvSpPr>
-        <p:spPr>
-          <a:xfrm>
-            <a:off x="0" y="0"/>
-            <a:ext cx="12191695" cy="109728"/>
-          </a:xfrm>
-          <a:prstGeom prst="rect">
-            <a:avLst/>
-          </a:prstGeom>
-          <a:solidFill>
-            <a:srgbClr val="D4AF37"/>
-          </a:solidFill>
-          <a:ln>
-            <a:noFill/>
-          </a:ln>
-        </p:spPr>
-        <p:style>
-          <a:lnRef idx="1">
-            <a:schemeClr val="accent1"/>
-          </a:lnRef>
-          <a:fillRef idx="3">
-            <a:schemeClr val="accent1"/>
-          </a:fillRef>
-          <a:effectRef idx="2">
-            <a:schemeClr val="accent1"/>
-          </a:effectRef>
-          <a:fontRef idx="minor">
-            <a:schemeClr val="lt1"/>
-          </a:fontRef>
-        </p:style>
-        <p:txBody>
-          <a:bodyPr rtlCol="0" anchor="ctr"/>
-          <a:lstStyle/>
-          <a:p>
-            <a:pPr algn="ctr"/>
-          </a:p>
-        </p:txBody>
-      </p:sp>
-      <p:sp>
-        <p:nvSpPr>
-          <p:cNvPr id="4" name="TextBox 3"/>
-          <p:cNvSpPr txBox="1"/>
-          <p:nvPr/>
-        </p:nvSpPr>
-        <p:spPr>
-          <a:xfrm>
-            <a:off x="731520" y="6492240"/>
-            <a:ext cx="9601200" cy="274320"/>
-          </a:xfrm>
-          <a:prstGeom prst="rect">
-            <a:avLst/>
-          </a:prstGeom>
-          <a:noFill/>
-        </p:spPr>
-        <p:txBody>
-          <a:bodyPr wrap="none" lIns="0" rIns="0" tIns="0" bIns="0">
-            <a:spAutoFit/>
-          </a:bodyPr>
-          <a:lstStyle/>
-          <a:p>
-            <a:pPr>
-              <a:defRPr sz="900" b="1">
-                <a:solidFill>
-                  <a:srgbClr val="475569"/>
-                </a:solidFill>
-                <a:latin typeface="Segoe UI"/>
-              </a:defRPr>
-            </a:pPr>
-            <a:r>
-              <a:t>UZBEK-TRIP (SAMARQAND CRAFTOUR)  |  HAMKORLIK TAQDIMOTI 2026</a:t>
-            </a:r>
-          </a:p>
-        </p:txBody>
-      </p:sp>
-      <p:pic>
-        <p:nvPicPr>
-          <p:cNvPr id="5" name="Picture 4" descr="logo.jpg"/>
-          <p:cNvPicPr>
-            <a:picLocks noChangeAspect="1"/>
-          </p:cNvPicPr>
-          <p:nvPr/>
-        </p:nvPicPr>
-        <p:blipFill>
-          <a:blip r:embed="rId3"/>
-          <a:stretch>
-            <a:fillRect/>
-          </a:stretch>
-        </p:blipFill>
-        <p:spPr>
-          <a:xfrm>
-            <a:off x="11430000" y="6309360"/>
-            <a:ext cx="457200" cy="457200"/>
-          </a:xfrm>
-          <a:prstGeom prst="rect">
-            <a:avLst/>
-          </a:prstGeom>
-        </p:spPr>
-      </p:pic>
-      <p:sp>
-        <p:nvSpPr>
-          <p:cNvPr id="6" name="TextBox 5"/>
-          <p:cNvSpPr txBox="1"/>
-          <p:nvPr/>
-        </p:nvSpPr>
-        <p:spPr>
-          <a:xfrm>
-            <a:off x="731520" y="457200"/>
-            <a:ext cx="10728655" cy="731520"/>
-          </a:xfrm>
-          <a:prstGeom prst="rect">
-            <a:avLst/>
-          </a:prstGeom>
-          <a:noFill/>
-        </p:spPr>
-        <p:txBody>
-          <a:bodyPr wrap="square" lIns="0" rIns="0" tIns="0" bIns="0">
-            <a:spAutoFit/>
-          </a:bodyPr>
-          <a:lstStyle/>
-          <a:p>
-            <a:pPr>
-              <a:defRPr sz="3000" b="1">
-                <a:solidFill>
-                  <a:srgbClr val="D4AF37"/>
-                </a:solidFill>
-                <a:latin typeface="Georgia"/>
-              </a:defRPr>
-            </a:pPr>
-            <a:r>
-              <a:t>ERISHILGAN MUVAFFAQIYATLAR VA KOD TAYYORLIGI</a:t>
-            </a:r>
-          </a:p>
-        </p:txBody>
-      </p:sp>
-      <p:sp>
-        <p:nvSpPr>
-          <p:cNvPr id="7" name="TextBox 6"/>
-          <p:cNvSpPr txBox="1"/>
-          <p:nvPr/>
-        </p:nvSpPr>
-        <p:spPr>
-          <a:xfrm>
-            <a:off x="731520" y="1645920"/>
-            <a:ext cx="4572000" cy="4114800"/>
-          </a:xfrm>
-          <a:prstGeom prst="rect">
-            <a:avLst/>
-          </a:prstGeom>
-          <a:noFill/>
-        </p:spPr>
-        <p:txBody>
-          <a:bodyPr wrap="square">
-            <a:spAutoFit/>
-          </a:bodyPr>
-          <a:lstStyle/>
-          <a:p>
-            <a:pPr>
-              <a:spcAft>
-                <a:spcPts val="1000"/>
-              </a:spcAft>
-              <a:defRPr sz="1400" b="1">
-                <a:solidFill>
-                  <a:srgbClr val="009B9E"/>
-                </a:solidFill>
-                <a:latin typeface="Segoe UI"/>
-              </a:defRPr>
-            </a:pPr>
-            <a:r>
-              <a:t>LOYIHANING BUGUNGI HOLATI</a:t>
-            </a:r>
-          </a:p>
-          <a:p>
-            <a:pPr>
+            <a:pPr algn="ctr">
               <a:spcAft>
                 <a:spcPts val="1500"/>
               </a:spcAft>
@@ -8931,15 +6436,15 @@
               </a:defRPr>
             </a:pPr>
             <a:r>
-              <a:t>Tayyor va Ishlovchi MVP</a:t>
-            </a:r>
-          </a:p>
-          <a:p>
-            <a:pPr>
+              <a:t>KATTA RAHMAT! SAVOLLAR?</a:t>
+            </a:r>
+          </a:p>
+          <a:p>
+            <a:pPr algn="ctr">
               <a:spcAft>
-                <a:spcPts val="1000"/>
+                <a:spcPts val="2500"/>
               </a:spcAft>
-              <a:defRPr sz="1300">
+              <a:defRPr sz="1600">
                 <a:solidFill>
                   <a:srgbClr val="FFFFFF"/>
                 </a:solidFill>
@@ -8947,195 +6452,15 @@
               </a:defRPr>
             </a:pPr>
             <a:r>
-              <a:t>Platformaning veb-versiyasi ishlab chiqildi va barcha asosiy funksiyalar kod darajasida tayyorlandi:</a:t>
-            </a:r>
-          </a:p>
-          <a:p>
-            <a:pPr>
-              <a:spcAft>
-                <a:spcPts val="500"/>
-              </a:spcAft>
-              <a:defRPr sz="1200" b="1">
-                <a:solidFill>
-                  <a:srgbClr val="D4AF37"/>
-                </a:solidFill>
-                <a:latin typeface="Segoe UI"/>
-              </a:defRPr>
-            </a:pPr>
-            <a:r>
-              <a:t>✔ Vercel Live-demo — </a:t>
-            </a:r>
-            <a:r>
-              <a:rPr b="0">
-                <a:solidFill>
-                  <a:srgbClr val="94A3B8"/>
-                </a:solidFill>
-              </a:rPr>
-              <a:t>Loyiha muvaffaqiyatli bulutga yuklandi va testdan o'tdi.</a:t>
-            </a:r>
-          </a:p>
-          <a:p>
-            <a:pPr>
-              <a:spcAft>
-                <a:spcPts val="500"/>
-              </a:spcAft>
-              <a:defRPr sz="1200" b="1">
-                <a:solidFill>
-                  <a:srgbClr val="D4AF37"/>
-                </a:solidFill>
-                <a:latin typeface="Segoe UI"/>
-              </a:defRPr>
-            </a:pPr>
-            <a:r>
-              <a:t>✔ OSRM Routing — </a:t>
-            </a:r>
-            <a:r>
-              <a:rPr b="0">
-                <a:solidFill>
-                  <a:srgbClr val="94A3B8"/>
-                </a:solidFill>
-              </a:rPr>
-              <a:t>Haqiqiy avtomobil yo'llari bo'yicha navigatsiya chizig'i ishlaydi.</a:t>
-            </a:r>
-          </a:p>
-          <a:p>
-            <a:pPr>
-              <a:spcAft>
-                <a:spcPts val="500"/>
-              </a:spcAft>
-              <a:defRPr sz="1200" b="1">
-                <a:solidFill>
-                  <a:srgbClr val="D4AF37"/>
-                </a:solidFill>
-                <a:latin typeface="Segoe UI"/>
-              </a:defRPr>
-            </a:pPr>
-            <a:r>
-              <a:t>✔ Jonli GPS Navigatsiyasi — </a:t>
-            </a:r>
-            <a:r>
-              <a:rPr b="0">
-                <a:solidFill>
-                  <a:srgbClr val="94A3B8"/>
-                </a:solidFill>
-              </a:rPr>
-              <a:t>Foydalanuvchi joylashuvini live ko'rsatish funksiyasi tayyor.</a:t>
-            </a:r>
-          </a:p>
-          <a:p>
-            <a:pPr>
-              <a:spcAft>
-                <a:spcPts val="500"/>
-              </a:spcAft>
-              <a:defRPr sz="1200" b="1">
-                <a:solidFill>
-                  <a:srgbClr val="D4AF37"/>
-                </a:solidFill>
-                <a:latin typeface="Segoe UI"/>
-              </a:defRPr>
-            </a:pPr>
-            <a:r>
-              <a:t>✔ Simulyatsiya rejimi (Demo) — </a:t>
-            </a:r>
-            <a:r>
-              <a:rPr b="0">
-                <a:solidFill>
-                  <a:srgbClr val="94A3B8"/>
-                </a:solidFill>
-              </a:rPr>
-              <a:t>Virtual haydovchining harakatlanishini kuzatish imkoniyati.</a:t>
-            </a:r>
-          </a:p>
-        </p:txBody>
-      </p:sp>
-      <p:sp>
-        <p:nvSpPr>
-          <p:cNvPr id="8" name="Rounded Rectangle 7"/>
-          <p:cNvSpPr/>
-          <p:nvPr/>
-        </p:nvSpPr>
-        <p:spPr>
-          <a:xfrm>
-            <a:off x="5943600" y="1645920"/>
-            <a:ext cx="5486400" cy="4114800"/>
-          </a:xfrm>
-          <a:prstGeom prst="roundRect">
-            <a:avLst/>
-          </a:prstGeom>
-          <a:solidFill>
-            <a:srgbClr val="121A2F"/>
-          </a:solidFill>
-          <a:ln w="19050">
-            <a:solidFill>
-              <a:srgbClr val="D4AF37"/>
-            </a:solidFill>
-          </a:ln>
-        </p:spPr>
-        <p:style>
-          <a:lnRef idx="1">
-            <a:schemeClr val="accent1"/>
-          </a:lnRef>
-          <a:fillRef idx="3">
-            <a:schemeClr val="accent1"/>
-          </a:fillRef>
-          <a:effectRef idx="2">
-            <a:schemeClr val="accent1"/>
-          </a:effectRef>
-          <a:fontRef idx="minor">
-            <a:schemeClr val="lt1"/>
-          </a:fontRef>
-        </p:style>
-        <p:txBody>
-          <a:bodyPr rtlCol="0" anchor="ctr"/>
-          <a:lstStyle/>
-          <a:p>
-            <a:pPr algn="ctr"/>
-          </a:p>
-        </p:txBody>
-      </p:sp>
-      <p:sp>
-        <p:nvSpPr>
-          <p:cNvPr id="9" name="TextBox 8"/>
-          <p:cNvSpPr txBox="1"/>
-          <p:nvPr/>
-        </p:nvSpPr>
-        <p:spPr>
-          <a:xfrm>
-            <a:off x="6309360" y="1920240"/>
-            <a:ext cx="4754880" cy="3566160"/>
-          </a:xfrm>
-          <a:prstGeom prst="rect">
-            <a:avLst/>
-          </a:prstGeom>
-          <a:noFill/>
-        </p:spPr>
-        <p:txBody>
-          <a:bodyPr wrap="square">
-            <a:spAutoFit/>
-          </a:bodyPr>
-          <a:lstStyle/>
-          <a:p>
-            <a:pPr>
+              <a:t>O'zbekistonda shaxsiy turizm kelajagini birgalikda barpo etamiz.</a:t>
+            </a:r>
+          </a:p>
+          <a:p>
+            <a:pPr algn="ctr">
               <a:spcAft>
                 <a:spcPts val="1500"/>
               </a:spcAft>
-              <a:defRPr sz="2000" b="1">
-                <a:solidFill>
-                  <a:srgbClr val="D4AF37"/>
-                </a:solidFill>
-                <a:latin typeface="Georgia"/>
-              </a:defRPr>
-            </a:pPr>
-            <a:r>
-              <a:t>📈 Keyingi 3 Oylik Reja</a:t>
-            </a:r>
-          </a:p>
-          <a:p>
-            <a:pPr>
-              <a:spcAft>
-                <a:spcPts val="800"/>
-              </a:spcAft>
-              <a:defRPr sz="1200">
+              <a:defRPr sz="1400">
                 <a:solidFill>
                   <a:srgbClr val="94A3B8"/>
                 </a:solidFill>
@@ -9143,71 +6468,28 @@
               </a:defRPr>
             </a:pPr>
             <a:r>
-              <a:t>⚡ Mehmonxonalarga QR-kodlarni taqsimlashni boshlash.</a:t>
-            </a:r>
-          </a:p>
-          <a:p>
-            <a:pPr>
-              <a:spcAft>
-                <a:spcPts val="800"/>
-              </a:spcAft>
-              <a:defRPr sz="1200">
-                <a:solidFill>
-                  <a:srgbClr val="94A3B8"/>
+              <a:t>📞 Telefon: +998 (94) 019-64-20</a:t>
+            </a:r>
+            <a:br/>
+            <a:r>
+              <a:t>📧 Email: mikemukhriddin@gmail.com</a:t>
+            </a:r>
+            <a:br/>
+            <a:r>
+              <a:t>🌐 Veb-sayt: uzbek-trip.vercel.app</a:t>
+            </a:r>
+          </a:p>
+          <a:p>
+            <a:pPr algn="ctr">
+              <a:defRPr sz="1300" b="1" i="1">
+                <a:solidFill>
+                  <a:srgbClr val="009B9E"/>
                 </a:solidFill>
                 <a:latin typeface="Segoe UI"/>
               </a:defRPr>
             </a:pPr>
             <a:r>
-              <a:t>⚡ Samarqand shahridagi 50 ta yetakchi gid va 30 ta haydovchini tizimga ro'yxatga olish.</a:t>
-            </a:r>
-          </a:p>
-          <a:p>
-            <a:pPr>
-              <a:spcAft>
-                <a:spcPts val="800"/>
-              </a:spcAft>
-              <a:defRPr sz="1200">
-                <a:solidFill>
-                  <a:srgbClr val="94A3B8"/>
-                </a:solidFill>
-                <a:latin typeface="Segoe UI"/>
-              </a:defRPr>
-            </a:pPr>
-            <a:r>
-              <a:t>⚡ Restoranlar va eko-turizm nuqtalari bilan keshbek shartnomalarini tuzish.</a:t>
-            </a:r>
-          </a:p>
-          <a:p>
-            <a:pPr>
-              <a:spcAft>
-                <a:spcPts val="800"/>
-              </a:spcAft>
-              <a:defRPr sz="1200">
-                <a:solidFill>
-                  <a:srgbClr val="94A3B8"/>
-                </a:solidFill>
-                <a:latin typeface="Segoe UI"/>
-              </a:defRPr>
-            </a:pPr>
-            <a:r>
-              <a:t>⚡ Ilk 1,000 ta muvaffaqiyatli buyurtmani yakunlash.</a:t>
-            </a:r>
-          </a:p>
-          <a:p>
-            <a:pPr>
-              <a:spcBef>
-                <a:spcPts val="2000"/>
-              </a:spcBef>
-              <a:defRPr sz="1300" b="1">
-                <a:solidFill>
-                  <a:srgbClr val="009B9E"/>
-                </a:solidFill>
-                <a:latin typeface="Segoe UI"/>
-              </a:defRPr>
-            </a:pPr>
-            <a:r>
-              <a:t>Veb-sayt: uzbek-trip.vercel.app</a:t>
+              <a:t>5 daqiqada qisqa va lo'nda javob berishga tayyormiz!</a:t>
             </a:r>
           </a:p>
         </p:txBody>

</xml_diff>